<commit_message>
Presentación Tavares: agregar fotos, productos y servicios
Co-Authored-By: Claude Sonnet 5.5 <noreply@anthropic.com>
Claude-Session: https://claude.ai/code/session_01Ca6i6mxVBQE5Hs5u6ti3nX
</commit_message>
<xml_diff>
--- a/Vista_Previa_Presentacion_Tavares.pptx
+++ b/Vista_Previa_Presentacion_Tavares.pptx
@@ -2014,29 +2014,32 @@
           <a:chExt cx="0" cy="0"/>
         </a:xfrm>
       </p:grpSpPr>
-      <p:sp>
-        <p:nvSpPr>
-          <p:cNvPr id="2" name="Shape 0"/>
-          <p:cNvSpPr/>
-          <p:nvPr/>
-        </p:nvSpPr>
-        <p:spPr>
-          <a:xfrm>
-            <a:off x="5852160" y="0"/>
-            <a:ext cx="3291840" cy="5143500"/>
-          </a:xfrm>
-          <a:prstGeom prst="rect">
-            <a:avLst/>
-          </a:prstGeom>
-          <a:solidFill>
-            <a:srgbClr val="E5323B"/>
-          </a:solidFill>
-          <a:ln/>
-        </p:spPr>
-      </p:sp>
-      <p:sp>
-        <p:nvSpPr>
-          <p:cNvPr id="3" name="Shape 1"/>
+      <p:pic>
+        <p:nvPicPr>
+          <p:cNvPr id="2" name="Image 0" descr="use/katuete.jpg">    </p:cNvPr>
+          <p:cNvPicPr>
+            <a:picLocks noChangeAspect="1"/>
+          </p:cNvPicPr>
+          <p:nvPr/>
+        </p:nvPicPr>
+        <p:blipFill>
+          <a:blip r:embed="rId1"/>
+          <a:srcRect l="0" r="0" t="0" b="0"/>
+          <a:stretch/>
+        </p:blipFill>
+        <p:spPr>
+          <a:xfrm>
+            <a:off x="4754880" y="0"/>
+            <a:ext cx="4389120" cy="5143500"/>
+          </a:xfrm>
+          <a:prstGeom prst="rect">
+            <a:avLst/>
+          </a:prstGeom>
+        </p:spPr>
+      </p:pic>
+      <p:sp>
+        <p:nvSpPr>
+          <p:cNvPr id="3" name="Shape 0"/>
           <p:cNvSpPr/>
           <p:nvPr/>
         </p:nvSpPr>
@@ -2058,14 +2061,14 @@
       </p:sp>
       <p:pic>
         <p:nvPicPr>
-          <p:cNvPr id="4" name="Image 0" descr="logo_c.png">    </p:cNvPr>
+          <p:cNvPr id="4" name="Image 1" descr="logo_c.png">    </p:cNvPr>
           <p:cNvPicPr>
             <a:picLocks noChangeAspect="1"/>
           </p:cNvPicPr>
           <p:nvPr/>
         </p:nvPicPr>
         <p:blipFill>
-          <a:blip r:embed="rId1"/>
+          <a:blip r:embed="rId2"/>
           <a:stretch>
             <a:fillRect/>
           </a:stretch>
@@ -2082,14 +2085,14 @@
       </p:pic>
       <p:sp>
         <p:nvSpPr>
-          <p:cNvPr id="5" name="Text 2"/>
-          <p:cNvSpPr txBox="1"/>
-          <p:nvPr/>
-        </p:nvSpPr>
-        <p:spPr>
-          <a:xfrm>
-            <a:off x="457200" y="1920240"/>
-            <a:ext cx="5029200" cy="274320"/>
+          <p:cNvPr id="5" name="Text 1"/>
+          <p:cNvSpPr txBox="1"/>
+          <p:nvPr/>
+        </p:nvSpPr>
+        <p:spPr>
+          <a:xfrm>
+            <a:off x="457200" y="1828800"/>
+            <a:ext cx="4114800" cy="274320"/>
           </a:xfrm>
           <a:prstGeom prst="rect">
             <a:avLst/>
@@ -2121,14 +2124,14 @@
       </p:sp>
       <p:sp>
         <p:nvSpPr>
-          <p:cNvPr id="6" name="Text 3"/>
-          <p:cNvSpPr txBox="1"/>
-          <p:nvPr/>
-        </p:nvSpPr>
-        <p:spPr>
-          <a:xfrm>
-            <a:off x="457200" y="2240280"/>
-            <a:ext cx="5120640" cy="1463040"/>
+          <p:cNvPr id="6" name="Text 2"/>
+          <p:cNvSpPr txBox="1"/>
+          <p:nvPr/>
+        </p:nvSpPr>
+        <p:spPr>
+          <a:xfrm>
+            <a:off x="457200" y="2148840"/>
+            <a:ext cx="4114800" cy="1737360"/>
           </a:xfrm>
           <a:prstGeom prst="rect">
             <a:avLst/>
@@ -2144,7 +2147,7 @@
               <a:buNone/>
             </a:pPr>
             <a:r>
-              <a:rPr lang="en-US" sz="3400" b="1" dirty="0">
+              <a:rPr lang="en-US" sz="3000" b="1" dirty="0">
                 <a:solidFill>
                   <a:srgbClr val="FFFFFF"/>
                 </a:solidFill>
@@ -2154,36 +2157,36 @@
               </a:rPr>
               <a:t>Repuestos que mantienen al país en movimiento</a:t>
             </a:r>
-            <a:endParaRPr lang="en-US" sz="3400" dirty="0"/>
-          </a:p>
-        </p:txBody>
-      </p:sp>
-      <p:sp>
-        <p:nvSpPr>
-          <p:cNvPr id="7" name="Text 4"/>
-          <p:cNvSpPr txBox="1"/>
-          <p:nvPr/>
-        </p:nvSpPr>
-        <p:spPr>
-          <a:xfrm>
-            <a:off x="457200" y="4069080"/>
-            <a:ext cx="5120640" cy="274320"/>
-          </a:xfrm>
-          <a:prstGeom prst="rect">
-            <a:avLst/>
-          </a:prstGeom>
-          <a:noFill/>
-          <a:ln/>
-        </p:spPr>
-        <p:txBody>
-          <a:bodyPr wrap="square" lIns="0" tIns="0" rIns="0" bIns="0" rtlCol="0" anchor="ctr"/>
-          <a:lstStyle/>
-          <a:p>
-            <a:pPr indent="0" marL="0">
-              <a:buNone/>
-            </a:pPr>
-            <a:r>
-              <a:rPr lang="en-US" sz="1300" b="1" dirty="0">
+            <a:endParaRPr lang="en-US" sz="3000" dirty="0"/>
+          </a:p>
+        </p:txBody>
+      </p:sp>
+      <p:sp>
+        <p:nvSpPr>
+          <p:cNvPr id="7" name="Text 3"/>
+          <p:cNvSpPr txBox="1"/>
+          <p:nvPr/>
+        </p:nvSpPr>
+        <p:spPr>
+          <a:xfrm>
+            <a:off x="457200" y="4114800"/>
+            <a:ext cx="4114800" cy="274320"/>
+          </a:xfrm>
+          <a:prstGeom prst="rect">
+            <a:avLst/>
+          </a:prstGeom>
+          <a:noFill/>
+          <a:ln/>
+        </p:spPr>
+        <p:txBody>
+          <a:bodyPr wrap="square" lIns="0" tIns="0" rIns="0" bIns="0" rtlCol="0" anchor="ctr"/>
+          <a:lstStyle/>
+          <a:p>
+            <a:pPr indent="0" marL="0">
+              <a:buNone/>
+            </a:pPr>
+            <a:r>
+              <a:rPr lang="en-US" sz="1200" b="1" dirty="0">
                 <a:solidFill>
                   <a:srgbClr val="FFFFFF"/>
                 </a:solidFill>
@@ -2193,20 +2196,20 @@
               </a:rPr>
               <a:t>Repuestos Tavares Sociedad Anónima Emisora</a:t>
             </a:r>
-            <a:endParaRPr lang="en-US" sz="1300" dirty="0"/>
-          </a:p>
-        </p:txBody>
-      </p:sp>
-      <p:sp>
-        <p:nvSpPr>
-          <p:cNvPr id="8" name="Text 5"/>
-          <p:cNvSpPr txBox="1"/>
-          <p:nvPr/>
-        </p:nvSpPr>
-        <p:spPr>
-          <a:xfrm>
-            <a:off x="457200" y="4343400"/>
-            <a:ext cx="5120640" cy="274320"/>
+            <a:endParaRPr lang="en-US" sz="1200" dirty="0"/>
+          </a:p>
+        </p:txBody>
+      </p:sp>
+      <p:sp>
+        <p:nvSpPr>
+          <p:cNvPr id="8" name="Text 4"/>
+          <p:cNvSpPr txBox="1"/>
+          <p:nvPr/>
+        </p:nvSpPr>
+        <p:spPr>
+          <a:xfrm>
+            <a:off x="457200" y="4389120"/>
+            <a:ext cx="4114800" cy="274320"/>
           </a:xfrm>
           <a:prstGeom prst="rect">
             <a:avLst/>
@@ -2238,30 +2241,59 @@
       </p:sp>
       <p:sp>
         <p:nvSpPr>
-          <p:cNvPr id="9" name="Text 6"/>
-          <p:cNvSpPr txBox="1"/>
-          <p:nvPr/>
-        </p:nvSpPr>
-        <p:spPr>
-          <a:xfrm>
-            <a:off x="6172200" y="1737360"/>
-            <a:ext cx="2651760" cy="274320"/>
-          </a:xfrm>
-          <a:prstGeom prst="rect">
-            <a:avLst/>
-          </a:prstGeom>
-          <a:noFill/>
-          <a:ln/>
-        </p:spPr>
-        <p:txBody>
-          <a:bodyPr wrap="square" lIns="0" tIns="0" rIns="0" bIns="0" rtlCol="0" anchor="ctr"/>
-          <a:lstStyle/>
-          <a:p>
-            <a:pPr indent="0" marL="0">
-              <a:buNone/>
-            </a:pPr>
-            <a:r>
-              <a:rPr lang="en-US" sz="1100" b="1" spc="200" kern="0" dirty="0">
+          <p:cNvPr id="9" name="Shape 5"/>
+          <p:cNvSpPr/>
+          <p:nvPr/>
+        </p:nvSpPr>
+        <p:spPr>
+          <a:xfrm>
+            <a:off x="5120640" y="3429000"/>
+            <a:ext cx="3566160" cy="1234440"/>
+          </a:xfrm>
+          <a:prstGeom prst="roundRect">
+            <a:avLst>
+              <a:gd name="adj" fmla="val 7407"/>
+            </a:avLst>
+          </a:prstGeom>
+          <a:solidFill>
+            <a:srgbClr val="E5323B"/>
+          </a:solidFill>
+          <a:ln/>
+          <a:effectLst>
+            <a:outerShdw sx="100000" sy="100000" kx="0" ky="0" algn="bl" rotWithShape="0" blurRad="101600" dist="25400" dir="5400000">
+              <a:srgbClr val="000000">
+                <a:alpha val="12000"/>
+              </a:srgbClr>
+            </a:outerShdw>
+          </a:effectLst>
+        </p:spPr>
+      </p:sp>
+      <p:sp>
+        <p:nvSpPr>
+          <p:cNvPr id="10" name="Text 6"/>
+          <p:cNvSpPr txBox="1"/>
+          <p:nvPr/>
+        </p:nvSpPr>
+        <p:spPr>
+          <a:xfrm>
+            <a:off x="5349240" y="3520440"/>
+            <a:ext cx="3200400" cy="274320"/>
+          </a:xfrm>
+          <a:prstGeom prst="rect">
+            <a:avLst/>
+          </a:prstGeom>
+          <a:noFill/>
+          <a:ln/>
+        </p:spPr>
+        <p:txBody>
+          <a:bodyPr wrap="square" lIns="0" tIns="0" rIns="0" bIns="0" rtlCol="0" anchor="ctr"/>
+          <a:lstStyle/>
+          <a:p>
+            <a:pPr indent="0" marL="0">
+              <a:buNone/>
+            </a:pPr>
+            <a:r>
+              <a:rPr lang="en-US" sz="1000" b="1" spc="200" kern="0" dirty="0">
                 <a:solidFill>
                   <a:srgbClr val="FFFFFF"/>
                 </a:solidFill>
@@ -2271,36 +2303,36 @@
               </a:rPr>
               <a:t>PROGRAMA DE EMISIÓN GLOBAL</a:t>
             </a:r>
-            <a:endParaRPr lang="en-US" sz="1100" dirty="0"/>
-          </a:p>
-        </p:txBody>
-      </p:sp>
-      <p:sp>
-        <p:nvSpPr>
-          <p:cNvPr id="10" name="Text 7"/>
-          <p:cNvSpPr txBox="1"/>
-          <p:nvPr/>
-        </p:nvSpPr>
-        <p:spPr>
-          <a:xfrm>
-            <a:off x="6172200" y="2011680"/>
-            <a:ext cx="2651760" cy="1097280"/>
-          </a:xfrm>
-          <a:prstGeom prst="rect">
-            <a:avLst/>
-          </a:prstGeom>
-          <a:noFill/>
-          <a:ln/>
-        </p:spPr>
-        <p:txBody>
-          <a:bodyPr wrap="square" lIns="0" tIns="0" rIns="0" bIns="0" rtlCol="0" anchor="ctr"/>
-          <a:lstStyle/>
-          <a:p>
-            <a:pPr indent="0" marL="0">
-              <a:buNone/>
-            </a:pPr>
-            <a:r>
-              <a:rPr lang="en-US" sz="8000" b="1" dirty="0">
+            <a:endParaRPr lang="en-US" sz="1000" dirty="0"/>
+          </a:p>
+        </p:txBody>
+      </p:sp>
+      <p:sp>
+        <p:nvSpPr>
+          <p:cNvPr id="11" name="Text 7"/>
+          <p:cNvSpPr txBox="1"/>
+          <p:nvPr/>
+        </p:nvSpPr>
+        <p:spPr>
+          <a:xfrm>
+            <a:off x="5349240" y="3794760"/>
+            <a:ext cx="3200400" cy="731520"/>
+          </a:xfrm>
+          <a:prstGeom prst="rect">
+            <a:avLst/>
+          </a:prstGeom>
+          <a:noFill/>
+          <a:ln/>
+        </p:spPr>
+        <p:txBody>
+          <a:bodyPr wrap="square" lIns="0" tIns="0" rIns="0" bIns="0" rtlCol="0" anchor="ctr"/>
+          <a:lstStyle/>
+          <a:p>
+            <a:pPr indent="0" marL="0">
+              <a:buNone/>
+            </a:pPr>
+            <a:r>
+              <a:rPr lang="en-US" sz="3400" b="1" dirty="0">
                 <a:solidFill>
                   <a:srgbClr val="FFFFFF"/>
                 </a:solidFill>
@@ -2310,36 +2342,11 @@
               </a:rPr>
               <a:t>G1</a:t>
             </a:r>
-            <a:endParaRPr lang="en-US" sz="8000" dirty="0"/>
-          </a:p>
-        </p:txBody>
-      </p:sp>
-      <p:sp>
-        <p:nvSpPr>
-          <p:cNvPr id="11" name="Text 8"/>
-          <p:cNvSpPr txBox="1"/>
-          <p:nvPr/>
-        </p:nvSpPr>
-        <p:spPr>
-          <a:xfrm>
-            <a:off x="6172200" y="3200400"/>
-            <a:ext cx="2651760" cy="548640"/>
-          </a:xfrm>
-          <a:prstGeom prst="rect">
-            <a:avLst/>
-          </a:prstGeom>
-          <a:noFill/>
-          <a:ln/>
-        </p:spPr>
-        <p:txBody>
-          <a:bodyPr wrap="square" lIns="0" tIns="0" rIns="0" bIns="0" rtlCol="0" anchor="ctr"/>
-          <a:lstStyle/>
-          <a:p>
-            <a:pPr indent="0" marL="0">
-              <a:buNone/>
-            </a:pPr>
-            <a:r>
-              <a:rPr lang="en-US" sz="1600" dirty="0">
+            <a:pPr indent="0" marL="0">
+              <a:buNone/>
+            </a:pPr>
+            <a:r>
+              <a:rPr lang="en-US" sz="1300" dirty="0">
                 <a:solidFill>
                   <a:srgbClr val="FFFFFF"/>
                 </a:solidFill>
@@ -2347,9 +2354,9 @@
                 <a:ea typeface="Calibri" pitchFamily="34" charset="-122"/>
                 <a:cs typeface="Calibri" pitchFamily="34" charset="-120"/>
               </a:rPr>
-              <a:t>Bonos por Gs. 15.000 millones</a:t>
-            </a:r>
-            <a:endParaRPr lang="en-US" sz="1600" dirty="0"/>
+              <a:t>   Bonos · Gs. 15.000 millones</a:t>
+            </a:r>
+            <a:endParaRPr lang="en-US" sz="3400" dirty="0"/>
           </a:p>
         </p:txBody>
       </p:sp>
@@ -2385,32 +2392,118 @@
           <a:chExt cx="0" cy="0"/>
         </a:xfrm>
       </p:grpSpPr>
-      <p:sp>
-        <p:nvSpPr>
-          <p:cNvPr id="2" name="Text 0"/>
-          <p:cNvSpPr txBox="1"/>
-          <p:nvPr/>
-        </p:nvSpPr>
-        <p:spPr>
-          <a:xfrm>
-            <a:off x="457200" y="320040"/>
-            <a:ext cx="8229600" cy="640080"/>
-          </a:xfrm>
-          <a:prstGeom prst="rect">
-            <a:avLst/>
-          </a:prstGeom>
-          <a:noFill/>
-          <a:ln/>
-        </p:spPr>
-        <p:txBody>
-          <a:bodyPr wrap="square" lIns="0" tIns="0" rIns="0" bIns="0" rtlCol="0" anchor="ctr"/>
-          <a:lstStyle/>
-          <a:p>
-            <a:pPr indent="0" marL="0">
-              <a:buNone/>
-            </a:pPr>
-            <a:r>
-              <a:rPr lang="en-US" sz="3000" b="1" dirty="0">
+      <p:pic>
+        <p:nvPicPr>
+          <p:cNvPr id="2" name="Image 0" descr="use/campo9.jpg">    </p:cNvPr>
+          <p:cNvPicPr>
+            <a:picLocks noChangeAspect="1"/>
+          </p:cNvPicPr>
+          <p:nvPr/>
+        </p:nvPicPr>
+        <p:blipFill>
+          <a:blip r:embed="rId1"/>
+          <a:srcRect l="0" r="0" t="0" b="0"/>
+          <a:stretch/>
+        </p:blipFill>
+        <p:spPr>
+          <a:xfrm>
+            <a:off x="0" y="0"/>
+            <a:ext cx="3749040" cy="5143500"/>
+          </a:xfrm>
+          <a:prstGeom prst="rect">
+            <a:avLst/>
+          </a:prstGeom>
+        </p:spPr>
+      </p:pic>
+      <p:sp>
+        <p:nvSpPr>
+          <p:cNvPr id="3" name="Shape 0"/>
+          <p:cNvSpPr/>
+          <p:nvPr/>
+        </p:nvSpPr>
+        <p:spPr>
+          <a:xfrm>
+            <a:off x="274320" y="4343400"/>
+            <a:ext cx="2377440" cy="274320"/>
+          </a:xfrm>
+          <a:prstGeom prst="roundRect">
+            <a:avLst>
+              <a:gd name="adj" fmla="val 16667"/>
+            </a:avLst>
+          </a:prstGeom>
+          <a:solidFill>
+            <a:srgbClr val="1E2023">
+              <a:alpha val="85000"/>
+            </a:srgbClr>
+          </a:solidFill>
+          <a:ln/>
+        </p:spPr>
+      </p:sp>
+      <p:sp>
+        <p:nvSpPr>
+          <p:cNvPr id="4" name="Text 1"/>
+          <p:cNvSpPr txBox="1"/>
+          <p:nvPr/>
+        </p:nvSpPr>
+        <p:spPr>
+          <a:xfrm>
+            <a:off x="274320" y="4343400"/>
+            <a:ext cx="2377440" cy="274320"/>
+          </a:xfrm>
+          <a:prstGeom prst="rect">
+            <a:avLst/>
+          </a:prstGeom>
+          <a:noFill/>
+          <a:ln/>
+        </p:spPr>
+        <p:txBody>
+          <a:bodyPr wrap="square" lIns="0" tIns="0" rIns="0" bIns="0" rtlCol="0" anchor="ctr"/>
+          <a:lstStyle/>
+          <a:p>
+            <a:pPr algn="ctr" indent="0" marL="0">
+              <a:buNone/>
+            </a:pPr>
+            <a:r>
+              <a:rPr lang="en-US" sz="1000" b="1" dirty="0">
+                <a:solidFill>
+                  <a:srgbClr val="FFFFFF"/>
+                </a:solidFill>
+                <a:latin typeface="Calibri" pitchFamily="34" charset="0"/>
+                <a:ea typeface="Calibri" pitchFamily="34" charset="-122"/>
+                <a:cs typeface="Calibri" pitchFamily="34" charset="-120"/>
+              </a:rPr>
+              <a:t>Unidad Campo 9 · Ruta PY 02</a:t>
+            </a:r>
+            <a:endParaRPr lang="en-US" sz="1000" dirty="0"/>
+          </a:p>
+        </p:txBody>
+      </p:sp>
+      <p:sp>
+        <p:nvSpPr>
+          <p:cNvPr id="5" name="Text 2"/>
+          <p:cNvSpPr txBox="1"/>
+          <p:nvPr/>
+        </p:nvSpPr>
+        <p:spPr>
+          <a:xfrm>
+            <a:off x="4206240" y="365760"/>
+            <a:ext cx="4480560" cy="548640"/>
+          </a:xfrm>
+          <a:prstGeom prst="rect">
+            <a:avLst/>
+          </a:prstGeom>
+          <a:noFill/>
+          <a:ln/>
+        </p:spPr>
+        <p:txBody>
+          <a:bodyPr wrap="square" lIns="0" tIns="0" rIns="0" bIns="0" rtlCol="0" anchor="ctr"/>
+          <a:lstStyle/>
+          <a:p>
+            <a:pPr indent="0" marL="0">
+              <a:buNone/>
+            </a:pPr>
+            <a:r>
+              <a:rPr lang="en-US" sz="2800" b="1" dirty="0">
                 <a:solidFill>
                   <a:srgbClr val="1E2023"/>
                 </a:solidFill>
@@ -2420,20 +2513,20 @@
               </a:rPr>
               <a:t>Quiénes somos</a:t>
             </a:r>
-            <a:endParaRPr lang="en-US" sz="3000" dirty="0"/>
-          </a:p>
-        </p:txBody>
-      </p:sp>
-      <p:sp>
-        <p:nvSpPr>
-          <p:cNvPr id="3" name="Text 1"/>
-          <p:cNvSpPr txBox="1"/>
-          <p:nvPr/>
-        </p:nvSpPr>
-        <p:spPr>
-          <a:xfrm>
-            <a:off x="457200" y="1234440"/>
-            <a:ext cx="4023360" cy="2377440"/>
+            <a:endParaRPr lang="en-US" sz="2800" dirty="0"/>
+          </a:p>
+        </p:txBody>
+      </p:sp>
+      <p:sp>
+        <p:nvSpPr>
+          <p:cNvPr id="6" name="Text 3"/>
+          <p:cNvSpPr txBox="1"/>
+          <p:nvPr/>
+        </p:nvSpPr>
+        <p:spPr>
+          <a:xfrm>
+            <a:off x="4206240" y="1005840"/>
+            <a:ext cx="4480560" cy="1371600"/>
           </a:xfrm>
           <a:prstGeom prst="rect">
             <a:avLst/>
@@ -2449,7 +2542,7 @@
               <a:buNone/>
             </a:pPr>
             <a:r>
-              <a:rPr lang="en-US" sz="1400" b="1" dirty="0">
+              <a:rPr lang="en-US" sz="1250" dirty="0">
                 <a:solidFill>
                   <a:srgbClr val="1E2023"/>
                 </a:solidFill>
@@ -2457,114 +2550,47 @@
                 <a:ea typeface="Calibri" pitchFamily="34" charset="-122"/>
                 <a:cs typeface="Calibri" pitchFamily="34" charset="-120"/>
               </a:rPr>
-              <a:t>Repuestos Tavares S.A.E. </a:t>
-            </a:r>
-            <a:pPr indent="0" marL="0">
-              <a:buNone/>
-            </a:pPr>
-            <a:r>
-              <a:rPr lang="en-US" sz="1400" dirty="0">
-                <a:solidFill>
-                  <a:srgbClr val="1E2023"/>
-                </a:solidFill>
-                <a:latin typeface="Calibri" pitchFamily="34" charset="0"/>
-                <a:ea typeface="Calibri" pitchFamily="34" charset="-122"/>
-                <a:cs typeface="Calibri" pitchFamily="34" charset="-120"/>
-              </a:rPr>
-              <a:t>es una empresa paraguaya dedicada a la comercialización de repuestos, partes y accesorios para camiones, tractocamiones, remolques y maquinaria agrícola.</a:t>
-            </a:r>
-            <a:endParaRPr lang="en-US" sz="1400" dirty="0"/>
-          </a:p>
-          <a:p>
-            <a:pPr indent="0" marL="0">
-              <a:buNone/>
-            </a:pPr>
-            <a:r>
-              <a:rPr lang="en-US" sz="600" dirty="0">
-                <a:solidFill>
-                  <a:srgbClr val="1E2023"/>
-                </a:solidFill>
-                <a:latin typeface="Calibri" pitchFamily="34" charset="0"/>
-                <a:ea typeface="Calibri" pitchFamily="34" charset="-122"/>
-                <a:cs typeface="Calibri" pitchFamily="34" charset="-120"/>
-              </a:rPr>
-              <a:t> </a:t>
-            </a:r>
-            <a:endParaRPr lang="en-US" sz="1400" dirty="0"/>
-          </a:p>
-          <a:p>
-            <a:pPr indent="0" marL="0">
-              <a:buNone/>
-            </a:pPr>
-            <a:r>
-              <a:rPr lang="en-US" sz="1400" dirty="0">
-                <a:solidFill>
-                  <a:srgbClr val="1E2023"/>
-                </a:solidFill>
-                <a:latin typeface="Calibri" pitchFamily="34" charset="0"/>
-                <a:ea typeface="Calibri" pitchFamily="34" charset="-122"/>
-                <a:cs typeface="Calibri" pitchFamily="34" charset="-120"/>
-              </a:rPr>
-              <a:t>Integra la venta de repuestos nuevos y reconstruidos con un taller propio de mecánica pesada, tornería, chapería y pintura, bajo la marca Tavares Group.</a:t>
-            </a:r>
-            <a:endParaRPr lang="en-US" sz="1400" dirty="0"/>
-          </a:p>
-        </p:txBody>
-      </p:sp>
-      <p:sp>
-        <p:nvSpPr>
-          <p:cNvPr id="4" name="Text 2"/>
-          <p:cNvSpPr txBox="1"/>
-          <p:nvPr/>
-        </p:nvSpPr>
-        <p:spPr>
-          <a:xfrm>
-            <a:off x="457200" y="3749040"/>
-            <a:ext cx="4023360" cy="731520"/>
-          </a:xfrm>
-          <a:prstGeom prst="rect">
-            <a:avLst/>
-          </a:prstGeom>
-          <a:noFill/>
-          <a:ln/>
-        </p:spPr>
-        <p:txBody>
-          <a:bodyPr wrap="square" lIns="0" tIns="0" rIns="0" bIns="0" rtlCol="0" anchor="t"/>
-          <a:lstStyle/>
-          <a:p>
-            <a:pPr indent="0" marL="0">
-              <a:buNone/>
-            </a:pPr>
-            <a:r>
-              <a:rPr lang="en-US" sz="1200" i="1" dirty="0">
-                <a:solidFill>
-                  <a:srgbClr val="8A8D91"/>
-                </a:solidFill>
-                <a:latin typeface="Calibri" pitchFamily="34" charset="0"/>
-                <a:ea typeface="Calibri" pitchFamily="34" charset="-122"/>
-                <a:cs typeface="Calibri" pitchFamily="34" charset="-120"/>
-              </a:rPr>
-              <a:t>Atendemos a empresas de transporte de carga, productores agrícolas, talleres y compañías de seguros.</a:t>
-            </a:r>
-            <a:endParaRPr lang="en-US" sz="1200" dirty="0"/>
-          </a:p>
-        </p:txBody>
-      </p:sp>
-      <p:sp>
-        <p:nvSpPr>
-          <p:cNvPr id="5" name="Shape 3"/>
+              <a:t>Empresa paraguaya especializada en repuestos, partes y accesorios para camiones, tractocamiones, remolques y maquinaria agrícola, con taller propio de mecánica pesada, tornería, chapería y pintura. Opera bajo la marca Tavares Group.</a:t>
+            </a:r>
+            <a:endParaRPr lang="en-US" sz="1250" dirty="0"/>
+          </a:p>
+        </p:txBody>
+      </p:sp>
+      <p:sp>
+        <p:nvSpPr>
+          <p:cNvPr id="7" name="Shape 4"/>
           <p:cNvSpPr/>
           <p:nvPr/>
         </p:nvSpPr>
         <p:spPr>
           <a:xfrm>
-            <a:off x="5029200" y="457200"/>
-            <a:ext cx="3657600" cy="1234440"/>
+            <a:off x="4206240" y="2514600"/>
+            <a:ext cx="4480560" cy="960120"/>
           </a:xfrm>
           <a:prstGeom prst="roundRect">
             <a:avLst>
-              <a:gd name="adj" fmla="val 7407"/>
+              <a:gd name="adj" fmla="val 7619"/>
             </a:avLst>
+          </a:prstGeom>
+          <a:solidFill>
+            <a:srgbClr val="F3F4F5"/>
+          </a:solidFill>
+          <a:ln/>
+        </p:spPr>
+      </p:sp>
+      <p:sp>
+        <p:nvSpPr>
+          <p:cNvPr id="8" name="Shape 5"/>
+          <p:cNvSpPr/>
+          <p:nvPr/>
+        </p:nvSpPr>
+        <p:spPr>
+          <a:xfrm>
+            <a:off x="4389120" y="2788920"/>
+            <a:ext cx="411480" cy="411480"/>
+          </a:xfrm>
+          <a:prstGeom prst="ellipse">
+            <a:avLst/>
           </a:prstGeom>
           <a:solidFill>
             <a:srgbClr val="E5323B"/>
@@ -2574,176 +2600,150 @@
       </p:sp>
       <p:sp>
         <p:nvSpPr>
-          <p:cNvPr id="6" name="Text 4"/>
-          <p:cNvSpPr txBox="1"/>
-          <p:nvPr/>
-        </p:nvSpPr>
-        <p:spPr>
-          <a:xfrm>
-            <a:off x="5257800" y="548640"/>
-            <a:ext cx="1737360" cy="1051560"/>
-          </a:xfrm>
-          <a:prstGeom prst="rect">
-            <a:avLst/>
-          </a:prstGeom>
-          <a:noFill/>
-          <a:ln/>
-        </p:spPr>
-        <p:txBody>
-          <a:bodyPr wrap="square" lIns="0" tIns="0" rIns="0" bIns="0" rtlCol="0" anchor="ctr"/>
-          <a:lstStyle/>
-          <a:p>
-            <a:pPr indent="0" marL="0">
-              <a:buNone/>
-            </a:pPr>
-            <a:r>
-              <a:rPr lang="en-US" sz="3800" b="1" dirty="0">
-                <a:solidFill>
-                  <a:srgbClr val="FFFFFF"/>
-                </a:solidFill>
-                <a:latin typeface="Cambria" pitchFamily="34" charset="0"/>
-                <a:ea typeface="Cambria" pitchFamily="34" charset="-122"/>
-                <a:cs typeface="Cambria" pitchFamily="34" charset="-120"/>
-              </a:rPr>
-              <a:t>1996</a:t>
-            </a:r>
-            <a:endParaRPr lang="en-US" sz="3800" dirty="0"/>
-          </a:p>
-        </p:txBody>
-      </p:sp>
-      <p:sp>
-        <p:nvSpPr>
-          <p:cNvPr id="7" name="Text 5"/>
-          <p:cNvSpPr txBox="1"/>
-          <p:nvPr/>
-        </p:nvSpPr>
-        <p:spPr>
-          <a:xfrm>
-            <a:off x="6949440" y="548640"/>
-            <a:ext cx="1554480" cy="1051560"/>
-          </a:xfrm>
-          <a:prstGeom prst="rect">
-            <a:avLst/>
-          </a:prstGeom>
-          <a:noFill/>
-          <a:ln/>
-        </p:spPr>
-        <p:txBody>
-          <a:bodyPr wrap="square" lIns="0" tIns="0" rIns="0" bIns="0" rtlCol="0" anchor="ctr"/>
-          <a:lstStyle/>
-          <a:p>
-            <a:pPr indent="0" marL="0">
-              <a:buNone/>
-            </a:pPr>
-            <a:r>
-              <a:rPr lang="en-US" sz="1200" dirty="0">
-                <a:solidFill>
-                  <a:srgbClr val="FFFFFF"/>
-                </a:solidFill>
-                <a:latin typeface="Calibri" pitchFamily="34" charset="0"/>
-                <a:ea typeface="Calibri" pitchFamily="34" charset="-122"/>
-                <a:cs typeface="Calibri" pitchFamily="34" charset="-120"/>
-              </a:rPr>
-              <a:t>Inicio de la actividad</a:t>
-            </a:r>
-            <a:endParaRPr lang="en-US" sz="1200" dirty="0"/>
-          </a:p>
-        </p:txBody>
-      </p:sp>
-      <p:sp>
-        <p:nvSpPr>
-          <p:cNvPr id="8" name="Shape 6"/>
+          <p:cNvPr id="9" name="Text 6"/>
+          <p:cNvSpPr txBox="1"/>
+          <p:nvPr/>
+        </p:nvSpPr>
+        <p:spPr>
+          <a:xfrm>
+            <a:off x="4983480" y="2606040"/>
+            <a:ext cx="3566160" cy="228600"/>
+          </a:xfrm>
+          <a:prstGeom prst="rect">
+            <a:avLst/>
+          </a:prstGeom>
+          <a:noFill/>
+          <a:ln/>
+        </p:spPr>
+        <p:txBody>
+          <a:bodyPr wrap="square" lIns="0" tIns="0" rIns="0" bIns="0" rtlCol="0" anchor="ctr"/>
+          <a:lstStyle/>
+          <a:p>
+            <a:pPr indent="0" marL="0">
+              <a:buNone/>
+            </a:pPr>
+            <a:r>
+              <a:rPr lang="en-US" sz="950" b="1" spc="300" kern="0" dirty="0">
+                <a:solidFill>
+                  <a:srgbClr val="E5323B"/>
+                </a:solidFill>
+                <a:latin typeface="Calibri" pitchFamily="34" charset="0"/>
+                <a:ea typeface="Calibri" pitchFamily="34" charset="-122"/>
+                <a:cs typeface="Calibri" pitchFamily="34" charset="-120"/>
+              </a:rPr>
+              <a:t>MISIÓN</a:t>
+            </a:r>
+            <a:endParaRPr lang="en-US" sz="950" dirty="0"/>
+          </a:p>
+        </p:txBody>
+      </p:sp>
+      <p:sp>
+        <p:nvSpPr>
+          <p:cNvPr id="10" name="Text 7"/>
+          <p:cNvSpPr txBox="1"/>
+          <p:nvPr/>
+        </p:nvSpPr>
+        <p:spPr>
+          <a:xfrm>
+            <a:off x="4983480" y="2834640"/>
+            <a:ext cx="3566160" cy="594360"/>
+          </a:xfrm>
+          <a:prstGeom prst="rect">
+            <a:avLst/>
+          </a:prstGeom>
+          <a:noFill/>
+          <a:ln/>
+        </p:spPr>
+        <p:txBody>
+          <a:bodyPr wrap="square" lIns="0" tIns="0" rIns="0" bIns="0" rtlCol="0" anchor="t"/>
+          <a:lstStyle/>
+          <a:p>
+            <a:pPr indent="0" marL="0">
+              <a:buNone/>
+            </a:pPr>
+            <a:r>
+              <a:rPr lang="en-US" sz="1050" dirty="0">
+                <a:solidFill>
+                  <a:srgbClr val="3A3D41"/>
+                </a:solidFill>
+                <a:latin typeface="Calibri" pitchFamily="34" charset="0"/>
+                <a:ea typeface="Calibri" pitchFamily="34" charset="-122"/>
+                <a:cs typeface="Calibri" pitchFamily="34" charset="-120"/>
+              </a:rPr>
+              <a:t>Proveer repuestos, componentes y servicios técnicos para mantener operativos los vehículos y equipos de nuestros clientes.</a:t>
+            </a:r>
+            <a:endParaRPr lang="en-US" sz="1050" dirty="0"/>
+          </a:p>
+        </p:txBody>
+      </p:sp>
+      <p:sp>
+        <p:nvSpPr>
+          <p:cNvPr id="11" name="Shape 8"/>
           <p:cNvSpPr/>
           <p:nvPr/>
         </p:nvSpPr>
         <p:spPr>
           <a:xfrm>
-            <a:off x="5029200" y="1874520"/>
-            <a:ext cx="3657600" cy="1234440"/>
+            <a:off x="4206240" y="3611880"/>
+            <a:ext cx="4480560" cy="960120"/>
           </a:xfrm>
           <a:prstGeom prst="roundRect">
             <a:avLst>
-              <a:gd name="adj" fmla="val 7407"/>
+              <a:gd name="adj" fmla="val 7619"/>
             </a:avLst>
           </a:prstGeom>
           <a:solidFill>
             <a:srgbClr val="F3F4F5"/>
           </a:solidFill>
           <a:ln/>
-          <a:effectLst>
-            <a:outerShdw sx="100000" sy="100000" kx="0" ky="0" algn="bl" rotWithShape="0" blurRad="101600" dist="25400" dir="5400000">
-              <a:srgbClr val="000000">
-                <a:alpha val="12000"/>
-              </a:srgbClr>
-            </a:outerShdw>
-          </a:effectLst>
-        </p:spPr>
-      </p:sp>
-      <p:sp>
-        <p:nvSpPr>
-          <p:cNvPr id="9" name="Text 7"/>
-          <p:cNvSpPr txBox="1"/>
-          <p:nvPr/>
-        </p:nvSpPr>
-        <p:spPr>
-          <a:xfrm>
-            <a:off x="5257800" y="1965960"/>
-            <a:ext cx="1737360" cy="1051560"/>
-          </a:xfrm>
-          <a:prstGeom prst="rect">
-            <a:avLst/>
-          </a:prstGeom>
-          <a:noFill/>
-          <a:ln/>
-        </p:spPr>
-        <p:txBody>
-          <a:bodyPr wrap="square" lIns="0" tIns="0" rIns="0" bIns="0" rtlCol="0" anchor="ctr"/>
-          <a:lstStyle/>
-          <a:p>
-            <a:pPr indent="0" marL="0">
-              <a:buNone/>
-            </a:pPr>
-            <a:r>
-              <a:rPr lang="en-US" sz="3800" b="1" dirty="0">
-                <a:solidFill>
-                  <a:srgbClr val="E5323B"/>
-                </a:solidFill>
-                <a:latin typeface="Cambria" pitchFamily="34" charset="0"/>
-                <a:ea typeface="Cambria" pitchFamily="34" charset="-122"/>
-                <a:cs typeface="Cambria" pitchFamily="34" charset="-120"/>
-              </a:rPr>
-              <a:t>2</a:t>
-            </a:r>
-            <a:endParaRPr lang="en-US" sz="3800" dirty="0"/>
-          </a:p>
-        </p:txBody>
-      </p:sp>
-      <p:sp>
-        <p:nvSpPr>
-          <p:cNvPr id="10" name="Text 8"/>
-          <p:cNvSpPr txBox="1"/>
-          <p:nvPr/>
-        </p:nvSpPr>
-        <p:spPr>
-          <a:xfrm>
-            <a:off x="6949440" y="1965960"/>
-            <a:ext cx="1554480" cy="1051560"/>
-          </a:xfrm>
-          <a:prstGeom prst="rect">
-            <a:avLst/>
-          </a:prstGeom>
-          <a:noFill/>
-          <a:ln/>
-        </p:spPr>
-        <p:txBody>
-          <a:bodyPr wrap="square" lIns="0" tIns="0" rIns="0" bIns="0" rtlCol="0" anchor="ctr"/>
-          <a:lstStyle/>
-          <a:p>
-            <a:pPr indent="0" marL="0">
-              <a:buNone/>
-            </a:pPr>
-            <a:r>
-              <a:rPr lang="en-US" sz="1200" dirty="0">
+        </p:spPr>
+      </p:sp>
+      <p:sp>
+        <p:nvSpPr>
+          <p:cNvPr id="12" name="Shape 9"/>
+          <p:cNvSpPr/>
+          <p:nvPr/>
+        </p:nvSpPr>
+        <p:spPr>
+          <a:xfrm>
+            <a:off x="4389120" y="3886200"/>
+            <a:ext cx="411480" cy="411480"/>
+          </a:xfrm>
+          <a:prstGeom prst="ellipse">
+            <a:avLst/>
+          </a:prstGeom>
+          <a:solidFill>
+            <a:srgbClr val="1E2023"/>
+          </a:solidFill>
+          <a:ln/>
+        </p:spPr>
+      </p:sp>
+      <p:sp>
+        <p:nvSpPr>
+          <p:cNvPr id="13" name="Text 10"/>
+          <p:cNvSpPr txBox="1"/>
+          <p:nvPr/>
+        </p:nvSpPr>
+        <p:spPr>
+          <a:xfrm>
+            <a:off x="4983480" y="3703320"/>
+            <a:ext cx="3566160" cy="228600"/>
+          </a:xfrm>
+          <a:prstGeom prst="rect">
+            <a:avLst/>
+          </a:prstGeom>
+          <a:noFill/>
+          <a:ln/>
+        </p:spPr>
+        <p:txBody>
+          <a:bodyPr wrap="square" lIns="0" tIns="0" rIns="0" bIns="0" rtlCol="0" anchor="ctr"/>
+          <a:lstStyle/>
+          <a:p>
+            <a:pPr indent="0" marL="0">
+              <a:buNone/>
+            </a:pPr>
+            <a:r>
+              <a:rPr lang="en-US" sz="950" b="1" spc="300" kern="0" dirty="0">
                 <a:solidFill>
                   <a:srgbClr val="1E2023"/>
                 </a:solidFill>
@@ -2751,145 +2751,77 @@
                 <a:ea typeface="Calibri" pitchFamily="34" charset="-122"/>
                 <a:cs typeface="Calibri" pitchFamily="34" charset="-120"/>
               </a:rPr>
-              <a:t>Unidades propias en zonas agroproductivas</a:t>
-            </a:r>
-            <a:endParaRPr lang="en-US" sz="1200" dirty="0"/>
-          </a:p>
-        </p:txBody>
-      </p:sp>
-      <p:sp>
-        <p:nvSpPr>
-          <p:cNvPr id="11" name="Shape 9"/>
-          <p:cNvSpPr/>
-          <p:nvPr/>
-        </p:nvSpPr>
-        <p:spPr>
-          <a:xfrm>
-            <a:off x="5029200" y="3291840"/>
-            <a:ext cx="3657600" cy="1234440"/>
-          </a:xfrm>
-          <a:prstGeom prst="roundRect">
-            <a:avLst>
-              <a:gd name="adj" fmla="val 7407"/>
-            </a:avLst>
-          </a:prstGeom>
-          <a:solidFill>
-            <a:srgbClr val="F3F4F5"/>
-          </a:solidFill>
-          <a:ln/>
-          <a:effectLst>
-            <a:outerShdw sx="100000" sy="100000" kx="0" ky="0" algn="bl" rotWithShape="0" blurRad="101600" dist="25400" dir="5400000">
-              <a:srgbClr val="000000">
-                <a:alpha val="12000"/>
-              </a:srgbClr>
-            </a:outerShdw>
-          </a:effectLst>
-        </p:spPr>
-      </p:sp>
-      <p:sp>
-        <p:nvSpPr>
-          <p:cNvPr id="12" name="Text 10"/>
-          <p:cNvSpPr txBox="1"/>
-          <p:nvPr/>
-        </p:nvSpPr>
-        <p:spPr>
-          <a:xfrm>
-            <a:off x="5257800" y="3383280"/>
-            <a:ext cx="1737360" cy="1051560"/>
-          </a:xfrm>
-          <a:prstGeom prst="rect">
-            <a:avLst/>
-          </a:prstGeom>
-          <a:noFill/>
-          <a:ln/>
-        </p:spPr>
-        <p:txBody>
-          <a:bodyPr wrap="square" lIns="0" tIns="0" rIns="0" bIns="0" rtlCol="0" anchor="ctr"/>
-          <a:lstStyle/>
-          <a:p>
-            <a:pPr indent="0" marL="0">
-              <a:buNone/>
-            </a:pPr>
-            <a:r>
-              <a:rPr lang="en-US" sz="3800" b="1" dirty="0">
-                <a:solidFill>
-                  <a:srgbClr val="E5323B"/>
-                </a:solidFill>
-                <a:latin typeface="Cambria" pitchFamily="34" charset="0"/>
-                <a:ea typeface="Cambria" pitchFamily="34" charset="-122"/>
-                <a:cs typeface="Cambria" pitchFamily="34" charset="-120"/>
-              </a:rPr>
-              <a:t>3.259</a:t>
-            </a:r>
-            <a:endParaRPr lang="en-US" sz="3800" dirty="0"/>
-          </a:p>
-        </p:txBody>
-      </p:sp>
-      <p:sp>
-        <p:nvSpPr>
-          <p:cNvPr id="13" name="Text 11"/>
-          <p:cNvSpPr txBox="1"/>
-          <p:nvPr/>
-        </p:nvSpPr>
-        <p:spPr>
-          <a:xfrm>
-            <a:off x="6949440" y="3383280"/>
-            <a:ext cx="1554480" cy="1051560"/>
-          </a:xfrm>
-          <a:prstGeom prst="rect">
-            <a:avLst/>
-          </a:prstGeom>
-          <a:noFill/>
-          <a:ln/>
-        </p:spPr>
-        <p:txBody>
-          <a:bodyPr wrap="square" lIns="0" tIns="0" rIns="0" bIns="0" rtlCol="0" anchor="ctr"/>
-          <a:lstStyle/>
-          <a:p>
-            <a:pPr indent="0" marL="0">
-              <a:buNone/>
-            </a:pPr>
-            <a:r>
-              <a:rPr lang="en-US" sz="1200" dirty="0">
-                <a:solidFill>
-                  <a:srgbClr val="1E2023"/>
-                </a:solidFill>
-                <a:latin typeface="Calibri" pitchFamily="34" charset="0"/>
-                <a:ea typeface="Calibri" pitchFamily="34" charset="-122"/>
-                <a:cs typeface="Calibri" pitchFamily="34" charset="-120"/>
-              </a:rPr>
-              <a:t>Clientes atendidos entre 2023 y 2025</a:t>
-            </a:r>
-            <a:endParaRPr lang="en-US" sz="1200" dirty="0"/>
-          </a:p>
-        </p:txBody>
-      </p:sp>
-      <p:sp>
-        <p:nvSpPr>
-          <p:cNvPr id="14" name="Text 12"/>
-          <p:cNvSpPr txBox="1"/>
-          <p:nvPr/>
-        </p:nvSpPr>
-        <p:spPr>
-          <a:xfrm>
-            <a:off x="457200" y="4800600"/>
-            <a:ext cx="5486400" cy="228600"/>
-          </a:xfrm>
-          <a:prstGeom prst="rect">
-            <a:avLst/>
-          </a:prstGeom>
-          <a:noFill/>
-          <a:ln/>
-        </p:spPr>
-        <p:txBody>
-          <a:bodyPr wrap="square" lIns="0" tIns="0" rIns="0" bIns="0" rtlCol="0" anchor="ctr"/>
-          <a:lstStyle/>
-          <a:p>
-            <a:pPr indent="0" marL="0">
-              <a:buNone/>
-            </a:pPr>
-            <a:r>
-              <a:rPr lang="en-US" sz="800" dirty="0">
+              <a:t>VISIÓN</a:t>
+            </a:r>
+            <a:endParaRPr lang="en-US" sz="950" dirty="0"/>
+          </a:p>
+        </p:txBody>
+      </p:sp>
+      <p:sp>
+        <p:nvSpPr>
+          <p:cNvPr id="14" name="Text 11"/>
+          <p:cNvSpPr txBox="1"/>
+          <p:nvPr/>
+        </p:nvSpPr>
+        <p:spPr>
+          <a:xfrm>
+            <a:off x="4983480" y="3931920"/>
+            <a:ext cx="3566160" cy="594360"/>
+          </a:xfrm>
+          <a:prstGeom prst="rect">
+            <a:avLst/>
+          </a:prstGeom>
+          <a:noFill/>
+          <a:ln/>
+        </p:spPr>
+        <p:txBody>
+          <a:bodyPr wrap="square" lIns="0" tIns="0" rIns="0" bIns="0" rtlCol="0" anchor="t"/>
+          <a:lstStyle/>
+          <a:p>
+            <a:pPr indent="0" marL="0">
+              <a:buNone/>
+            </a:pPr>
+            <a:r>
+              <a:rPr lang="en-US" sz="1050" dirty="0">
+                <a:solidFill>
+                  <a:srgbClr val="3A3D41"/>
+                </a:solidFill>
+                <a:latin typeface="Calibri" pitchFamily="34" charset="0"/>
+                <a:ea typeface="Calibri" pitchFamily="34" charset="-122"/>
+                <a:cs typeface="Calibri" pitchFamily="34" charset="-120"/>
+              </a:rPr>
+              <a:t>Ser referente en Paraguay en soluciones técnicas para el transporte pesado y el agro.</a:t>
+            </a:r>
+            <a:endParaRPr lang="en-US" sz="1050" dirty="0"/>
+          </a:p>
+        </p:txBody>
+      </p:sp>
+      <p:sp>
+        <p:nvSpPr>
+          <p:cNvPr id="15" name="Text 12"/>
+          <p:cNvSpPr txBox="1"/>
+          <p:nvPr/>
+        </p:nvSpPr>
+        <p:spPr>
+          <a:xfrm>
+            <a:off x="4206240" y="4800600"/>
+            <a:ext cx="3931920" cy="228600"/>
+          </a:xfrm>
+          <a:prstGeom prst="rect">
+            <a:avLst/>
+          </a:prstGeom>
+          <a:noFill/>
+          <a:ln/>
+        </p:spPr>
+        <p:txBody>
+          <a:bodyPr wrap="square" lIns="0" tIns="0" rIns="0" bIns="0" rtlCol="0" anchor="ctr"/>
+          <a:lstStyle/>
+          <a:p>
+            <a:pPr indent="0" marL="0">
+              <a:buNone/>
+            </a:pPr>
+            <a:r>
+              <a:rPr lang="en-US" sz="750" dirty="0">
                 <a:solidFill>
                   <a:srgbClr val="8A8D91"/>
                 </a:solidFill>
@@ -2899,13 +2831,13 @@
               </a:rPr>
               <a:t>Borrador de vista previa · Sujeto a registro ante la Superintendencia de Valores</a:t>
             </a:r>
-            <a:endParaRPr lang="en-US" sz="800" dirty="0"/>
-          </a:p>
-        </p:txBody>
-      </p:sp>
-      <p:sp>
-        <p:nvSpPr>
-          <p:cNvPr id="15" name="Text 13"/>
+            <a:endParaRPr lang="en-US" sz="750" dirty="0"/>
+          </a:p>
+        </p:txBody>
+      </p:sp>
+      <p:sp>
+        <p:nvSpPr>
+          <p:cNvPr id="16" name="Text 13"/>
           <p:cNvSpPr txBox="1"/>
           <p:nvPr/>
         </p:nvSpPr>
@@ -2974,94 +2906,180 @@
           <a:chExt cx="0" cy="0"/>
         </a:xfrm>
       </p:grpSpPr>
-      <p:sp>
-        <p:nvSpPr>
-          <p:cNvPr id="2" name="Text 0"/>
-          <p:cNvSpPr txBox="1"/>
-          <p:nvPr/>
-        </p:nvSpPr>
-        <p:spPr>
-          <a:xfrm>
-            <a:off x="457200" y="320040"/>
-            <a:ext cx="8229600" cy="640080"/>
-          </a:xfrm>
-          <a:prstGeom prst="rect">
-            <a:avLst/>
-          </a:prstGeom>
-          <a:noFill/>
-          <a:ln/>
-        </p:spPr>
-        <p:txBody>
-          <a:bodyPr wrap="square" lIns="0" tIns="0" rIns="0" bIns="0" rtlCol="0" anchor="ctr"/>
-          <a:lstStyle/>
-          <a:p>
-            <a:pPr indent="0" marL="0">
-              <a:buNone/>
-            </a:pPr>
-            <a:r>
-              <a:rPr lang="en-US" sz="3000" b="1" dirty="0">
-                <a:solidFill>
-                  <a:srgbClr val="1E2023"/>
+      <p:pic>
+        <p:nvPicPr>
+          <p:cNvPr id="2" name="Image 0" descr="use/hierro.jpg">    </p:cNvPr>
+          <p:cNvPicPr>
+            <a:picLocks noChangeAspect="1"/>
+          </p:cNvPicPr>
+          <p:nvPr/>
+        </p:nvPicPr>
+        <p:blipFill>
+          <a:blip r:embed="rId1"/>
+          <a:srcRect l="0" r="0" t="0" b="0"/>
+          <a:stretch/>
+        </p:blipFill>
+        <p:spPr>
+          <a:xfrm>
+            <a:off x="457200" y="457200"/>
+            <a:ext cx="3291840" cy="3566160"/>
+          </a:xfrm>
+          <a:prstGeom prst="rect">
+            <a:avLst/>
+          </a:prstGeom>
+        </p:spPr>
+      </p:pic>
+      <p:sp>
+        <p:nvSpPr>
+          <p:cNvPr id="3" name="Shape 0"/>
+          <p:cNvSpPr/>
+          <p:nvPr/>
+        </p:nvSpPr>
+        <p:spPr>
+          <a:xfrm>
+            <a:off x="594360" y="3657600"/>
+            <a:ext cx="3017520" cy="274320"/>
+          </a:xfrm>
+          <a:prstGeom prst="roundRect">
+            <a:avLst>
+              <a:gd name="adj" fmla="val 16667"/>
+            </a:avLst>
+          </a:prstGeom>
+          <a:solidFill>
+            <a:srgbClr val="1E2023">
+              <a:alpha val="85000"/>
+            </a:srgbClr>
+          </a:solidFill>
+          <a:ln/>
+        </p:spPr>
+      </p:sp>
+      <p:sp>
+        <p:nvSpPr>
+          <p:cNvPr id="4" name="Text 1"/>
+          <p:cNvSpPr txBox="1"/>
+          <p:nvPr/>
+        </p:nvSpPr>
+        <p:spPr>
+          <a:xfrm>
+            <a:off x="594360" y="3657600"/>
+            <a:ext cx="3017520" cy="274320"/>
+          </a:xfrm>
+          <a:prstGeom prst="rect">
+            <a:avLst/>
+          </a:prstGeom>
+          <a:noFill/>
+          <a:ln/>
+        </p:spPr>
+        <p:txBody>
+          <a:bodyPr wrap="square" lIns="0" tIns="0" rIns="0" bIns="0" rtlCol="0" anchor="ctr"/>
+          <a:lstStyle/>
+          <a:p>
+            <a:pPr algn="ctr" indent="0" marL="0">
+              <a:buNone/>
+            </a:pPr>
+            <a:r>
+              <a:rPr lang="en-US" sz="1000" b="1" dirty="0">
+                <a:solidFill>
+                  <a:srgbClr val="FFFFFF"/>
+                </a:solidFill>
+                <a:latin typeface="Calibri" pitchFamily="34" charset="0"/>
+                <a:ea typeface="Calibri" pitchFamily="34" charset="-122"/>
+                <a:cs typeface="Calibri" pitchFamily="34" charset="-120"/>
+              </a:rPr>
+              <a:t>Cartel original del negocio · años 90</a:t>
+            </a:r>
+            <a:endParaRPr lang="en-US" sz="1000" dirty="0"/>
+          </a:p>
+        </p:txBody>
+      </p:sp>
+      <p:sp>
+        <p:nvSpPr>
+          <p:cNvPr id="5" name="Text 2"/>
+          <p:cNvSpPr txBox="1"/>
+          <p:nvPr/>
+        </p:nvSpPr>
+        <p:spPr>
+          <a:xfrm>
+            <a:off x="457200" y="4160520"/>
+            <a:ext cx="3291840" cy="548640"/>
+          </a:xfrm>
+          <a:prstGeom prst="rect">
+            <a:avLst/>
+          </a:prstGeom>
+          <a:noFill/>
+          <a:ln/>
+        </p:spPr>
+        <p:txBody>
+          <a:bodyPr wrap="square" lIns="0" tIns="0" rIns="0" bIns="0" rtlCol="0" anchor="t"/>
+          <a:lstStyle/>
+          <a:p>
+            <a:pPr indent="0" marL="0">
+              <a:buNone/>
+            </a:pPr>
+            <a:r>
+              <a:rPr lang="en-US" sz="1150" i="1" dirty="0">
+                <a:solidFill>
+                  <a:srgbClr val="3A3D41"/>
                 </a:solidFill>
                 <a:latin typeface="Cambria" pitchFamily="34" charset="0"/>
                 <a:ea typeface="Cambria" pitchFamily="34" charset="-122"/>
                 <a:cs typeface="Cambria" pitchFamily="34" charset="-120"/>
               </a:rPr>
+              <a:t>“Del hierro viejo a una red de repuestos”</a:t>
+            </a:r>
+            <a:endParaRPr lang="en-US" sz="1150" dirty="0"/>
+          </a:p>
+        </p:txBody>
+      </p:sp>
+      <p:sp>
+        <p:nvSpPr>
+          <p:cNvPr id="6" name="Text 3"/>
+          <p:cNvSpPr txBox="1"/>
+          <p:nvPr/>
+        </p:nvSpPr>
+        <p:spPr>
+          <a:xfrm>
+            <a:off x="4206240" y="365760"/>
+            <a:ext cx="4480560" cy="548640"/>
+          </a:xfrm>
+          <a:prstGeom prst="rect">
+            <a:avLst/>
+          </a:prstGeom>
+          <a:noFill/>
+          <a:ln/>
+        </p:spPr>
+        <p:txBody>
+          <a:bodyPr wrap="square" lIns="0" tIns="0" rIns="0" bIns="0" rtlCol="0" anchor="ctr"/>
+          <a:lstStyle/>
+          <a:p>
+            <a:pPr indent="0" marL="0">
+              <a:buNone/>
+            </a:pPr>
+            <a:r>
+              <a:rPr lang="en-US" sz="2800" b="1" dirty="0">
+                <a:solidFill>
+                  <a:srgbClr val="1E2023"/>
+                </a:solidFill>
+                <a:latin typeface="Cambria" pitchFamily="34" charset="0"/>
+                <a:ea typeface="Cambria" pitchFamily="34" charset="-122"/>
+                <a:cs typeface="Cambria" pitchFamily="34" charset="-120"/>
+              </a:rPr>
               <a:t>Nuestra trayectoria</a:t>
             </a:r>
-            <a:endParaRPr lang="en-US" sz="3000" dirty="0"/>
-          </a:p>
-        </p:txBody>
-      </p:sp>
-      <p:sp>
-        <p:nvSpPr>
-          <p:cNvPr id="3" name="Text 1"/>
-          <p:cNvSpPr txBox="1"/>
-          <p:nvPr/>
-        </p:nvSpPr>
-        <p:spPr>
-          <a:xfrm>
-            <a:off x="457200" y="932688"/>
-            <a:ext cx="7315200" cy="274320"/>
-          </a:xfrm>
-          <a:prstGeom prst="rect">
-            <a:avLst/>
-          </a:prstGeom>
-          <a:noFill/>
-          <a:ln/>
-        </p:spPr>
-        <p:txBody>
-          <a:bodyPr wrap="square" lIns="0" tIns="0" rIns="0" bIns="0" rtlCol="0" anchor="ctr"/>
-          <a:lstStyle/>
-          <a:p>
-            <a:pPr indent="0" marL="0">
-              <a:buNone/>
-            </a:pPr>
-            <a:r>
-              <a:rPr lang="en-US" sz="1200" dirty="0">
-                <a:solidFill>
-                  <a:srgbClr val="8A8D91"/>
-                </a:solidFill>
-                <a:latin typeface="Calibri" pitchFamily="34" charset="0"/>
-                <a:ea typeface="Calibri" pitchFamily="34" charset="-122"/>
-                <a:cs typeface="Calibri" pitchFamily="34" charset="-120"/>
-              </a:rPr>
-              <a:t>Casi tres décadas de conocimiento técnico</a:t>
-            </a:r>
-            <a:endParaRPr lang="en-US" sz="1200" dirty="0"/>
-          </a:p>
-        </p:txBody>
-      </p:sp>
-      <p:sp>
-        <p:nvSpPr>
-          <p:cNvPr id="4" name="Shape 2"/>
+            <a:endParaRPr lang="en-US" sz="2800" dirty="0"/>
+          </a:p>
+        </p:txBody>
+      </p:sp>
+      <p:sp>
+        <p:nvSpPr>
+          <p:cNvPr id="7" name="Shape 4"/>
           <p:cNvSpPr/>
           <p:nvPr/>
         </p:nvSpPr>
         <p:spPr>
           <a:xfrm>
-            <a:off x="640080" y="2331720"/>
-            <a:ext cx="7863840" cy="0"/>
+            <a:off x="4617720" y="1234440"/>
+            <a:ext cx="0" cy="3291840"/>
           </a:xfrm>
           <a:prstGeom prst="line">
             <a:avLst/>
@@ -3069,7 +3087,7 @@
           <a:noFill/>
           <a:ln w="19050">
             <a:solidFill>
-              <a:srgbClr val="8A8D91"/>
+              <a:srgbClr val="C4C6C9"/>
             </a:solidFill>
             <a:prstDash val="solid"/>
           </a:ln>
@@ -3077,14 +3095,14 @@
       </p:sp>
       <p:sp>
         <p:nvSpPr>
-          <p:cNvPr id="5" name="Shape 3"/>
+          <p:cNvPr id="8" name="Shape 5"/>
           <p:cNvSpPr/>
           <p:nvPr/>
         </p:nvSpPr>
         <p:spPr>
           <a:xfrm>
-            <a:off x="914400" y="2194560"/>
-            <a:ext cx="274320" cy="274320"/>
+            <a:off x="4507992" y="1225296"/>
+            <a:ext cx="219456" cy="219456"/>
           </a:xfrm>
           <a:prstGeom prst="ellipse">
             <a:avLst/>
@@ -3102,30 +3120,30 @@
       </p:sp>
       <p:sp>
         <p:nvSpPr>
-          <p:cNvPr id="6" name="Text 4"/>
-          <p:cNvSpPr txBox="1"/>
-          <p:nvPr/>
-        </p:nvSpPr>
-        <p:spPr>
-          <a:xfrm>
-            <a:off x="457200" y="1600200"/>
-            <a:ext cx="1188720" cy="457200"/>
-          </a:xfrm>
-          <a:prstGeom prst="rect">
-            <a:avLst/>
-          </a:prstGeom>
-          <a:noFill/>
-          <a:ln/>
-        </p:spPr>
-        <p:txBody>
-          <a:bodyPr wrap="square" lIns="0" tIns="0" rIns="0" bIns="0" rtlCol="0" anchor="ctr"/>
-          <a:lstStyle/>
-          <a:p>
-            <a:pPr algn="ctr" indent="0" marL="0">
-              <a:buNone/>
-            </a:pPr>
-            <a:r>
-              <a:rPr lang="en-US" sz="2200" b="1" dirty="0">
+          <p:cNvPr id="9" name="Text 6"/>
+          <p:cNvSpPr txBox="1"/>
+          <p:nvPr/>
+        </p:nvSpPr>
+        <p:spPr>
+          <a:xfrm>
+            <a:off x="4892040" y="1097280"/>
+            <a:ext cx="822960" cy="475488"/>
+          </a:xfrm>
+          <a:prstGeom prst="rect">
+            <a:avLst/>
+          </a:prstGeom>
+          <a:noFill/>
+          <a:ln/>
+        </p:spPr>
+        <p:txBody>
+          <a:bodyPr wrap="square" lIns="0" tIns="0" rIns="0" bIns="0" rtlCol="0" anchor="ctr"/>
+          <a:lstStyle/>
+          <a:p>
+            <a:pPr indent="0" marL="0">
+              <a:buNone/>
+            </a:pPr>
+            <a:r>
+              <a:rPr lang="en-US" sz="1700" b="1" dirty="0">
                 <a:solidFill>
                   <a:srgbClr val="1E2023"/>
                 </a:solidFill>
@@ -3135,36 +3153,36 @@
               </a:rPr>
               <a:t>1996</a:t>
             </a:r>
-            <a:endParaRPr lang="en-US" sz="2200" dirty="0"/>
-          </a:p>
-        </p:txBody>
-      </p:sp>
-      <p:sp>
-        <p:nvSpPr>
-          <p:cNvPr id="7" name="Text 5"/>
-          <p:cNvSpPr txBox="1"/>
-          <p:nvPr/>
-        </p:nvSpPr>
-        <p:spPr>
-          <a:xfrm>
-            <a:off x="411480" y="2697480"/>
-            <a:ext cx="1280160" cy="1737360"/>
-          </a:xfrm>
-          <a:prstGeom prst="rect">
-            <a:avLst/>
-          </a:prstGeom>
-          <a:noFill/>
-          <a:ln/>
-        </p:spPr>
-        <p:txBody>
-          <a:bodyPr wrap="square" lIns="0" tIns="0" rIns="0" bIns="0" rtlCol="0" anchor="t"/>
-          <a:lstStyle/>
-          <a:p>
-            <a:pPr algn="ctr" indent="0" marL="0">
-              <a:buNone/>
-            </a:pPr>
-            <a:r>
-              <a:rPr lang="en-US" sz="1100" dirty="0">
+            <a:endParaRPr lang="en-US" sz="1700" dirty="0"/>
+          </a:p>
+        </p:txBody>
+      </p:sp>
+      <p:sp>
+        <p:nvSpPr>
+          <p:cNvPr id="10" name="Text 7"/>
+          <p:cNvSpPr txBox="1"/>
+          <p:nvPr/>
+        </p:nvSpPr>
+        <p:spPr>
+          <a:xfrm>
+            <a:off x="5715000" y="1097280"/>
+            <a:ext cx="3017520" cy="475488"/>
+          </a:xfrm>
+          <a:prstGeom prst="rect">
+            <a:avLst/>
+          </a:prstGeom>
+          <a:noFill/>
+          <a:ln/>
+        </p:spPr>
+        <p:txBody>
+          <a:bodyPr wrap="square" lIns="0" tIns="0" rIns="0" bIns="0" rtlCol="0" anchor="ctr"/>
+          <a:lstStyle/>
+          <a:p>
+            <a:pPr indent="0" marL="0">
+              <a:buNone/>
+            </a:pPr>
+            <a:r>
+              <a:rPr lang="en-US" sz="1050" dirty="0">
                 <a:solidFill>
                   <a:srgbClr val="3A3D41"/>
                 </a:solidFill>
@@ -3174,20 +3192,20 @@
               </a:rPr>
               <a:t>Nelson Tavares dos Santos inicia la recuperación y venta de piezas para transporte pesado</a:t>
             </a:r>
-            <a:endParaRPr lang="en-US" sz="1100" dirty="0"/>
-          </a:p>
-        </p:txBody>
-      </p:sp>
-      <p:sp>
-        <p:nvSpPr>
-          <p:cNvPr id="8" name="Shape 6"/>
+            <a:endParaRPr lang="en-US" sz="1050" dirty="0"/>
+          </a:p>
+        </p:txBody>
+      </p:sp>
+      <p:sp>
+        <p:nvSpPr>
+          <p:cNvPr id="11" name="Shape 8"/>
           <p:cNvSpPr/>
           <p:nvPr/>
         </p:nvSpPr>
         <p:spPr>
           <a:xfrm>
-            <a:off x="2286000" y="2194560"/>
-            <a:ext cx="274320" cy="274320"/>
+            <a:off x="4507992" y="1801368"/>
+            <a:ext cx="219456" cy="219456"/>
           </a:xfrm>
           <a:prstGeom prst="ellipse">
             <a:avLst/>
@@ -3205,30 +3223,30 @@
       </p:sp>
       <p:sp>
         <p:nvSpPr>
-          <p:cNvPr id="9" name="Text 7"/>
-          <p:cNvSpPr txBox="1"/>
-          <p:nvPr/>
-        </p:nvSpPr>
-        <p:spPr>
-          <a:xfrm>
-            <a:off x="1828800" y="1600200"/>
-            <a:ext cx="1188720" cy="457200"/>
-          </a:xfrm>
-          <a:prstGeom prst="rect">
-            <a:avLst/>
-          </a:prstGeom>
-          <a:noFill/>
-          <a:ln/>
-        </p:spPr>
-        <p:txBody>
-          <a:bodyPr wrap="square" lIns="0" tIns="0" rIns="0" bIns="0" rtlCol="0" anchor="ctr"/>
-          <a:lstStyle/>
-          <a:p>
-            <a:pPr algn="ctr" indent="0" marL="0">
-              <a:buNone/>
-            </a:pPr>
-            <a:r>
-              <a:rPr lang="en-US" sz="2200" b="1" dirty="0">
+          <p:cNvPr id="12" name="Text 9"/>
+          <p:cNvSpPr txBox="1"/>
+          <p:nvPr/>
+        </p:nvSpPr>
+        <p:spPr>
+          <a:xfrm>
+            <a:off x="4892040" y="1673352"/>
+            <a:ext cx="822960" cy="475488"/>
+          </a:xfrm>
+          <a:prstGeom prst="rect">
+            <a:avLst/>
+          </a:prstGeom>
+          <a:noFill/>
+          <a:ln/>
+        </p:spPr>
+        <p:txBody>
+          <a:bodyPr wrap="square" lIns="0" tIns="0" rIns="0" bIns="0" rtlCol="0" anchor="ctr"/>
+          <a:lstStyle/>
+          <a:p>
+            <a:pPr indent="0" marL="0">
+              <a:buNone/>
+            </a:pPr>
+            <a:r>
+              <a:rPr lang="en-US" sz="1700" b="1" dirty="0">
                 <a:solidFill>
                   <a:srgbClr val="1E2023"/>
                 </a:solidFill>
@@ -3238,36 +3256,36 @@
               </a:rPr>
               <a:t>2008</a:t>
             </a:r>
-            <a:endParaRPr lang="en-US" sz="2200" dirty="0"/>
-          </a:p>
-        </p:txBody>
-      </p:sp>
-      <p:sp>
-        <p:nvSpPr>
-          <p:cNvPr id="10" name="Text 8"/>
-          <p:cNvSpPr txBox="1"/>
-          <p:nvPr/>
-        </p:nvSpPr>
-        <p:spPr>
-          <a:xfrm>
-            <a:off x="1783080" y="2697480"/>
-            <a:ext cx="1280160" cy="1737360"/>
-          </a:xfrm>
-          <a:prstGeom prst="rect">
-            <a:avLst/>
-          </a:prstGeom>
-          <a:noFill/>
-          <a:ln/>
-        </p:spPr>
-        <p:txBody>
-          <a:bodyPr wrap="square" lIns="0" tIns="0" rIns="0" bIns="0" rtlCol="0" anchor="t"/>
-          <a:lstStyle/>
-          <a:p>
-            <a:pPr algn="ctr" indent="0" marL="0">
-              <a:buNone/>
-            </a:pPr>
-            <a:r>
-              <a:rPr lang="en-US" sz="1100" dirty="0">
+            <a:endParaRPr lang="en-US" sz="1700" dirty="0"/>
+          </a:p>
+        </p:txBody>
+      </p:sp>
+      <p:sp>
+        <p:nvSpPr>
+          <p:cNvPr id="13" name="Text 10"/>
+          <p:cNvSpPr txBox="1"/>
+          <p:nvPr/>
+        </p:nvSpPr>
+        <p:spPr>
+          <a:xfrm>
+            <a:off x="5715000" y="1673352"/>
+            <a:ext cx="3017520" cy="475488"/>
+          </a:xfrm>
+          <a:prstGeom prst="rect">
+            <a:avLst/>
+          </a:prstGeom>
+          <a:noFill/>
+          <a:ln/>
+        </p:spPr>
+        <p:txBody>
+          <a:bodyPr wrap="square" lIns="0" tIns="0" rIns="0" bIns="0" rtlCol="0" anchor="ctr"/>
+          <a:lstStyle/>
+          <a:p>
+            <a:pPr indent="0" marL="0">
+              <a:buNone/>
+            </a:pPr>
+            <a:r>
+              <a:rPr lang="en-US" sz="1050" dirty="0">
                 <a:solidFill>
                   <a:srgbClr val="3A3D41"/>
                 </a:solidFill>
@@ -3275,22 +3293,22 @@
                 <a:ea typeface="Calibri" pitchFamily="34" charset="-122"/>
                 <a:cs typeface="Calibri" pitchFamily="34" charset="-120"/>
               </a:rPr>
-              <a:t>Se constituye la sociedad como Rey de los Bulones S.A.</a:t>
-            </a:r>
-            <a:endParaRPr lang="en-US" sz="1100" dirty="0"/>
-          </a:p>
-        </p:txBody>
-      </p:sp>
-      <p:sp>
-        <p:nvSpPr>
-          <p:cNvPr id="11" name="Shape 9"/>
+              <a:t>Se constituye la sociedad (Rey de los Bulones S.A.)</a:t>
+            </a:r>
+            <a:endParaRPr lang="en-US" sz="1050" dirty="0"/>
+          </a:p>
+        </p:txBody>
+      </p:sp>
+      <p:sp>
+        <p:nvSpPr>
+          <p:cNvPr id="14" name="Shape 11"/>
           <p:cNvSpPr/>
           <p:nvPr/>
         </p:nvSpPr>
         <p:spPr>
           <a:xfrm>
-            <a:off x="3657600" y="2194560"/>
-            <a:ext cx="274320" cy="274320"/>
+            <a:off x="4507992" y="2377440"/>
+            <a:ext cx="219456" cy="219456"/>
           </a:xfrm>
           <a:prstGeom prst="ellipse">
             <a:avLst/>
@@ -3308,30 +3326,30 @@
       </p:sp>
       <p:sp>
         <p:nvSpPr>
-          <p:cNvPr id="12" name="Text 10"/>
-          <p:cNvSpPr txBox="1"/>
-          <p:nvPr/>
-        </p:nvSpPr>
-        <p:spPr>
-          <a:xfrm>
-            <a:off x="3200400" y="1600200"/>
-            <a:ext cx="1188720" cy="457200"/>
-          </a:xfrm>
-          <a:prstGeom prst="rect">
-            <a:avLst/>
-          </a:prstGeom>
-          <a:noFill/>
-          <a:ln/>
-        </p:spPr>
-        <p:txBody>
-          <a:bodyPr wrap="square" lIns="0" tIns="0" rIns="0" bIns="0" rtlCol="0" anchor="ctr"/>
-          <a:lstStyle/>
-          <a:p>
-            <a:pPr algn="ctr" indent="0" marL="0">
-              <a:buNone/>
-            </a:pPr>
-            <a:r>
-              <a:rPr lang="en-US" sz="2200" b="1" dirty="0">
+          <p:cNvPr id="15" name="Text 12"/>
+          <p:cNvSpPr txBox="1"/>
+          <p:nvPr/>
+        </p:nvSpPr>
+        <p:spPr>
+          <a:xfrm>
+            <a:off x="4892040" y="2249424"/>
+            <a:ext cx="822960" cy="475488"/>
+          </a:xfrm>
+          <a:prstGeom prst="rect">
+            <a:avLst/>
+          </a:prstGeom>
+          <a:noFill/>
+          <a:ln/>
+        </p:spPr>
+        <p:txBody>
+          <a:bodyPr wrap="square" lIns="0" tIns="0" rIns="0" bIns="0" rtlCol="0" anchor="ctr"/>
+          <a:lstStyle/>
+          <a:p>
+            <a:pPr indent="0" marL="0">
+              <a:buNone/>
+            </a:pPr>
+            <a:r>
+              <a:rPr lang="en-US" sz="1700" b="1" dirty="0">
                 <a:solidFill>
                   <a:srgbClr val="1E2023"/>
                 </a:solidFill>
@@ -3341,36 +3359,36 @@
               </a:rPr>
               <a:t>2012</a:t>
             </a:r>
-            <a:endParaRPr lang="en-US" sz="2200" dirty="0"/>
-          </a:p>
-        </p:txBody>
-      </p:sp>
-      <p:sp>
-        <p:nvSpPr>
-          <p:cNvPr id="13" name="Text 11"/>
-          <p:cNvSpPr txBox="1"/>
-          <p:nvPr/>
-        </p:nvSpPr>
-        <p:spPr>
-          <a:xfrm>
-            <a:off x="3154680" y="2697480"/>
-            <a:ext cx="1280160" cy="1737360"/>
-          </a:xfrm>
-          <a:prstGeom prst="rect">
-            <a:avLst/>
-          </a:prstGeom>
-          <a:noFill/>
-          <a:ln/>
-        </p:spPr>
-        <p:txBody>
-          <a:bodyPr wrap="square" lIns="0" tIns="0" rIns="0" bIns="0" rtlCol="0" anchor="t"/>
-          <a:lstStyle/>
-          <a:p>
-            <a:pPr algn="ctr" indent="0" marL="0">
-              <a:buNone/>
-            </a:pPr>
-            <a:r>
-              <a:rPr lang="en-US" sz="1100" dirty="0">
+            <a:endParaRPr lang="en-US" sz="1700" dirty="0"/>
+          </a:p>
+        </p:txBody>
+      </p:sp>
+      <p:sp>
+        <p:nvSpPr>
+          <p:cNvPr id="16" name="Text 13"/>
+          <p:cNvSpPr txBox="1"/>
+          <p:nvPr/>
+        </p:nvSpPr>
+        <p:spPr>
+          <a:xfrm>
+            <a:off x="5715000" y="2249424"/>
+            <a:ext cx="3017520" cy="475488"/>
+          </a:xfrm>
+          <a:prstGeom prst="rect">
+            <a:avLst/>
+          </a:prstGeom>
+          <a:noFill/>
+          <a:ln/>
+        </p:spPr>
+        <p:txBody>
+          <a:bodyPr wrap="square" lIns="0" tIns="0" rIns="0" bIns="0" rtlCol="0" anchor="ctr"/>
+          <a:lstStyle/>
+          <a:p>
+            <a:pPr indent="0" marL="0">
+              <a:buNone/>
+            </a:pPr>
+            <a:r>
+              <a:rPr lang="en-US" sz="1050" dirty="0">
                 <a:solidFill>
                   <a:srgbClr val="3A3D41"/>
                 </a:solidFill>
@@ -3378,22 +3396,22 @@
                 <a:ea typeface="Calibri" pitchFamily="34" charset="-122"/>
                 <a:cs typeface="Calibri" pitchFamily="34" charset="-120"/>
               </a:rPr>
-              <a:t>Adopta el nombre Repuestos Tavares S.A.; consolida la unidad de Katueté</a:t>
-            </a:r>
-            <a:endParaRPr lang="en-US" sz="1100" dirty="0"/>
-          </a:p>
-        </p:txBody>
-      </p:sp>
-      <p:sp>
-        <p:nvSpPr>
-          <p:cNvPr id="14" name="Shape 12"/>
+              <a:t>Adopta el nombre Repuestos Tavares S.A. y consolida la unidad de Katueté</a:t>
+            </a:r>
+            <a:endParaRPr lang="en-US" sz="1050" dirty="0"/>
+          </a:p>
+        </p:txBody>
+      </p:sp>
+      <p:sp>
+        <p:nvSpPr>
+          <p:cNvPr id="17" name="Shape 14"/>
           <p:cNvSpPr/>
           <p:nvPr/>
         </p:nvSpPr>
         <p:spPr>
           <a:xfrm>
-            <a:off x="5029200" y="2194560"/>
-            <a:ext cx="274320" cy="274320"/>
+            <a:off x="4507992" y="2953512"/>
+            <a:ext cx="219456" cy="219456"/>
           </a:xfrm>
           <a:prstGeom prst="ellipse">
             <a:avLst/>
@@ -3411,30 +3429,30 @@
       </p:sp>
       <p:sp>
         <p:nvSpPr>
-          <p:cNvPr id="15" name="Text 13"/>
-          <p:cNvSpPr txBox="1"/>
-          <p:nvPr/>
-        </p:nvSpPr>
-        <p:spPr>
-          <a:xfrm>
-            <a:off x="4572000" y="1600200"/>
-            <a:ext cx="1188720" cy="457200"/>
-          </a:xfrm>
-          <a:prstGeom prst="rect">
-            <a:avLst/>
-          </a:prstGeom>
-          <a:noFill/>
-          <a:ln/>
-        </p:spPr>
-        <p:txBody>
-          <a:bodyPr wrap="square" lIns="0" tIns="0" rIns="0" bIns="0" rtlCol="0" anchor="ctr"/>
-          <a:lstStyle/>
-          <a:p>
-            <a:pPr algn="ctr" indent="0" marL="0">
-              <a:buNone/>
-            </a:pPr>
-            <a:r>
-              <a:rPr lang="en-US" sz="2200" b="1" dirty="0">
+          <p:cNvPr id="18" name="Text 15"/>
+          <p:cNvSpPr txBox="1"/>
+          <p:nvPr/>
+        </p:nvSpPr>
+        <p:spPr>
+          <a:xfrm>
+            <a:off x="4892040" y="2825496"/>
+            <a:ext cx="822960" cy="475488"/>
+          </a:xfrm>
+          <a:prstGeom prst="rect">
+            <a:avLst/>
+          </a:prstGeom>
+          <a:noFill/>
+          <a:ln/>
+        </p:spPr>
+        <p:txBody>
+          <a:bodyPr wrap="square" lIns="0" tIns="0" rIns="0" bIns="0" rtlCol="0" anchor="ctr"/>
+          <a:lstStyle/>
+          <a:p>
+            <a:pPr indent="0" marL="0">
+              <a:buNone/>
+            </a:pPr>
+            <a:r>
+              <a:rPr lang="en-US" sz="1700" b="1" dirty="0">
                 <a:solidFill>
                   <a:srgbClr val="1E2023"/>
                 </a:solidFill>
@@ -3444,36 +3462,36 @@
               </a:rPr>
               <a:t>2022</a:t>
             </a:r>
-            <a:endParaRPr lang="en-US" sz="2200" dirty="0"/>
-          </a:p>
-        </p:txBody>
-      </p:sp>
-      <p:sp>
-        <p:nvSpPr>
-          <p:cNvPr id="16" name="Text 14"/>
-          <p:cNvSpPr txBox="1"/>
-          <p:nvPr/>
-        </p:nvSpPr>
-        <p:spPr>
-          <a:xfrm>
-            <a:off x="4526280" y="2697480"/>
-            <a:ext cx="1280160" cy="1737360"/>
-          </a:xfrm>
-          <a:prstGeom prst="rect">
-            <a:avLst/>
-          </a:prstGeom>
-          <a:noFill/>
-          <a:ln/>
-        </p:spPr>
-        <p:txBody>
-          <a:bodyPr wrap="square" lIns="0" tIns="0" rIns="0" bIns="0" rtlCol="0" anchor="t"/>
-          <a:lstStyle/>
-          <a:p>
-            <a:pPr algn="ctr" indent="0" marL="0">
-              <a:buNone/>
-            </a:pPr>
-            <a:r>
-              <a:rPr lang="en-US" sz="1100" dirty="0">
+            <a:endParaRPr lang="en-US" sz="1700" dirty="0"/>
+          </a:p>
+        </p:txBody>
+      </p:sp>
+      <p:sp>
+        <p:nvSpPr>
+          <p:cNvPr id="19" name="Text 16"/>
+          <p:cNvSpPr txBox="1"/>
+          <p:nvPr/>
+        </p:nvSpPr>
+        <p:spPr>
+          <a:xfrm>
+            <a:off x="5715000" y="2825496"/>
+            <a:ext cx="3017520" cy="475488"/>
+          </a:xfrm>
+          <a:prstGeom prst="rect">
+            <a:avLst/>
+          </a:prstGeom>
+          <a:noFill/>
+          <a:ln/>
+        </p:spPr>
+        <p:txBody>
+          <a:bodyPr wrap="square" lIns="0" tIns="0" rIns="0" bIns="0" rtlCol="0" anchor="ctr"/>
+          <a:lstStyle/>
+          <a:p>
+            <a:pPr indent="0" marL="0">
+              <a:buNone/>
+            </a:pPr>
+            <a:r>
+              <a:rPr lang="en-US" sz="1050" dirty="0">
                 <a:solidFill>
                   <a:srgbClr val="3A3D41"/>
                 </a:solidFill>
@@ -3483,20 +3501,20 @@
               </a:rPr>
               <a:t>Desarrolla los camiones de competición “La Bestia” y “La Furia”</a:t>
             </a:r>
-            <a:endParaRPr lang="en-US" sz="1100" dirty="0"/>
-          </a:p>
-        </p:txBody>
-      </p:sp>
-      <p:sp>
-        <p:nvSpPr>
-          <p:cNvPr id="17" name="Shape 15"/>
+            <a:endParaRPr lang="en-US" sz="1050" dirty="0"/>
+          </a:p>
+        </p:txBody>
+      </p:sp>
+      <p:sp>
+        <p:nvSpPr>
+          <p:cNvPr id="20" name="Shape 17"/>
           <p:cNvSpPr/>
           <p:nvPr/>
         </p:nvSpPr>
         <p:spPr>
           <a:xfrm>
-            <a:off x="6400800" y="2194560"/>
-            <a:ext cx="274320" cy="274320"/>
+            <a:off x="4507992" y="3529584"/>
+            <a:ext cx="219456" cy="219456"/>
           </a:xfrm>
           <a:prstGeom prst="ellipse">
             <a:avLst/>
@@ -3514,30 +3532,30 @@
       </p:sp>
       <p:sp>
         <p:nvSpPr>
-          <p:cNvPr id="18" name="Text 16"/>
-          <p:cNvSpPr txBox="1"/>
-          <p:nvPr/>
-        </p:nvSpPr>
-        <p:spPr>
-          <a:xfrm>
-            <a:off x="5943600" y="1600200"/>
-            <a:ext cx="1188720" cy="457200"/>
-          </a:xfrm>
-          <a:prstGeom prst="rect">
-            <a:avLst/>
-          </a:prstGeom>
-          <a:noFill/>
-          <a:ln/>
-        </p:spPr>
-        <p:txBody>
-          <a:bodyPr wrap="square" lIns="0" tIns="0" rIns="0" bIns="0" rtlCol="0" anchor="ctr"/>
-          <a:lstStyle/>
-          <a:p>
-            <a:pPr algn="ctr" indent="0" marL="0">
-              <a:buNone/>
-            </a:pPr>
-            <a:r>
-              <a:rPr lang="en-US" sz="2200" b="1" dirty="0">
+          <p:cNvPr id="21" name="Text 18"/>
+          <p:cNvSpPr txBox="1"/>
+          <p:nvPr/>
+        </p:nvSpPr>
+        <p:spPr>
+          <a:xfrm>
+            <a:off x="4892040" y="3401568"/>
+            <a:ext cx="822960" cy="475488"/>
+          </a:xfrm>
+          <a:prstGeom prst="rect">
+            <a:avLst/>
+          </a:prstGeom>
+          <a:noFill/>
+          <a:ln/>
+        </p:spPr>
+        <p:txBody>
+          <a:bodyPr wrap="square" lIns="0" tIns="0" rIns="0" bIns="0" rtlCol="0" anchor="ctr"/>
+          <a:lstStyle/>
+          <a:p>
+            <a:pPr indent="0" marL="0">
+              <a:buNone/>
+            </a:pPr>
+            <a:r>
+              <a:rPr lang="en-US" sz="1700" b="1" dirty="0">
                 <a:solidFill>
                   <a:srgbClr val="1E2023"/>
                 </a:solidFill>
@@ -3547,36 +3565,36 @@
               </a:rPr>
               <a:t>2023</a:t>
             </a:r>
-            <a:endParaRPr lang="en-US" sz="2200" dirty="0"/>
-          </a:p>
-        </p:txBody>
-      </p:sp>
-      <p:sp>
-        <p:nvSpPr>
-          <p:cNvPr id="19" name="Text 17"/>
-          <p:cNvSpPr txBox="1"/>
-          <p:nvPr/>
-        </p:nvSpPr>
-        <p:spPr>
-          <a:xfrm>
-            <a:off x="5897880" y="2697480"/>
-            <a:ext cx="1280160" cy="1737360"/>
-          </a:xfrm>
-          <a:prstGeom prst="rect">
-            <a:avLst/>
-          </a:prstGeom>
-          <a:noFill/>
-          <a:ln/>
-        </p:spPr>
-        <p:txBody>
-          <a:bodyPr wrap="square" lIns="0" tIns="0" rIns="0" bIns="0" rtlCol="0" anchor="t"/>
-          <a:lstStyle/>
-          <a:p>
-            <a:pPr algn="ctr" indent="0" marL="0">
-              <a:buNone/>
-            </a:pPr>
-            <a:r>
-              <a:rPr lang="en-US" sz="1100" dirty="0">
+            <a:endParaRPr lang="en-US" sz="1700" dirty="0"/>
+          </a:p>
+        </p:txBody>
+      </p:sp>
+      <p:sp>
+        <p:nvSpPr>
+          <p:cNvPr id="22" name="Text 19"/>
+          <p:cNvSpPr txBox="1"/>
+          <p:nvPr/>
+        </p:nvSpPr>
+        <p:spPr>
+          <a:xfrm>
+            <a:off x="5715000" y="3401568"/>
+            <a:ext cx="3017520" cy="475488"/>
+          </a:xfrm>
+          <a:prstGeom prst="rect">
+            <a:avLst/>
+          </a:prstGeom>
+          <a:noFill/>
+          <a:ln/>
+        </p:spPr>
+        <p:txBody>
+          <a:bodyPr wrap="square" lIns="0" tIns="0" rIns="0" bIns="0" rtlCol="0" anchor="ctr"/>
+          <a:lstStyle/>
+          <a:p>
+            <a:pPr indent="0" marL="0">
+              <a:buNone/>
+            </a:pPr>
+            <a:r>
+              <a:rPr lang="en-US" sz="1050" dirty="0">
                 <a:solidFill>
                   <a:srgbClr val="3A3D41"/>
                 </a:solidFill>
@@ -3586,20 +3604,20 @@
               </a:rPr>
               <a:t>Abre la unidad de Campo 9, sobre la Ruta PY 02</a:t>
             </a:r>
-            <a:endParaRPr lang="en-US" sz="1100" dirty="0"/>
-          </a:p>
-        </p:txBody>
-      </p:sp>
-      <p:sp>
-        <p:nvSpPr>
-          <p:cNvPr id="20" name="Shape 18"/>
+            <a:endParaRPr lang="en-US" sz="1050" dirty="0"/>
+          </a:p>
+        </p:txBody>
+      </p:sp>
+      <p:sp>
+        <p:nvSpPr>
+          <p:cNvPr id="23" name="Shape 20"/>
           <p:cNvSpPr/>
           <p:nvPr/>
         </p:nvSpPr>
         <p:spPr>
           <a:xfrm>
-            <a:off x="7772400" y="2194560"/>
-            <a:ext cx="274320" cy="274320"/>
+            <a:off x="4507992" y="4105656"/>
+            <a:ext cx="219456" cy="219456"/>
           </a:xfrm>
           <a:prstGeom prst="ellipse">
             <a:avLst/>
@@ -3617,30 +3635,30 @@
       </p:sp>
       <p:sp>
         <p:nvSpPr>
-          <p:cNvPr id="21" name="Text 19"/>
-          <p:cNvSpPr txBox="1"/>
-          <p:nvPr/>
-        </p:nvSpPr>
-        <p:spPr>
-          <a:xfrm>
-            <a:off x="7315200" y="1600200"/>
-            <a:ext cx="1188720" cy="457200"/>
-          </a:xfrm>
-          <a:prstGeom prst="rect">
-            <a:avLst/>
-          </a:prstGeom>
-          <a:noFill/>
-          <a:ln/>
-        </p:spPr>
-        <p:txBody>
-          <a:bodyPr wrap="square" lIns="0" tIns="0" rIns="0" bIns="0" rtlCol="0" anchor="ctr"/>
-          <a:lstStyle/>
-          <a:p>
-            <a:pPr algn="ctr" indent="0" marL="0">
-              <a:buNone/>
-            </a:pPr>
-            <a:r>
-              <a:rPr lang="en-US" sz="2200" b="1" dirty="0">
+          <p:cNvPr id="24" name="Text 21"/>
+          <p:cNvSpPr txBox="1"/>
+          <p:nvPr/>
+        </p:nvSpPr>
+        <p:spPr>
+          <a:xfrm>
+            <a:off x="4892040" y="3977640"/>
+            <a:ext cx="822960" cy="475488"/>
+          </a:xfrm>
+          <a:prstGeom prst="rect">
+            <a:avLst/>
+          </a:prstGeom>
+          <a:noFill/>
+          <a:ln/>
+        </p:spPr>
+        <p:txBody>
+          <a:bodyPr wrap="square" lIns="0" tIns="0" rIns="0" bIns="0" rtlCol="0" anchor="ctr"/>
+          <a:lstStyle/>
+          <a:p>
+            <a:pPr indent="0" marL="0">
+              <a:buNone/>
+            </a:pPr>
+            <a:r>
+              <a:rPr lang="en-US" sz="1700" b="1" dirty="0">
                 <a:solidFill>
                   <a:srgbClr val="E5323B"/>
                 </a:solidFill>
@@ -3650,36 +3668,36 @@
               </a:rPr>
               <a:t>2026</a:t>
             </a:r>
-            <a:endParaRPr lang="en-US" sz="2200" dirty="0"/>
-          </a:p>
-        </p:txBody>
-      </p:sp>
-      <p:sp>
-        <p:nvSpPr>
-          <p:cNvPr id="22" name="Text 20"/>
-          <p:cNvSpPr txBox="1"/>
-          <p:nvPr/>
-        </p:nvSpPr>
-        <p:spPr>
-          <a:xfrm>
-            <a:off x="7269480" y="2697480"/>
-            <a:ext cx="1280160" cy="1737360"/>
-          </a:xfrm>
-          <a:prstGeom prst="rect">
-            <a:avLst/>
-          </a:prstGeom>
-          <a:noFill/>
-          <a:ln/>
-        </p:spPr>
-        <p:txBody>
-          <a:bodyPr wrap="square" lIns="0" tIns="0" rIns="0" bIns="0" rtlCol="0" anchor="t"/>
-          <a:lstStyle/>
-          <a:p>
-            <a:pPr algn="ctr" indent="0" marL="0">
-              <a:buNone/>
-            </a:pPr>
-            <a:r>
-              <a:rPr lang="en-US" sz="1100" dirty="0">
+            <a:endParaRPr lang="en-US" sz="1700" dirty="0"/>
+          </a:p>
+        </p:txBody>
+      </p:sp>
+      <p:sp>
+        <p:nvSpPr>
+          <p:cNvPr id="25" name="Text 22"/>
+          <p:cNvSpPr txBox="1"/>
+          <p:nvPr/>
+        </p:nvSpPr>
+        <p:spPr>
+          <a:xfrm>
+            <a:off x="5715000" y="3977640"/>
+            <a:ext cx="3017520" cy="475488"/>
+          </a:xfrm>
+          <a:prstGeom prst="rect">
+            <a:avLst/>
+          </a:prstGeom>
+          <a:noFill/>
+          <a:ln/>
+        </p:spPr>
+        <p:txBody>
+          <a:bodyPr wrap="square" lIns="0" tIns="0" rIns="0" bIns="0" rtlCol="0" anchor="ctr"/>
+          <a:lstStyle/>
+          <a:p>
+            <a:pPr indent="0" marL="0">
+              <a:buNone/>
+            </a:pPr>
+            <a:r>
+              <a:rPr lang="en-US" sz="1050" dirty="0">
                 <a:solidFill>
                   <a:srgbClr val="3A3D41"/>
                 </a:solidFill>
@@ -3687,15 +3705,15 @@
                 <a:ea typeface="Calibri" pitchFamily="34" charset="-122"/>
                 <a:cs typeface="Calibri" pitchFamily="34" charset="-120"/>
               </a:rPr>
-              <a:t>Se adecúa a la Ley 7572/2025 y pasa a ser Sociedad Anónima Emisora</a:t>
-            </a:r>
-            <a:endParaRPr lang="en-US" sz="1100" dirty="0"/>
-          </a:p>
-        </p:txBody>
-      </p:sp>
-      <p:sp>
-        <p:nvSpPr>
-          <p:cNvPr id="23" name="Text 21"/>
+              <a:t>Se adecúa a la Ley 7572/2025: Sociedad Anónima Emisora</a:t>
+            </a:r>
+            <a:endParaRPr lang="en-US" sz="1050" dirty="0"/>
+          </a:p>
+        </p:txBody>
+      </p:sp>
+      <p:sp>
+        <p:nvSpPr>
+          <p:cNvPr id="26" name="Text 23"/>
           <p:cNvSpPr txBox="1"/>
           <p:nvPr/>
         </p:nvSpPr>
@@ -3734,7 +3752,7 @@
       </p:sp>
       <p:sp>
         <p:nvSpPr>
-          <p:cNvPr id="24" name="Text 22"/>
+          <p:cNvPr id="27" name="Text 24"/>
           <p:cNvSpPr txBox="1"/>
           <p:nvPr/>
         </p:nvSpPr>
@@ -3836,7 +3854,7 @@
                 <a:ea typeface="Cambria" pitchFamily="34" charset="-122"/>
                 <a:cs typeface="Cambria" pitchFamily="34" charset="-120"/>
               </a:rPr>
-              <a:t>Propósito y filosofía</a:t>
+              <a:t>Productos y servicios</a:t>
             </a:r>
             <a:endParaRPr lang="en-US" sz="3000" dirty="0"/>
           </a:p>
@@ -3844,18 +3862,57 @@
       </p:sp>
       <p:sp>
         <p:nvSpPr>
-          <p:cNvPr id="3" name="Shape 1"/>
+          <p:cNvPr id="3" name="Text 1"/>
+          <p:cNvSpPr txBox="1"/>
+          <p:nvPr/>
+        </p:nvSpPr>
+        <p:spPr>
+          <a:xfrm>
+            <a:off x="457200" y="932688"/>
+            <a:ext cx="7315200" cy="274320"/>
+          </a:xfrm>
+          <a:prstGeom prst="rect">
+            <a:avLst/>
+          </a:prstGeom>
+          <a:noFill/>
+          <a:ln/>
+        </p:spPr>
+        <p:txBody>
+          <a:bodyPr wrap="square" lIns="0" tIns="0" rIns="0" bIns="0" rtlCol="0" anchor="ctr"/>
+          <a:lstStyle/>
+          <a:p>
+            <a:pPr indent="0" marL="0">
+              <a:buNone/>
+            </a:pPr>
+            <a:r>
+              <a:rPr lang="en-US" sz="1200" dirty="0">
+                <a:solidFill>
+                  <a:srgbClr val="B8BBBF"/>
+                </a:solidFill>
+                <a:latin typeface="Calibri" pitchFamily="34" charset="0"/>
+                <a:ea typeface="Calibri" pitchFamily="34" charset="-122"/>
+                <a:cs typeface="Calibri" pitchFamily="34" charset="-120"/>
+              </a:rPr>
+              <a:t>Todo lo que el transporte pesado y el agro necesitan, en un solo lugar</a:t>
+            </a:r>
+            <a:endParaRPr lang="en-US" sz="1200" dirty="0"/>
+          </a:p>
+        </p:txBody>
+      </p:sp>
+      <p:sp>
+        <p:nvSpPr>
+          <p:cNvPr id="4" name="Shape 2"/>
           <p:cNvSpPr/>
           <p:nvPr/>
         </p:nvSpPr>
         <p:spPr>
           <a:xfrm>
-            <a:off x="457200" y="1234440"/>
-            <a:ext cx="3931920" cy="2011680"/>
+            <a:off x="457200" y="1417320"/>
+            <a:ext cx="4023360" cy="1417320"/>
           </a:xfrm>
           <a:prstGeom prst="roundRect">
             <a:avLst>
-              <a:gd name="adj" fmla="val 4545"/>
+              <a:gd name="adj" fmla="val 6452"/>
             </a:avLst>
           </a:prstGeom>
           <a:solidFill>
@@ -3866,53 +3923,112 @@
       </p:sp>
       <p:sp>
         <p:nvSpPr>
-          <p:cNvPr id="4" name="Text 2"/>
-          <p:cNvSpPr txBox="1"/>
-          <p:nvPr/>
-        </p:nvSpPr>
-        <p:spPr>
-          <a:xfrm>
-            <a:off x="731520" y="1417320"/>
-            <a:ext cx="3383280" cy="274320"/>
-          </a:xfrm>
-          <a:prstGeom prst="rect">
-            <a:avLst/>
-          </a:prstGeom>
-          <a:noFill/>
-          <a:ln/>
-        </p:spPr>
-        <p:txBody>
-          <a:bodyPr wrap="square" lIns="0" tIns="0" rIns="0" bIns="0" rtlCol="0" anchor="ctr"/>
-          <a:lstStyle/>
-          <a:p>
-            <a:pPr indent="0" marL="0">
-              <a:buNone/>
-            </a:pPr>
-            <a:r>
-              <a:rPr lang="en-US" sz="1200" b="1" spc="300" kern="0" dirty="0">
-                <a:solidFill>
-                  <a:srgbClr val="E5323B"/>
-                </a:solidFill>
-                <a:latin typeface="Calibri" pitchFamily="34" charset="0"/>
-                <a:ea typeface="Calibri" pitchFamily="34" charset="-122"/>
-                <a:cs typeface="Calibri" pitchFamily="34" charset="-120"/>
-              </a:rPr>
-              <a:t>MISIÓN</a:t>
-            </a:r>
-            <a:endParaRPr lang="en-US" sz="1200" dirty="0"/>
-          </a:p>
-        </p:txBody>
-      </p:sp>
-      <p:sp>
-        <p:nvSpPr>
-          <p:cNvPr id="5" name="Text 3"/>
-          <p:cNvSpPr txBox="1"/>
-          <p:nvPr/>
-        </p:nvSpPr>
-        <p:spPr>
-          <a:xfrm>
-            <a:off x="731520" y="1783080"/>
-            <a:ext cx="3383280" cy="1371600"/>
+          <p:cNvPr id="5" name="Shape 3"/>
+          <p:cNvSpPr/>
+          <p:nvPr/>
+        </p:nvSpPr>
+        <p:spPr>
+          <a:xfrm>
+            <a:off x="685800" y="1645920"/>
+            <a:ext cx="640080" cy="640080"/>
+          </a:xfrm>
+          <a:prstGeom prst="ellipse">
+            <a:avLst/>
+          </a:prstGeom>
+          <a:solidFill>
+            <a:srgbClr val="E5323B"/>
+          </a:solidFill>
+          <a:ln/>
+        </p:spPr>
+      </p:sp>
+      <p:sp>
+        <p:nvSpPr>
+          <p:cNvPr id="6" name="Text 4"/>
+          <p:cNvSpPr txBox="1"/>
+          <p:nvPr/>
+        </p:nvSpPr>
+        <p:spPr>
+          <a:xfrm>
+            <a:off x="685800" y="1645920"/>
+            <a:ext cx="640080" cy="640080"/>
+          </a:xfrm>
+          <a:prstGeom prst="rect">
+            <a:avLst/>
+          </a:prstGeom>
+          <a:noFill/>
+          <a:ln/>
+        </p:spPr>
+        <p:txBody>
+          <a:bodyPr wrap="square" lIns="0" tIns="0" rIns="0" bIns="0" rtlCol="0" anchor="ctr"/>
+          <a:lstStyle/>
+          <a:p>
+            <a:pPr algn="ctr" indent="0" marL="0">
+              <a:buNone/>
+            </a:pPr>
+            <a:r>
+              <a:rPr lang="en-US" sz="1800" b="1" dirty="0">
+                <a:solidFill>
+                  <a:srgbClr val="FFFFFF"/>
+                </a:solidFill>
+                <a:latin typeface="Cambria" pitchFamily="34" charset="0"/>
+                <a:ea typeface="Cambria" pitchFamily="34" charset="-122"/>
+                <a:cs typeface="Cambria" pitchFamily="34" charset="-120"/>
+              </a:rPr>
+              <a:t>01</a:t>
+            </a:r>
+            <a:endParaRPr lang="en-US" sz="1800" dirty="0"/>
+          </a:p>
+        </p:txBody>
+      </p:sp>
+      <p:sp>
+        <p:nvSpPr>
+          <p:cNvPr id="7" name="Text 5"/>
+          <p:cNvSpPr txBox="1"/>
+          <p:nvPr/>
+        </p:nvSpPr>
+        <p:spPr>
+          <a:xfrm>
+            <a:off x="1508760" y="1600200"/>
+            <a:ext cx="2743200" cy="320040"/>
+          </a:xfrm>
+          <a:prstGeom prst="rect">
+            <a:avLst/>
+          </a:prstGeom>
+          <a:noFill/>
+          <a:ln/>
+        </p:spPr>
+        <p:txBody>
+          <a:bodyPr wrap="square" lIns="0" tIns="0" rIns="0" bIns="0" rtlCol="0" anchor="ctr"/>
+          <a:lstStyle/>
+          <a:p>
+            <a:pPr indent="0" marL="0">
+              <a:buNone/>
+            </a:pPr>
+            <a:r>
+              <a:rPr lang="en-US" sz="1500" b="1" dirty="0">
+                <a:solidFill>
+                  <a:srgbClr val="FFFFFF"/>
+                </a:solidFill>
+                <a:latin typeface="Cambria" pitchFamily="34" charset="0"/>
+                <a:ea typeface="Cambria" pitchFamily="34" charset="-122"/>
+                <a:cs typeface="Cambria" pitchFamily="34" charset="-120"/>
+              </a:rPr>
+              <a:t>Repuestos nuevos</a:t>
+            </a:r>
+            <a:endParaRPr lang="en-US" sz="1500" dirty="0"/>
+          </a:p>
+        </p:txBody>
+      </p:sp>
+      <p:sp>
+        <p:nvSpPr>
+          <p:cNvPr id="8" name="Text 6"/>
+          <p:cNvSpPr txBox="1"/>
+          <p:nvPr/>
+        </p:nvSpPr>
+        <p:spPr>
+          <a:xfrm>
+            <a:off x="1508760" y="1947672"/>
+            <a:ext cx="2788920" cy="822960"/>
           </a:xfrm>
           <a:prstGeom prst="rect">
             <a:avLst/>
@@ -3928,34 +4044,34 @@
               <a:buNone/>
             </a:pPr>
             <a:r>
-              <a:rPr lang="en-US" sz="1400" dirty="0">
-                <a:solidFill>
-                  <a:srgbClr val="FFFFFF"/>
-                </a:solidFill>
-                <a:latin typeface="Calibri" pitchFamily="34" charset="0"/>
-                <a:ea typeface="Calibri" pitchFamily="34" charset="-122"/>
-                <a:cs typeface="Calibri" pitchFamily="34" charset="-120"/>
-              </a:rPr>
-              <a:t>Proveer repuestos, componentes y servicios técnicos para mantener operativos los vehículos de transporte pesado y la maquinaria agrícola de nuestros clientes.</a:t>
-            </a:r>
-            <a:endParaRPr lang="en-US" sz="1400" dirty="0"/>
-          </a:p>
-        </p:txBody>
-      </p:sp>
-      <p:sp>
-        <p:nvSpPr>
-          <p:cNvPr id="6" name="Shape 4"/>
+              <a:rPr lang="en-US" sz="1050" dirty="0">
+                <a:solidFill>
+                  <a:srgbClr val="D5D7DA"/>
+                </a:solidFill>
+                <a:latin typeface="Calibri" pitchFamily="34" charset="0"/>
+                <a:ea typeface="Calibri" pitchFamily="34" charset="-122"/>
+                <a:cs typeface="Calibri" pitchFamily="34" charset="-120"/>
+              </a:rPr>
+              <a:t>Motor, transmisión, cabina y carrocería, frenos y sistema eléctrico. Fuerte especialización en Scania.</a:t>
+            </a:r>
+            <a:endParaRPr lang="en-US" sz="1050" dirty="0"/>
+          </a:p>
+        </p:txBody>
+      </p:sp>
+      <p:sp>
+        <p:nvSpPr>
+          <p:cNvPr id="9" name="Shape 7"/>
           <p:cNvSpPr/>
           <p:nvPr/>
         </p:nvSpPr>
         <p:spPr>
           <a:xfrm>
-            <a:off x="4663440" y="1234440"/>
-            <a:ext cx="3931920" cy="2011680"/>
+            <a:off x="4663440" y="1417320"/>
+            <a:ext cx="4023360" cy="1417320"/>
           </a:xfrm>
           <a:prstGeom prst="roundRect">
             <a:avLst>
-              <a:gd name="adj" fmla="val 4545"/>
+              <a:gd name="adj" fmla="val 6452"/>
             </a:avLst>
           </a:prstGeom>
           <a:solidFill>
@@ -3966,97 +4082,17 @@
       </p:sp>
       <p:sp>
         <p:nvSpPr>
-          <p:cNvPr id="7" name="Text 5"/>
-          <p:cNvSpPr txBox="1"/>
-          <p:nvPr/>
-        </p:nvSpPr>
-        <p:spPr>
-          <a:xfrm>
-            <a:off x="4937760" y="1417320"/>
-            <a:ext cx="3383280" cy="274320"/>
-          </a:xfrm>
-          <a:prstGeom prst="rect">
-            <a:avLst/>
-          </a:prstGeom>
-          <a:noFill/>
-          <a:ln/>
-        </p:spPr>
-        <p:txBody>
-          <a:bodyPr wrap="square" lIns="0" tIns="0" rIns="0" bIns="0" rtlCol="0" anchor="ctr"/>
-          <a:lstStyle/>
-          <a:p>
-            <a:pPr indent="0" marL="0">
-              <a:buNone/>
-            </a:pPr>
-            <a:r>
-              <a:rPr lang="en-US" sz="1200" b="1" spc="300" kern="0" dirty="0">
-                <a:solidFill>
-                  <a:srgbClr val="E5323B"/>
-                </a:solidFill>
-                <a:latin typeface="Calibri" pitchFamily="34" charset="0"/>
-                <a:ea typeface="Calibri" pitchFamily="34" charset="-122"/>
-                <a:cs typeface="Calibri" pitchFamily="34" charset="-120"/>
-              </a:rPr>
-              <a:t>VISIÓN</a:t>
-            </a:r>
-            <a:endParaRPr lang="en-US" sz="1200" dirty="0"/>
-          </a:p>
-        </p:txBody>
-      </p:sp>
-      <p:sp>
-        <p:nvSpPr>
-          <p:cNvPr id="8" name="Text 6"/>
-          <p:cNvSpPr txBox="1"/>
-          <p:nvPr/>
-        </p:nvSpPr>
-        <p:spPr>
-          <a:xfrm>
-            <a:off x="4937760" y="1783080"/>
-            <a:ext cx="3383280" cy="1371600"/>
-          </a:xfrm>
-          <a:prstGeom prst="rect">
-            <a:avLst/>
-          </a:prstGeom>
-          <a:noFill/>
-          <a:ln/>
-        </p:spPr>
-        <p:txBody>
-          <a:bodyPr wrap="square" lIns="0" tIns="0" rIns="0" bIns="0" rtlCol="0" anchor="t"/>
-          <a:lstStyle/>
-          <a:p>
-            <a:pPr indent="0" marL="0">
-              <a:buNone/>
-            </a:pPr>
-            <a:r>
-              <a:rPr lang="en-US" sz="1400" dirty="0">
-                <a:solidFill>
-                  <a:srgbClr val="FFFFFF"/>
-                </a:solidFill>
-                <a:latin typeface="Calibri" pitchFamily="34" charset="0"/>
-                <a:ea typeface="Calibri" pitchFamily="34" charset="-122"/>
-                <a:cs typeface="Calibri" pitchFamily="34" charset="-120"/>
-              </a:rPr>
-              <a:t>Ser referente en Paraguay en repuestos y soluciones técnicas para el transporte pesado y el agro, reconocida por su confiabilidad y cercanía.</a:t>
-            </a:r>
-            <a:endParaRPr lang="en-US" sz="1400" dirty="0"/>
-          </a:p>
-        </p:txBody>
-      </p:sp>
-      <p:sp>
-        <p:nvSpPr>
-          <p:cNvPr id="9" name="Shape 7"/>
+          <p:cNvPr id="10" name="Shape 8"/>
           <p:cNvSpPr/>
           <p:nvPr/>
         </p:nvSpPr>
         <p:spPr>
           <a:xfrm>
-            <a:off x="457200" y="3474720"/>
-            <a:ext cx="8229600" cy="1005840"/>
-          </a:xfrm>
-          <a:prstGeom prst="roundRect">
-            <a:avLst>
-              <a:gd name="adj" fmla="val 9091"/>
-            </a:avLst>
+            <a:off x="4892040" y="1645920"/>
+            <a:ext cx="640080" cy="640080"/>
+          </a:xfrm>
+          <a:prstGeom prst="ellipse">
+            <a:avLst/>
           </a:prstGeom>
           <a:solidFill>
             <a:srgbClr val="E5323B"/>
@@ -4066,30 +4102,30 @@
       </p:sp>
       <p:sp>
         <p:nvSpPr>
-          <p:cNvPr id="10" name="Text 8"/>
-          <p:cNvSpPr txBox="1"/>
-          <p:nvPr/>
-        </p:nvSpPr>
-        <p:spPr>
-          <a:xfrm>
-            <a:off x="731520" y="3520440"/>
-            <a:ext cx="7680960" cy="914400"/>
-          </a:xfrm>
-          <a:prstGeom prst="rect">
-            <a:avLst/>
-          </a:prstGeom>
-          <a:noFill/>
-          <a:ln/>
-        </p:spPr>
-        <p:txBody>
-          <a:bodyPr wrap="square" lIns="0" tIns="0" rIns="0" bIns="0" rtlCol="0" anchor="ctr"/>
-          <a:lstStyle/>
-          <a:p>
-            <a:pPr indent="0" marL="0">
-              <a:buNone/>
-            </a:pPr>
-            <a:r>
-              <a:rPr lang="en-US" sz="1600" i="1" dirty="0">
+          <p:cNvPr id="11" name="Text 9"/>
+          <p:cNvSpPr txBox="1"/>
+          <p:nvPr/>
+        </p:nvSpPr>
+        <p:spPr>
+          <a:xfrm>
+            <a:off x="4892040" y="1645920"/>
+            <a:ext cx="640080" cy="640080"/>
+          </a:xfrm>
+          <a:prstGeom prst="rect">
+            <a:avLst/>
+          </a:prstGeom>
+          <a:noFill/>
+          <a:ln/>
+        </p:spPr>
+        <p:txBody>
+          <a:bodyPr wrap="square" lIns="0" tIns="0" rIns="0" bIns="0" rtlCol="0" anchor="ctr"/>
+          <a:lstStyle/>
+          <a:p>
+            <a:pPr algn="ctr" indent="0" marL="0">
+              <a:buNone/>
+            </a:pPr>
+            <a:r>
+              <a:rPr lang="en-US" sz="1800" b="1" dirty="0">
                 <a:solidFill>
                   <a:srgbClr val="FFFFFF"/>
                 </a:solidFill>
@@ -4097,15 +4133,411 @@
                 <a:ea typeface="Cambria" pitchFamily="34" charset="-122"/>
                 <a:cs typeface="Cambria" pitchFamily="34" charset="-120"/>
               </a:rPr>
-              <a:t>“Un vehículo detenido es actividad económica detenida. Nuestro foco es reducir el tiempo de inactividad de cada cliente.”</a:t>
-            </a:r>
-            <a:endParaRPr lang="en-US" sz="1600" dirty="0"/>
-          </a:p>
-        </p:txBody>
-      </p:sp>
-      <p:sp>
-        <p:nvSpPr>
-          <p:cNvPr id="11" name="Text 9"/>
+              <a:t>02</a:t>
+            </a:r>
+            <a:endParaRPr lang="en-US" sz="1800" dirty="0"/>
+          </a:p>
+        </p:txBody>
+      </p:sp>
+      <p:sp>
+        <p:nvSpPr>
+          <p:cNvPr id="12" name="Text 10"/>
+          <p:cNvSpPr txBox="1"/>
+          <p:nvPr/>
+        </p:nvSpPr>
+        <p:spPr>
+          <a:xfrm>
+            <a:off x="5715000" y="1600200"/>
+            <a:ext cx="2743200" cy="320040"/>
+          </a:xfrm>
+          <a:prstGeom prst="rect">
+            <a:avLst/>
+          </a:prstGeom>
+          <a:noFill/>
+          <a:ln/>
+        </p:spPr>
+        <p:txBody>
+          <a:bodyPr wrap="square" lIns="0" tIns="0" rIns="0" bIns="0" rtlCol="0" anchor="ctr"/>
+          <a:lstStyle/>
+          <a:p>
+            <a:pPr indent="0" marL="0">
+              <a:buNone/>
+            </a:pPr>
+            <a:r>
+              <a:rPr lang="en-US" sz="1500" b="1" dirty="0">
+                <a:solidFill>
+                  <a:srgbClr val="FFFFFF"/>
+                </a:solidFill>
+                <a:latin typeface="Cambria" pitchFamily="34" charset="0"/>
+                <a:ea typeface="Cambria" pitchFamily="34" charset="-122"/>
+                <a:cs typeface="Cambria" pitchFamily="34" charset="-120"/>
+              </a:rPr>
+              <a:t>Piezas reconstruidas</a:t>
+            </a:r>
+            <a:endParaRPr lang="en-US" sz="1500" dirty="0"/>
+          </a:p>
+        </p:txBody>
+      </p:sp>
+      <p:sp>
+        <p:nvSpPr>
+          <p:cNvPr id="13" name="Text 11"/>
+          <p:cNvSpPr txBox="1"/>
+          <p:nvPr/>
+        </p:nvSpPr>
+        <p:spPr>
+          <a:xfrm>
+            <a:off x="5715000" y="1947672"/>
+            <a:ext cx="2788920" cy="822960"/>
+          </a:xfrm>
+          <a:prstGeom prst="rect">
+            <a:avLst/>
+          </a:prstGeom>
+          <a:noFill/>
+          <a:ln/>
+        </p:spPr>
+        <p:txBody>
+          <a:bodyPr wrap="square" lIns="0" tIns="0" rIns="0" bIns="0" rtlCol="0" anchor="t"/>
+          <a:lstStyle/>
+          <a:p>
+            <a:pPr indent="0" marL="0">
+              <a:buNone/>
+            </a:pPr>
+            <a:r>
+              <a:rPr lang="en-US" sz="1050" dirty="0">
+                <a:solidFill>
+                  <a:srgbClr val="D5D7DA"/>
+                </a:solidFill>
+                <a:latin typeface="Calibri" pitchFamily="34" charset="0"/>
+                <a:ea typeface="Calibri" pitchFamily="34" charset="-122"/>
+                <a:cs typeface="Calibri" pitchFamily="34" charset="-120"/>
+              </a:rPr>
+              <a:t>Cabinas, motores, cajas y diferenciales recuperados: el origen histórico de la firma.</a:t>
+            </a:r>
+            <a:endParaRPr lang="en-US" sz="1050" dirty="0"/>
+          </a:p>
+        </p:txBody>
+      </p:sp>
+      <p:sp>
+        <p:nvSpPr>
+          <p:cNvPr id="14" name="Shape 12"/>
+          <p:cNvSpPr/>
+          <p:nvPr/>
+        </p:nvSpPr>
+        <p:spPr>
+          <a:xfrm>
+            <a:off x="457200" y="3017520"/>
+            <a:ext cx="4023360" cy="1417320"/>
+          </a:xfrm>
+          <a:prstGeom prst="roundRect">
+            <a:avLst>
+              <a:gd name="adj" fmla="val 6452"/>
+            </a:avLst>
+          </a:prstGeom>
+          <a:solidFill>
+            <a:srgbClr val="3A3D41"/>
+          </a:solidFill>
+          <a:ln/>
+        </p:spPr>
+      </p:sp>
+      <p:sp>
+        <p:nvSpPr>
+          <p:cNvPr id="15" name="Shape 13"/>
+          <p:cNvSpPr/>
+          <p:nvPr/>
+        </p:nvSpPr>
+        <p:spPr>
+          <a:xfrm>
+            <a:off x="685800" y="3246120"/>
+            <a:ext cx="640080" cy="640080"/>
+          </a:xfrm>
+          <a:prstGeom prst="ellipse">
+            <a:avLst/>
+          </a:prstGeom>
+          <a:solidFill>
+            <a:srgbClr val="E5323B"/>
+          </a:solidFill>
+          <a:ln/>
+        </p:spPr>
+      </p:sp>
+      <p:sp>
+        <p:nvSpPr>
+          <p:cNvPr id="16" name="Text 14"/>
+          <p:cNvSpPr txBox="1"/>
+          <p:nvPr/>
+        </p:nvSpPr>
+        <p:spPr>
+          <a:xfrm>
+            <a:off x="685800" y="3246120"/>
+            <a:ext cx="640080" cy="640080"/>
+          </a:xfrm>
+          <a:prstGeom prst="rect">
+            <a:avLst/>
+          </a:prstGeom>
+          <a:noFill/>
+          <a:ln/>
+        </p:spPr>
+        <p:txBody>
+          <a:bodyPr wrap="square" lIns="0" tIns="0" rIns="0" bIns="0" rtlCol="0" anchor="ctr"/>
+          <a:lstStyle/>
+          <a:p>
+            <a:pPr algn="ctr" indent="0" marL="0">
+              <a:buNone/>
+            </a:pPr>
+            <a:r>
+              <a:rPr lang="en-US" sz="1800" b="1" dirty="0">
+                <a:solidFill>
+                  <a:srgbClr val="FFFFFF"/>
+                </a:solidFill>
+                <a:latin typeface="Cambria" pitchFamily="34" charset="0"/>
+                <a:ea typeface="Cambria" pitchFamily="34" charset="-122"/>
+                <a:cs typeface="Cambria" pitchFamily="34" charset="-120"/>
+              </a:rPr>
+              <a:t>03</a:t>
+            </a:r>
+            <a:endParaRPr lang="en-US" sz="1800" dirty="0"/>
+          </a:p>
+        </p:txBody>
+      </p:sp>
+      <p:sp>
+        <p:nvSpPr>
+          <p:cNvPr id="17" name="Text 15"/>
+          <p:cNvSpPr txBox="1"/>
+          <p:nvPr/>
+        </p:nvSpPr>
+        <p:spPr>
+          <a:xfrm>
+            <a:off x="1508760" y="3200400"/>
+            <a:ext cx="2743200" cy="320040"/>
+          </a:xfrm>
+          <a:prstGeom prst="rect">
+            <a:avLst/>
+          </a:prstGeom>
+          <a:noFill/>
+          <a:ln/>
+        </p:spPr>
+        <p:txBody>
+          <a:bodyPr wrap="square" lIns="0" tIns="0" rIns="0" bIns="0" rtlCol="0" anchor="ctr"/>
+          <a:lstStyle/>
+          <a:p>
+            <a:pPr indent="0" marL="0">
+              <a:buNone/>
+            </a:pPr>
+            <a:r>
+              <a:rPr lang="en-US" sz="1500" b="1" dirty="0">
+                <a:solidFill>
+                  <a:srgbClr val="FFFFFF"/>
+                </a:solidFill>
+                <a:latin typeface="Cambria" pitchFamily="34" charset="0"/>
+                <a:ea typeface="Cambria" pitchFamily="34" charset="-122"/>
+                <a:cs typeface="Cambria" pitchFamily="34" charset="-120"/>
+              </a:rPr>
+              <a:t>Vehículos y carretas</a:t>
+            </a:r>
+            <a:endParaRPr lang="en-US" sz="1500" dirty="0"/>
+          </a:p>
+        </p:txBody>
+      </p:sp>
+      <p:sp>
+        <p:nvSpPr>
+          <p:cNvPr id="18" name="Text 16"/>
+          <p:cNvSpPr txBox="1"/>
+          <p:nvPr/>
+        </p:nvSpPr>
+        <p:spPr>
+          <a:xfrm>
+            <a:off x="1508760" y="3547872"/>
+            <a:ext cx="2788920" cy="822960"/>
+          </a:xfrm>
+          <a:prstGeom prst="rect">
+            <a:avLst/>
+          </a:prstGeom>
+          <a:noFill/>
+          <a:ln/>
+        </p:spPr>
+        <p:txBody>
+          <a:bodyPr wrap="square" lIns="0" tIns="0" rIns="0" bIns="0" rtlCol="0" anchor="t"/>
+          <a:lstStyle/>
+          <a:p>
+            <a:pPr indent="0" marL="0">
+              <a:buNone/>
+            </a:pPr>
+            <a:r>
+              <a:rPr lang="en-US" sz="1050" dirty="0">
+                <a:solidFill>
+                  <a:srgbClr val="D5D7DA"/>
+                </a:solidFill>
+                <a:latin typeface="Calibri" pitchFamily="34" charset="0"/>
+                <a:ea typeface="Calibri" pitchFamily="34" charset="-122"/>
+                <a:cs typeface="Calibri" pitchFamily="34" charset="-120"/>
+              </a:rPr>
+              <a:t>Camiones y tractocamiones usados; acoplados y semirremolques nuevos y usados.</a:t>
+            </a:r>
+            <a:endParaRPr lang="en-US" sz="1050" dirty="0"/>
+          </a:p>
+        </p:txBody>
+      </p:sp>
+      <p:sp>
+        <p:nvSpPr>
+          <p:cNvPr id="19" name="Shape 17"/>
+          <p:cNvSpPr/>
+          <p:nvPr/>
+        </p:nvSpPr>
+        <p:spPr>
+          <a:xfrm>
+            <a:off x="4663440" y="3017520"/>
+            <a:ext cx="4023360" cy="1417320"/>
+          </a:xfrm>
+          <a:prstGeom prst="roundRect">
+            <a:avLst>
+              <a:gd name="adj" fmla="val 6452"/>
+            </a:avLst>
+          </a:prstGeom>
+          <a:solidFill>
+            <a:srgbClr val="3A3D41"/>
+          </a:solidFill>
+          <a:ln/>
+        </p:spPr>
+      </p:sp>
+      <p:sp>
+        <p:nvSpPr>
+          <p:cNvPr id="20" name="Shape 18"/>
+          <p:cNvSpPr/>
+          <p:nvPr/>
+        </p:nvSpPr>
+        <p:spPr>
+          <a:xfrm>
+            <a:off x="4892040" y="3246120"/>
+            <a:ext cx="640080" cy="640080"/>
+          </a:xfrm>
+          <a:prstGeom prst="ellipse">
+            <a:avLst/>
+          </a:prstGeom>
+          <a:solidFill>
+            <a:srgbClr val="E5323B"/>
+          </a:solidFill>
+          <a:ln/>
+        </p:spPr>
+      </p:sp>
+      <p:sp>
+        <p:nvSpPr>
+          <p:cNvPr id="21" name="Text 19"/>
+          <p:cNvSpPr txBox="1"/>
+          <p:nvPr/>
+        </p:nvSpPr>
+        <p:spPr>
+          <a:xfrm>
+            <a:off x="4892040" y="3246120"/>
+            <a:ext cx="640080" cy="640080"/>
+          </a:xfrm>
+          <a:prstGeom prst="rect">
+            <a:avLst/>
+          </a:prstGeom>
+          <a:noFill/>
+          <a:ln/>
+        </p:spPr>
+        <p:txBody>
+          <a:bodyPr wrap="square" lIns="0" tIns="0" rIns="0" bIns="0" rtlCol="0" anchor="ctr"/>
+          <a:lstStyle/>
+          <a:p>
+            <a:pPr algn="ctr" indent="0" marL="0">
+              <a:buNone/>
+            </a:pPr>
+            <a:r>
+              <a:rPr lang="en-US" sz="1800" b="1" dirty="0">
+                <a:solidFill>
+                  <a:srgbClr val="FFFFFF"/>
+                </a:solidFill>
+                <a:latin typeface="Cambria" pitchFamily="34" charset="0"/>
+                <a:ea typeface="Cambria" pitchFamily="34" charset="-122"/>
+                <a:cs typeface="Cambria" pitchFamily="34" charset="-120"/>
+              </a:rPr>
+              <a:t>04</a:t>
+            </a:r>
+            <a:endParaRPr lang="en-US" sz="1800" dirty="0"/>
+          </a:p>
+        </p:txBody>
+      </p:sp>
+      <p:sp>
+        <p:nvSpPr>
+          <p:cNvPr id="22" name="Text 20"/>
+          <p:cNvSpPr txBox="1"/>
+          <p:nvPr/>
+        </p:nvSpPr>
+        <p:spPr>
+          <a:xfrm>
+            <a:off x="5715000" y="3200400"/>
+            <a:ext cx="2743200" cy="320040"/>
+          </a:xfrm>
+          <a:prstGeom prst="rect">
+            <a:avLst/>
+          </a:prstGeom>
+          <a:noFill/>
+          <a:ln/>
+        </p:spPr>
+        <p:txBody>
+          <a:bodyPr wrap="square" lIns="0" tIns="0" rIns="0" bIns="0" rtlCol="0" anchor="ctr"/>
+          <a:lstStyle/>
+          <a:p>
+            <a:pPr indent="0" marL="0">
+              <a:buNone/>
+            </a:pPr>
+            <a:r>
+              <a:rPr lang="en-US" sz="1500" b="1" dirty="0">
+                <a:solidFill>
+                  <a:srgbClr val="FFFFFF"/>
+                </a:solidFill>
+                <a:latin typeface="Cambria" pitchFamily="34" charset="0"/>
+                <a:ea typeface="Cambria" pitchFamily="34" charset="-122"/>
+                <a:cs typeface="Cambria" pitchFamily="34" charset="-120"/>
+              </a:rPr>
+              <a:t>Servicios de taller</a:t>
+            </a:r>
+            <a:endParaRPr lang="en-US" sz="1500" dirty="0"/>
+          </a:p>
+        </p:txBody>
+      </p:sp>
+      <p:sp>
+        <p:nvSpPr>
+          <p:cNvPr id="23" name="Text 21"/>
+          <p:cNvSpPr txBox="1"/>
+          <p:nvPr/>
+        </p:nvSpPr>
+        <p:spPr>
+          <a:xfrm>
+            <a:off x="5715000" y="3547872"/>
+            <a:ext cx="2788920" cy="822960"/>
+          </a:xfrm>
+          <a:prstGeom prst="rect">
+            <a:avLst/>
+          </a:prstGeom>
+          <a:noFill/>
+          <a:ln/>
+        </p:spPr>
+        <p:txBody>
+          <a:bodyPr wrap="square" lIns="0" tIns="0" rIns="0" bIns="0" rtlCol="0" anchor="t"/>
+          <a:lstStyle/>
+          <a:p>
+            <a:pPr indent="0" marL="0">
+              <a:buNone/>
+            </a:pPr>
+            <a:r>
+              <a:rPr lang="en-US" sz="1050" dirty="0">
+                <a:solidFill>
+                  <a:srgbClr val="D5D7DA"/>
+                </a:solidFill>
+                <a:latin typeface="Calibri" pitchFamily="34" charset="0"/>
+                <a:ea typeface="Calibri" pitchFamily="34" charset="-122"/>
+                <a:cs typeface="Calibri" pitchFamily="34" charset="-120"/>
+              </a:rPr>
+              <a:t>Mecánica pesada, tornería, chapería y pintura: vendemos el repuesto y lo colocamos.</a:t>
+            </a:r>
+            <a:endParaRPr lang="en-US" sz="1050" dirty="0"/>
+          </a:p>
+        </p:txBody>
+      </p:sp>
+      <p:sp>
+        <p:nvSpPr>
+          <p:cNvPr id="24" name="Text 22"/>
           <p:cNvSpPr txBox="1"/>
           <p:nvPr/>
         </p:nvSpPr>
@@ -4144,7 +4576,7 @@
       </p:sp>
       <p:sp>
         <p:nvSpPr>
-          <p:cNvPr id="12" name="Text 10"/>
+          <p:cNvPr id="25" name="Text 23"/>
           <p:cNvSpPr txBox="1"/>
           <p:nvPr/>
         </p:nvSpPr>
@@ -4246,7 +4678,7 @@
                 <a:ea typeface="Cambria" pitchFamily="34" charset="-122"/>
                 <a:cs typeface="Cambria" pitchFamily="34" charset="-120"/>
               </a:rPr>
-              <a:t>Presencia y modelo de negocio</a:t>
+              <a:t>Presencia y clientes</a:t>
             </a:r>
             <a:endParaRPr lang="en-US" sz="3000" dirty="0"/>
           </a:p>
@@ -4291,354 +4723,426 @@
           </a:p>
         </p:txBody>
       </p:sp>
-      <p:sp>
-        <p:nvSpPr>
-          <p:cNvPr id="4" name="Shape 2"/>
+      <p:pic>
+        <p:nvPicPr>
+          <p:cNvPr id="4" name="Image 0" descr="use/katuete.jpg">    </p:cNvPr>
+          <p:cNvPicPr>
+            <a:picLocks noChangeAspect="1"/>
+          </p:cNvPicPr>
+          <p:nvPr/>
+        </p:nvPicPr>
+        <p:blipFill>
+          <a:blip r:embed="rId1"/>
+          <a:srcRect l="0" r="0" t="0" b="0"/>
+          <a:stretch/>
+        </p:blipFill>
+        <p:spPr>
+          <a:xfrm>
+            <a:off x="457200" y="1325880"/>
+            <a:ext cx="4023360" cy="2103120"/>
+          </a:xfrm>
+          <a:prstGeom prst="rect">
+            <a:avLst/>
+          </a:prstGeom>
+        </p:spPr>
+      </p:pic>
+      <p:sp>
+        <p:nvSpPr>
+          <p:cNvPr id="5" name="Shape 2"/>
           <p:cNvSpPr/>
           <p:nvPr/>
         </p:nvSpPr>
         <p:spPr>
           <a:xfrm>
-            <a:off x="457200" y="1371600"/>
-            <a:ext cx="4206240" cy="1417320"/>
+            <a:off x="594360" y="3063240"/>
+            <a:ext cx="2651760" cy="274320"/>
           </a:xfrm>
           <a:prstGeom prst="roundRect">
             <a:avLst>
-              <a:gd name="adj" fmla="val 6452"/>
+              <a:gd name="adj" fmla="val 16667"/>
+            </a:avLst>
+          </a:prstGeom>
+          <a:solidFill>
+            <a:srgbClr val="1E2023">
+              <a:alpha val="85000"/>
+            </a:srgbClr>
+          </a:solidFill>
+          <a:ln/>
+        </p:spPr>
+      </p:sp>
+      <p:sp>
+        <p:nvSpPr>
+          <p:cNvPr id="6" name="Text 3"/>
+          <p:cNvSpPr txBox="1"/>
+          <p:nvPr/>
+        </p:nvSpPr>
+        <p:spPr>
+          <a:xfrm>
+            <a:off x="594360" y="3063240"/>
+            <a:ext cx="2651760" cy="274320"/>
+          </a:xfrm>
+          <a:prstGeom prst="rect">
+            <a:avLst/>
+          </a:prstGeom>
+          <a:noFill/>
+          <a:ln/>
+        </p:spPr>
+        <p:txBody>
+          <a:bodyPr wrap="square" lIns="0" tIns="0" rIns="0" bIns="0" rtlCol="0" anchor="ctr"/>
+          <a:lstStyle/>
+          <a:p>
+            <a:pPr algn="ctr" indent="0" marL="0">
+              <a:buNone/>
+            </a:pPr>
+            <a:r>
+              <a:rPr lang="en-US" sz="1000" b="1" dirty="0">
+                <a:solidFill>
+                  <a:srgbClr val="FFFFFF"/>
+                </a:solidFill>
+                <a:latin typeface="Calibri" pitchFamily="34" charset="0"/>
+                <a:ea typeface="Calibri" pitchFamily="34" charset="-122"/>
+                <a:cs typeface="Calibri" pitchFamily="34" charset="-120"/>
+              </a:rPr>
+              <a:t>Unidad 1 · Katueté (Canindeyú)</a:t>
+            </a:r>
+            <a:endParaRPr lang="en-US" sz="1000" dirty="0"/>
+          </a:p>
+        </p:txBody>
+      </p:sp>
+      <p:pic>
+        <p:nvPicPr>
+          <p:cNvPr id="7" name="Image 1" descr="use/campo9.jpg">    </p:cNvPr>
+          <p:cNvPicPr>
+            <a:picLocks noChangeAspect="1"/>
+          </p:cNvPicPr>
+          <p:nvPr/>
+        </p:nvPicPr>
+        <p:blipFill>
+          <a:blip r:embed="rId2"/>
+          <a:srcRect l="0" r="0" t="0" b="0"/>
+          <a:stretch/>
+        </p:blipFill>
+        <p:spPr>
+          <a:xfrm>
+            <a:off x="4663440" y="1325880"/>
+            <a:ext cx="4023360" cy="2103120"/>
+          </a:xfrm>
+          <a:prstGeom prst="rect">
+            <a:avLst/>
+          </a:prstGeom>
+        </p:spPr>
+      </p:pic>
+      <p:sp>
+        <p:nvSpPr>
+          <p:cNvPr id="8" name="Shape 4"/>
+          <p:cNvSpPr/>
+          <p:nvPr/>
+        </p:nvSpPr>
+        <p:spPr>
+          <a:xfrm>
+            <a:off x="4800600" y="3063240"/>
+            <a:ext cx="2651760" cy="274320"/>
+          </a:xfrm>
+          <a:prstGeom prst="roundRect">
+            <a:avLst>
+              <a:gd name="adj" fmla="val 16667"/>
+            </a:avLst>
+          </a:prstGeom>
+          <a:solidFill>
+            <a:srgbClr val="1E2023">
+              <a:alpha val="85000"/>
+            </a:srgbClr>
+          </a:solidFill>
+          <a:ln/>
+        </p:spPr>
+      </p:sp>
+      <p:sp>
+        <p:nvSpPr>
+          <p:cNvPr id="9" name="Text 5"/>
+          <p:cNvSpPr txBox="1"/>
+          <p:nvPr/>
+        </p:nvSpPr>
+        <p:spPr>
+          <a:xfrm>
+            <a:off x="4800600" y="3063240"/>
+            <a:ext cx="2651760" cy="274320"/>
+          </a:xfrm>
+          <a:prstGeom prst="rect">
+            <a:avLst/>
+          </a:prstGeom>
+          <a:noFill/>
+          <a:ln/>
+        </p:spPr>
+        <p:txBody>
+          <a:bodyPr wrap="square" lIns="0" tIns="0" rIns="0" bIns="0" rtlCol="0" anchor="ctr"/>
+          <a:lstStyle/>
+          <a:p>
+            <a:pPr algn="ctr" indent="0" marL="0">
+              <a:buNone/>
+            </a:pPr>
+            <a:r>
+              <a:rPr lang="en-US" sz="1000" b="1" dirty="0">
+                <a:solidFill>
+                  <a:srgbClr val="FFFFFF"/>
+                </a:solidFill>
+                <a:latin typeface="Calibri" pitchFamily="34" charset="0"/>
+                <a:ea typeface="Calibri" pitchFamily="34" charset="-122"/>
+                <a:cs typeface="Calibri" pitchFamily="34" charset="-120"/>
+              </a:rPr>
+              <a:t>Unidad 2 · Campo 9 (Caaguazú)</a:t>
+            </a:r>
+            <a:endParaRPr lang="en-US" sz="1000" dirty="0"/>
+          </a:p>
+        </p:txBody>
+      </p:sp>
+      <p:sp>
+        <p:nvSpPr>
+          <p:cNvPr id="10" name="Shape 6"/>
+          <p:cNvSpPr/>
+          <p:nvPr/>
+        </p:nvSpPr>
+        <p:spPr>
+          <a:xfrm>
+            <a:off x="457200" y="3611880"/>
+            <a:ext cx="1965960" cy="1051560"/>
+          </a:xfrm>
+          <a:prstGeom prst="roundRect">
+            <a:avLst>
+              <a:gd name="adj" fmla="val 6957"/>
             </a:avLst>
           </a:prstGeom>
           <a:solidFill>
             <a:srgbClr val="F3F4F5"/>
           </a:solidFill>
           <a:ln/>
-          <a:effectLst>
-            <a:outerShdw sx="100000" sy="100000" kx="0" ky="0" algn="bl" rotWithShape="0" blurRad="101600" dist="25400" dir="5400000">
-              <a:srgbClr val="000000">
-                <a:alpha val="12000"/>
-              </a:srgbClr>
-            </a:outerShdw>
-          </a:effectLst>
-        </p:spPr>
-      </p:sp>
-      <p:sp>
-        <p:nvSpPr>
-          <p:cNvPr id="5" name="Shape 3"/>
-          <p:cNvSpPr/>
-          <p:nvPr/>
-        </p:nvSpPr>
-        <p:spPr>
-          <a:xfrm>
-            <a:off x="685800" y="1828800"/>
-            <a:ext cx="502920" cy="502920"/>
-          </a:xfrm>
-          <a:prstGeom prst="ellipse">
-            <a:avLst/>
-          </a:prstGeom>
-          <a:solidFill>
-            <a:srgbClr val="E5323B"/>
-          </a:solidFill>
-          <a:ln/>
-        </p:spPr>
-      </p:sp>
-      <p:sp>
-        <p:nvSpPr>
-          <p:cNvPr id="6" name="Text 4"/>
-          <p:cNvSpPr txBox="1"/>
-          <p:nvPr/>
-        </p:nvSpPr>
-        <p:spPr>
-          <a:xfrm>
-            <a:off x="685800" y="1828800"/>
-            <a:ext cx="502920" cy="502920"/>
-          </a:xfrm>
-          <a:prstGeom prst="rect">
-            <a:avLst/>
-          </a:prstGeom>
-          <a:noFill/>
-          <a:ln/>
-        </p:spPr>
-        <p:txBody>
-          <a:bodyPr wrap="square" lIns="0" tIns="0" rIns="0" bIns="0" rtlCol="0" anchor="ctr"/>
-          <a:lstStyle/>
-          <a:p>
-            <a:pPr algn="ctr" indent="0" marL="0">
-              <a:buNone/>
-            </a:pPr>
-            <a:r>
-              <a:rPr lang="en-US" sz="1800" b="1" dirty="0">
-                <a:solidFill>
-                  <a:srgbClr val="FFFFFF"/>
+        </p:spPr>
+      </p:sp>
+      <p:sp>
+        <p:nvSpPr>
+          <p:cNvPr id="11" name="Text 7"/>
+          <p:cNvSpPr txBox="1"/>
+          <p:nvPr/>
+        </p:nvSpPr>
+        <p:spPr>
+          <a:xfrm>
+            <a:off x="594360" y="3657600"/>
+            <a:ext cx="1737360" cy="502920"/>
+          </a:xfrm>
+          <a:prstGeom prst="rect">
+            <a:avLst/>
+          </a:prstGeom>
+          <a:noFill/>
+          <a:ln/>
+        </p:spPr>
+        <p:txBody>
+          <a:bodyPr wrap="square" lIns="0" tIns="0" rIns="0" bIns="0" rtlCol="0" anchor="ctr"/>
+          <a:lstStyle/>
+          <a:p>
+            <a:pPr indent="0" marL="0">
+              <a:buNone/>
+            </a:pPr>
+            <a:r>
+              <a:rPr lang="en-US" sz="2400" b="1" dirty="0">
+                <a:solidFill>
+                  <a:srgbClr val="E5323B"/>
                 </a:solidFill>
                 <a:latin typeface="Cambria" pitchFamily="34" charset="0"/>
                 <a:ea typeface="Cambria" pitchFamily="34" charset="-122"/>
                 <a:cs typeface="Cambria" pitchFamily="34" charset="-120"/>
               </a:rPr>
-              <a:t>1</a:t>
-            </a:r>
-            <a:endParaRPr lang="en-US" sz="1800" dirty="0"/>
-          </a:p>
-        </p:txBody>
-      </p:sp>
-      <p:sp>
-        <p:nvSpPr>
-          <p:cNvPr id="7" name="Text 5"/>
-          <p:cNvSpPr txBox="1"/>
-          <p:nvPr/>
-        </p:nvSpPr>
-        <p:spPr>
-          <a:xfrm>
-            <a:off x="1417320" y="1508760"/>
-            <a:ext cx="3108960" cy="1143000"/>
-          </a:xfrm>
-          <a:prstGeom prst="rect">
-            <a:avLst/>
-          </a:prstGeom>
-          <a:noFill/>
-          <a:ln/>
-        </p:spPr>
-        <p:txBody>
-          <a:bodyPr wrap="square" lIns="0" tIns="0" rIns="0" bIns="0" rtlCol="0" anchor="ctr"/>
-          <a:lstStyle/>
-          <a:p>
-            <a:pPr indent="0" marL="0">
-              <a:buNone/>
-            </a:pPr>
-            <a:r>
-              <a:rPr lang="en-US" sz="1100" b="1" dirty="0">
-                <a:solidFill>
-                  <a:srgbClr val="E5323B"/>
-                </a:solidFill>
-                <a:latin typeface="Calibri" pitchFamily="34" charset="0"/>
-                <a:ea typeface="Calibri" pitchFamily="34" charset="-122"/>
-                <a:cs typeface="Calibri" pitchFamily="34" charset="-120"/>
-              </a:rPr>
-              <a:t>UNIDAD 1 · KATUETÉ</a:t>
-            </a:r>
-            <a:endParaRPr lang="en-US" sz="1100" dirty="0"/>
-          </a:p>
-          <a:p>
-            <a:pPr indent="0" marL="0">
-              <a:buNone/>
-            </a:pPr>
-            <a:r>
-              <a:rPr lang="en-US" sz="1300" b="1" dirty="0">
-                <a:solidFill>
-                  <a:srgbClr val="1E2023"/>
-                </a:solidFill>
-                <a:latin typeface="Calibri" pitchFamily="34" charset="0"/>
-                <a:ea typeface="Calibri" pitchFamily="34" charset="-122"/>
-                <a:cs typeface="Calibri" pitchFamily="34" charset="-120"/>
-              </a:rPr>
-              <a:t>Ruta PY 03 km 355, Canindeyú</a:t>
-            </a:r>
-            <a:endParaRPr lang="en-US" sz="1100" dirty="0"/>
-          </a:p>
-          <a:p>
-            <a:pPr indent="0" marL="0">
-              <a:buNone/>
-            </a:pPr>
-            <a:r>
-              <a:rPr lang="en-US" sz="1100" dirty="0">
-                <a:solidFill>
-                  <a:srgbClr val="8A8D91"/>
-                </a:solidFill>
-                <a:latin typeface="Calibri" pitchFamily="34" charset="0"/>
-                <a:ea typeface="Calibri" pitchFamily="34" charset="-122"/>
-                <a:cs typeface="Calibri" pitchFamily="34" charset="-120"/>
-              </a:rPr>
-              <a:t>Repuestos, taller, tornería y chapería</a:t>
-            </a:r>
-            <a:endParaRPr lang="en-US" sz="1100" dirty="0"/>
-          </a:p>
-        </p:txBody>
-      </p:sp>
-      <p:sp>
-        <p:nvSpPr>
-          <p:cNvPr id="8" name="Shape 6"/>
+              <a:t>3.259</a:t>
+            </a:r>
+            <a:endParaRPr lang="en-US" sz="2400" dirty="0"/>
+          </a:p>
+        </p:txBody>
+      </p:sp>
+      <p:sp>
+        <p:nvSpPr>
+          <p:cNvPr id="12" name="Text 8"/>
+          <p:cNvSpPr txBox="1"/>
+          <p:nvPr/>
+        </p:nvSpPr>
+        <p:spPr>
+          <a:xfrm>
+            <a:off x="594360" y="4160520"/>
+            <a:ext cx="1737360" cy="457200"/>
+          </a:xfrm>
+          <a:prstGeom prst="rect">
+            <a:avLst/>
+          </a:prstGeom>
+          <a:noFill/>
+          <a:ln/>
+        </p:spPr>
+        <p:txBody>
+          <a:bodyPr wrap="square" lIns="0" tIns="0" rIns="0" bIns="0" rtlCol="0" anchor="t"/>
+          <a:lstStyle/>
+          <a:p>
+            <a:pPr indent="0" marL="0">
+              <a:buNone/>
+            </a:pPr>
+            <a:r>
+              <a:rPr lang="en-US" sz="950" dirty="0">
+                <a:solidFill>
+                  <a:srgbClr val="3A3D41"/>
+                </a:solidFill>
+                <a:latin typeface="Calibri" pitchFamily="34" charset="0"/>
+                <a:ea typeface="Calibri" pitchFamily="34" charset="-122"/>
+                <a:cs typeface="Calibri" pitchFamily="34" charset="-120"/>
+              </a:rPr>
+              <a:t>clientes atendidos entre 2023 y 2025</a:t>
+            </a:r>
+            <a:endParaRPr lang="en-US" sz="950" dirty="0"/>
+          </a:p>
+        </p:txBody>
+      </p:sp>
+      <p:sp>
+        <p:nvSpPr>
+          <p:cNvPr id="13" name="Shape 9"/>
           <p:cNvSpPr/>
           <p:nvPr/>
         </p:nvSpPr>
         <p:spPr>
           <a:xfrm>
-            <a:off x="457200" y="2971800"/>
-            <a:ext cx="4206240" cy="1417320"/>
+            <a:off x="2578608" y="3611880"/>
+            <a:ext cx="1965960" cy="1051560"/>
           </a:xfrm>
           <a:prstGeom prst="roundRect">
             <a:avLst>
-              <a:gd name="adj" fmla="val 6452"/>
+              <a:gd name="adj" fmla="val 6957"/>
             </a:avLst>
           </a:prstGeom>
           <a:solidFill>
             <a:srgbClr val="F3F4F5"/>
           </a:solidFill>
           <a:ln/>
-          <a:effectLst>
-            <a:outerShdw sx="100000" sy="100000" kx="0" ky="0" algn="bl" rotWithShape="0" blurRad="101600" dist="25400" dir="5400000">
-              <a:srgbClr val="000000">
-                <a:alpha val="12000"/>
-              </a:srgbClr>
-            </a:outerShdw>
-          </a:effectLst>
-        </p:spPr>
-      </p:sp>
-      <p:sp>
-        <p:nvSpPr>
-          <p:cNvPr id="9" name="Shape 7"/>
-          <p:cNvSpPr/>
-          <p:nvPr/>
-        </p:nvSpPr>
-        <p:spPr>
-          <a:xfrm>
-            <a:off x="685800" y="3429000"/>
-            <a:ext cx="502920" cy="502920"/>
-          </a:xfrm>
-          <a:prstGeom prst="ellipse">
-            <a:avLst/>
-          </a:prstGeom>
-          <a:solidFill>
-            <a:srgbClr val="E5323B"/>
-          </a:solidFill>
-          <a:ln/>
-        </p:spPr>
-      </p:sp>
-      <p:sp>
-        <p:nvSpPr>
-          <p:cNvPr id="10" name="Text 8"/>
-          <p:cNvSpPr txBox="1"/>
-          <p:nvPr/>
-        </p:nvSpPr>
-        <p:spPr>
-          <a:xfrm>
-            <a:off x="685800" y="3429000"/>
-            <a:ext cx="502920" cy="502920"/>
-          </a:xfrm>
-          <a:prstGeom prst="rect">
-            <a:avLst/>
-          </a:prstGeom>
-          <a:noFill/>
-          <a:ln/>
-        </p:spPr>
-        <p:txBody>
-          <a:bodyPr wrap="square" lIns="0" tIns="0" rIns="0" bIns="0" rtlCol="0" anchor="ctr"/>
-          <a:lstStyle/>
-          <a:p>
-            <a:pPr algn="ctr" indent="0" marL="0">
-              <a:buNone/>
-            </a:pPr>
-            <a:r>
-              <a:rPr lang="en-US" sz="1800" b="1" dirty="0">
-                <a:solidFill>
-                  <a:srgbClr val="FFFFFF"/>
+        </p:spPr>
+      </p:sp>
+      <p:sp>
+        <p:nvSpPr>
+          <p:cNvPr id="14" name="Text 10"/>
+          <p:cNvSpPr txBox="1"/>
+          <p:nvPr/>
+        </p:nvSpPr>
+        <p:spPr>
+          <a:xfrm>
+            <a:off x="2715768" y="3657600"/>
+            <a:ext cx="1737360" cy="502920"/>
+          </a:xfrm>
+          <a:prstGeom prst="rect">
+            <a:avLst/>
+          </a:prstGeom>
+          <a:noFill/>
+          <a:ln/>
+        </p:spPr>
+        <p:txBody>
+          <a:bodyPr wrap="square" lIns="0" tIns="0" rIns="0" bIns="0" rtlCol="0" anchor="ctr"/>
+          <a:lstStyle/>
+          <a:p>
+            <a:pPr indent="0" marL="0">
+              <a:buNone/>
+            </a:pPr>
+            <a:r>
+              <a:rPr lang="en-US" sz="2400" b="1" dirty="0">
+                <a:solidFill>
+                  <a:srgbClr val="E5323B"/>
                 </a:solidFill>
                 <a:latin typeface="Cambria" pitchFamily="34" charset="0"/>
                 <a:ea typeface="Cambria" pitchFamily="34" charset="-122"/>
                 <a:cs typeface="Cambria" pitchFamily="34" charset="-120"/>
               </a:rPr>
-              <a:t>2</a:t>
-            </a:r>
-            <a:endParaRPr lang="en-US" sz="1800" dirty="0"/>
-          </a:p>
-        </p:txBody>
-      </p:sp>
-      <p:sp>
-        <p:nvSpPr>
-          <p:cNvPr id="11" name="Text 9"/>
-          <p:cNvSpPr txBox="1"/>
-          <p:nvPr/>
-        </p:nvSpPr>
-        <p:spPr>
-          <a:xfrm>
-            <a:off x="1417320" y="3108960"/>
-            <a:ext cx="3108960" cy="1143000"/>
-          </a:xfrm>
-          <a:prstGeom prst="rect">
-            <a:avLst/>
-          </a:prstGeom>
-          <a:noFill/>
-          <a:ln/>
-        </p:spPr>
-        <p:txBody>
-          <a:bodyPr wrap="square" lIns="0" tIns="0" rIns="0" bIns="0" rtlCol="0" anchor="ctr"/>
-          <a:lstStyle/>
-          <a:p>
-            <a:pPr indent="0" marL="0">
-              <a:buNone/>
-            </a:pPr>
-            <a:r>
-              <a:rPr lang="en-US" sz="1100" b="1" dirty="0">
-                <a:solidFill>
-                  <a:srgbClr val="E5323B"/>
-                </a:solidFill>
-                <a:latin typeface="Calibri" pitchFamily="34" charset="0"/>
-                <a:ea typeface="Calibri" pitchFamily="34" charset="-122"/>
-                <a:cs typeface="Calibri" pitchFamily="34" charset="-120"/>
-              </a:rPr>
-              <a:t>UNIDAD 2 · CAMPO 9</a:t>
-            </a:r>
-            <a:endParaRPr lang="en-US" sz="1100" dirty="0"/>
-          </a:p>
-          <a:p>
-            <a:pPr indent="0" marL="0">
-              <a:buNone/>
-            </a:pPr>
-            <a:r>
-              <a:rPr lang="en-US" sz="1300" b="1" dirty="0">
-                <a:solidFill>
-                  <a:srgbClr val="1E2023"/>
-                </a:solidFill>
-                <a:latin typeface="Calibri" pitchFamily="34" charset="0"/>
-                <a:ea typeface="Calibri" pitchFamily="34" charset="-122"/>
-                <a:cs typeface="Calibri" pitchFamily="34" charset="-120"/>
-              </a:rPr>
-              <a:t>J. Asunción Flores 661, Caaguazú</a:t>
-            </a:r>
-            <a:endParaRPr lang="en-US" sz="1100" dirty="0"/>
-          </a:p>
-          <a:p>
-            <a:pPr indent="0" marL="0">
-              <a:buNone/>
-            </a:pPr>
-            <a:r>
-              <a:rPr lang="en-US" sz="1100" dirty="0">
-                <a:solidFill>
-                  <a:srgbClr val="8A8D91"/>
-                </a:solidFill>
-                <a:latin typeface="Calibri" pitchFamily="34" charset="0"/>
-                <a:ea typeface="Calibri" pitchFamily="34" charset="-122"/>
-                <a:cs typeface="Calibri" pitchFamily="34" charset="-120"/>
-              </a:rPr>
-              <a:t>Sobre la Ruta PY 02 · abierta en 2023</a:t>
-            </a:r>
-            <a:endParaRPr lang="en-US" sz="1100" dirty="0"/>
-          </a:p>
-        </p:txBody>
-      </p:sp>
-      <p:sp>
-        <p:nvSpPr>
-          <p:cNvPr id="12" name="Text 10"/>
-          <p:cNvSpPr txBox="1"/>
-          <p:nvPr/>
-        </p:nvSpPr>
-        <p:spPr>
-          <a:xfrm>
-            <a:off x="5029200" y="1371600"/>
-            <a:ext cx="1737360" cy="868680"/>
-          </a:xfrm>
-          <a:prstGeom prst="rect">
-            <a:avLst/>
-          </a:prstGeom>
-          <a:noFill/>
-          <a:ln/>
-        </p:spPr>
-        <p:txBody>
-          <a:bodyPr wrap="square" lIns="0" tIns="0" rIns="0" bIns="0" rtlCol="0" anchor="ctr"/>
-          <a:lstStyle/>
-          <a:p>
-            <a:pPr indent="0" marL="0">
-              <a:buNone/>
-            </a:pPr>
-            <a:r>
-              <a:rPr lang="en-US" sz="3200" b="1" dirty="0">
+              <a:t>3,3%</a:t>
+            </a:r>
+            <a:endParaRPr lang="en-US" sz="2400" dirty="0"/>
+          </a:p>
+        </p:txBody>
+      </p:sp>
+      <p:sp>
+        <p:nvSpPr>
+          <p:cNvPr id="15" name="Text 11"/>
+          <p:cNvSpPr txBox="1"/>
+          <p:nvPr/>
+        </p:nvSpPr>
+        <p:spPr>
+          <a:xfrm>
+            <a:off x="2715768" y="4160520"/>
+            <a:ext cx="1737360" cy="457200"/>
+          </a:xfrm>
+          <a:prstGeom prst="rect">
+            <a:avLst/>
+          </a:prstGeom>
+          <a:noFill/>
+          <a:ln/>
+        </p:spPr>
+        <p:txBody>
+          <a:bodyPr wrap="square" lIns="0" tIns="0" rIns="0" bIns="0" rtlCol="0" anchor="t"/>
+          <a:lstStyle/>
+          <a:p>
+            <a:pPr indent="0" marL="0">
+              <a:buNone/>
+            </a:pPr>
+            <a:r>
+              <a:rPr lang="en-US" sz="950" dirty="0">
+                <a:solidFill>
+                  <a:srgbClr val="3A3D41"/>
+                </a:solidFill>
+                <a:latin typeface="Calibri" pitchFamily="34" charset="0"/>
+                <a:ea typeface="Calibri" pitchFamily="34" charset="-122"/>
+                <a:cs typeface="Calibri" pitchFamily="34" charset="-120"/>
+              </a:rPr>
+              <a:t>ventas del mayor cliente: cartera atomizada</a:t>
+            </a:r>
+            <a:endParaRPr lang="en-US" sz="950" dirty="0"/>
+          </a:p>
+        </p:txBody>
+      </p:sp>
+      <p:sp>
+        <p:nvSpPr>
+          <p:cNvPr id="16" name="Shape 12"/>
+          <p:cNvSpPr/>
+          <p:nvPr/>
+        </p:nvSpPr>
+        <p:spPr>
+          <a:xfrm>
+            <a:off x="4700016" y="3611880"/>
+            <a:ext cx="1965960" cy="1051560"/>
+          </a:xfrm>
+          <a:prstGeom prst="roundRect">
+            <a:avLst>
+              <a:gd name="adj" fmla="val 6957"/>
+            </a:avLst>
+          </a:prstGeom>
+          <a:solidFill>
+            <a:srgbClr val="F3F4F5"/>
+          </a:solidFill>
+          <a:ln/>
+        </p:spPr>
+      </p:sp>
+      <p:sp>
+        <p:nvSpPr>
+          <p:cNvPr id="17" name="Text 13"/>
+          <p:cNvSpPr txBox="1"/>
+          <p:nvPr/>
+        </p:nvSpPr>
+        <p:spPr>
+          <a:xfrm>
+            <a:off x="4837176" y="3657600"/>
+            <a:ext cx="1737360" cy="502920"/>
+          </a:xfrm>
+          <a:prstGeom prst="rect">
+            <a:avLst/>
+          </a:prstGeom>
+          <a:noFill/>
+          <a:ln/>
+        </p:spPr>
+        <p:txBody>
+          <a:bodyPr wrap="square" lIns="0" tIns="0" rIns="0" bIns="0" rtlCol="0" anchor="ctr"/>
+          <a:lstStyle/>
+          <a:p>
+            <a:pPr indent="0" marL="0">
+              <a:buNone/>
+            </a:pPr>
+            <a:r>
+              <a:rPr lang="en-US" sz="2400" b="1" dirty="0">
                 <a:solidFill>
                   <a:srgbClr val="E5323B"/>
                 </a:solidFill>
@@ -4646,100 +5150,99 @@
                 <a:ea typeface="Cambria" pitchFamily="34" charset="-122"/>
                 <a:cs typeface="Cambria" pitchFamily="34" charset="-120"/>
               </a:rPr>
-              <a:t>57,8%</a:t>
-            </a:r>
-            <a:endParaRPr lang="en-US" sz="3200" dirty="0"/>
-          </a:p>
-        </p:txBody>
-      </p:sp>
-      <p:sp>
-        <p:nvSpPr>
-          <p:cNvPr id="13" name="Text 11"/>
-          <p:cNvSpPr txBox="1"/>
-          <p:nvPr/>
-        </p:nvSpPr>
-        <p:spPr>
-          <a:xfrm>
-            <a:off x="6766560" y="1371600"/>
-            <a:ext cx="1920240" cy="868680"/>
-          </a:xfrm>
-          <a:prstGeom prst="rect">
-            <a:avLst/>
-          </a:prstGeom>
-          <a:noFill/>
-          <a:ln/>
-        </p:spPr>
-        <p:txBody>
-          <a:bodyPr wrap="square" lIns="0" tIns="0" rIns="0" bIns="0" rtlCol="0" anchor="ctr"/>
-          <a:lstStyle/>
-          <a:p>
-            <a:pPr indent="0" marL="0">
-              <a:buNone/>
-            </a:pPr>
-            <a:r>
-              <a:rPr lang="en-US" sz="1200" dirty="0">
-                <a:solidFill>
-                  <a:srgbClr val="1E2023"/>
-                </a:solidFill>
-                <a:latin typeface="Calibri" pitchFamily="34" charset="0"/>
-                <a:ea typeface="Calibri" pitchFamily="34" charset="-122"/>
-                <a:cs typeface="Calibri" pitchFamily="34" charset="-120"/>
-              </a:rPr>
-              <a:t>del inventario en repuestos Scania</a:t>
-            </a:r>
-            <a:endParaRPr lang="en-US" sz="1200" dirty="0"/>
-          </a:p>
-        </p:txBody>
-      </p:sp>
-      <p:sp>
-        <p:nvSpPr>
-          <p:cNvPr id="14" name="Shape 12"/>
+              <a:t>583</a:t>
+            </a:r>
+            <a:endParaRPr lang="en-US" sz="2400" dirty="0"/>
+          </a:p>
+        </p:txBody>
+      </p:sp>
+      <p:sp>
+        <p:nvSpPr>
+          <p:cNvPr id="18" name="Text 14"/>
+          <p:cNvSpPr txBox="1"/>
+          <p:nvPr/>
+        </p:nvSpPr>
+        <p:spPr>
+          <a:xfrm>
+            <a:off x="4837176" y="4160520"/>
+            <a:ext cx="1737360" cy="457200"/>
+          </a:xfrm>
+          <a:prstGeom prst="rect">
+            <a:avLst/>
+          </a:prstGeom>
+          <a:noFill/>
+          <a:ln/>
+        </p:spPr>
+        <p:txBody>
+          <a:bodyPr wrap="square" lIns="0" tIns="0" rIns="0" bIns="0" rtlCol="0" anchor="t"/>
+          <a:lstStyle/>
+          <a:p>
+            <a:pPr indent="0" marL="0">
+              <a:buNone/>
+            </a:pPr>
+            <a:r>
+              <a:rPr lang="en-US" sz="950" dirty="0">
+                <a:solidFill>
+                  <a:srgbClr val="3A3D41"/>
+                </a:solidFill>
+                <a:latin typeface="Calibri" pitchFamily="34" charset="0"/>
+                <a:ea typeface="Calibri" pitchFamily="34" charset="-122"/>
+                <a:cs typeface="Calibri" pitchFamily="34" charset="-120"/>
+              </a:rPr>
+              <a:t>proveedores en 2025</a:t>
+            </a:r>
+            <a:endParaRPr lang="en-US" sz="950" dirty="0"/>
+          </a:p>
+        </p:txBody>
+      </p:sp>
+      <p:sp>
+        <p:nvSpPr>
+          <p:cNvPr id="19" name="Shape 15"/>
           <p:cNvSpPr/>
           <p:nvPr/>
         </p:nvSpPr>
         <p:spPr>
           <a:xfrm>
-            <a:off x="5029200" y="2331720"/>
-            <a:ext cx="3657600" cy="0"/>
-          </a:xfrm>
-          <a:prstGeom prst="line">
-            <a:avLst/>
-          </a:prstGeom>
-          <a:noFill/>
-          <a:ln w="9525">
-            <a:solidFill>
-              <a:srgbClr val="D5D7DA"/>
-            </a:solidFill>
-            <a:prstDash val="solid"/>
-          </a:ln>
-        </p:spPr>
-      </p:sp>
-      <p:sp>
-        <p:nvSpPr>
-          <p:cNvPr id="15" name="Text 13"/>
-          <p:cNvSpPr txBox="1"/>
-          <p:nvPr/>
-        </p:nvSpPr>
-        <p:spPr>
-          <a:xfrm>
-            <a:off x="5029200" y="2423160"/>
-            <a:ext cx="1737360" cy="868680"/>
-          </a:xfrm>
-          <a:prstGeom prst="rect">
-            <a:avLst/>
-          </a:prstGeom>
-          <a:noFill/>
-          <a:ln/>
-        </p:spPr>
-        <p:txBody>
-          <a:bodyPr wrap="square" lIns="0" tIns="0" rIns="0" bIns="0" rtlCol="0" anchor="ctr"/>
-          <a:lstStyle/>
-          <a:p>
-            <a:pPr indent="0" marL="0">
-              <a:buNone/>
-            </a:pPr>
-            <a:r>
-              <a:rPr lang="en-US" sz="3200" b="1" dirty="0">
+            <a:off x="6821424" y="3611880"/>
+            <a:ext cx="1965960" cy="1051560"/>
+          </a:xfrm>
+          <a:prstGeom prst="roundRect">
+            <a:avLst>
+              <a:gd name="adj" fmla="val 6957"/>
+            </a:avLst>
+          </a:prstGeom>
+          <a:solidFill>
+            <a:srgbClr val="F3F4F5"/>
+          </a:solidFill>
+          <a:ln/>
+        </p:spPr>
+      </p:sp>
+      <p:sp>
+        <p:nvSpPr>
+          <p:cNvPr id="20" name="Text 16"/>
+          <p:cNvSpPr txBox="1"/>
+          <p:nvPr/>
+        </p:nvSpPr>
+        <p:spPr>
+          <a:xfrm>
+            <a:off x="6958584" y="3657600"/>
+            <a:ext cx="1737360" cy="502920"/>
+          </a:xfrm>
+          <a:prstGeom prst="rect">
+            <a:avLst/>
+          </a:prstGeom>
+          <a:noFill/>
+          <a:ln/>
+        </p:spPr>
+        <p:txBody>
+          <a:bodyPr wrap="square" lIns="0" tIns="0" rIns="0" bIns="0" rtlCol="0" anchor="ctr"/>
+          <a:lstStyle/>
+          <a:p>
+            <a:pPr indent="0" marL="0">
+              <a:buNone/>
+            </a:pPr>
+            <a:r>
+              <a:rPr lang="en-US" sz="2400" b="1" dirty="0">
                 <a:solidFill>
                   <a:srgbClr val="E5323B"/>
                 </a:solidFill>
@@ -4747,155 +5250,54 @@
                 <a:ea typeface="Cambria" pitchFamily="34" charset="-122"/>
                 <a:cs typeface="Cambria" pitchFamily="34" charset="-120"/>
               </a:rPr>
-              <a:t>583</a:t>
-            </a:r>
-            <a:endParaRPr lang="en-US" sz="3200" dirty="0"/>
-          </a:p>
-        </p:txBody>
-      </p:sp>
-      <p:sp>
-        <p:nvSpPr>
-          <p:cNvPr id="16" name="Text 14"/>
-          <p:cNvSpPr txBox="1"/>
-          <p:nvPr/>
-        </p:nvSpPr>
-        <p:spPr>
-          <a:xfrm>
-            <a:off x="6766560" y="2423160"/>
-            <a:ext cx="1920240" cy="868680"/>
-          </a:xfrm>
-          <a:prstGeom prst="rect">
-            <a:avLst/>
-          </a:prstGeom>
-          <a:noFill/>
-          <a:ln/>
-        </p:spPr>
-        <p:txBody>
-          <a:bodyPr wrap="square" lIns="0" tIns="0" rIns="0" bIns="0" rtlCol="0" anchor="ctr"/>
-          <a:lstStyle/>
-          <a:p>
-            <a:pPr indent="0" marL="0">
-              <a:buNone/>
-            </a:pPr>
-            <a:r>
-              <a:rPr lang="en-US" sz="1200" dirty="0">
-                <a:solidFill>
-                  <a:srgbClr val="1E2023"/>
-                </a:solidFill>
-                <a:latin typeface="Calibri" pitchFamily="34" charset="0"/>
-                <a:ea typeface="Calibri" pitchFamily="34" charset="-122"/>
-                <a:cs typeface="Calibri" pitchFamily="34" charset="-120"/>
-              </a:rPr>
-              <a:t>proveedores en 2025</a:t>
-            </a:r>
-            <a:endParaRPr lang="en-US" sz="1200" dirty="0"/>
-          </a:p>
-        </p:txBody>
-      </p:sp>
-      <p:sp>
-        <p:nvSpPr>
-          <p:cNvPr id="17" name="Shape 15"/>
-          <p:cNvSpPr/>
-          <p:nvPr/>
-        </p:nvSpPr>
-        <p:spPr>
-          <a:xfrm>
-            <a:off x="5029200" y="3383280"/>
-            <a:ext cx="3657600" cy="0"/>
-          </a:xfrm>
-          <a:prstGeom prst="line">
-            <a:avLst/>
-          </a:prstGeom>
-          <a:noFill/>
-          <a:ln w="9525">
-            <a:solidFill>
-              <a:srgbClr val="D5D7DA"/>
-            </a:solidFill>
-            <a:prstDash val="solid"/>
-          </a:ln>
-        </p:spPr>
-      </p:sp>
-      <p:sp>
-        <p:nvSpPr>
-          <p:cNvPr id="18" name="Text 16"/>
-          <p:cNvSpPr txBox="1"/>
-          <p:nvPr/>
-        </p:nvSpPr>
-        <p:spPr>
-          <a:xfrm>
-            <a:off x="5029200" y="3474720"/>
-            <a:ext cx="1737360" cy="868680"/>
-          </a:xfrm>
-          <a:prstGeom prst="rect">
-            <a:avLst/>
-          </a:prstGeom>
-          <a:noFill/>
-          <a:ln/>
-        </p:spPr>
-        <p:txBody>
-          <a:bodyPr wrap="square" lIns="0" tIns="0" rIns="0" bIns="0" rtlCol="0" anchor="ctr"/>
-          <a:lstStyle/>
-          <a:p>
-            <a:pPr indent="0" marL="0">
-              <a:buNone/>
-            </a:pPr>
-            <a:r>
-              <a:rPr lang="en-US" sz="3200" b="1" dirty="0">
-                <a:solidFill>
-                  <a:srgbClr val="E5323B"/>
-                </a:solidFill>
-                <a:latin typeface="Cambria" pitchFamily="34" charset="0"/>
-                <a:ea typeface="Cambria" pitchFamily="34" charset="-122"/>
-                <a:cs typeface="Cambria" pitchFamily="34" charset="-120"/>
-              </a:rPr>
-              <a:t>3,3%</a:t>
-            </a:r>
-            <a:endParaRPr lang="en-US" sz="3200" dirty="0"/>
-          </a:p>
-        </p:txBody>
-      </p:sp>
-      <p:sp>
-        <p:nvSpPr>
-          <p:cNvPr id="19" name="Text 17"/>
-          <p:cNvSpPr txBox="1"/>
-          <p:nvPr/>
-        </p:nvSpPr>
-        <p:spPr>
-          <a:xfrm>
-            <a:off x="6766560" y="3474720"/>
-            <a:ext cx="1920240" cy="868680"/>
-          </a:xfrm>
-          <a:prstGeom prst="rect">
-            <a:avLst/>
-          </a:prstGeom>
-          <a:noFill/>
-          <a:ln/>
-        </p:spPr>
-        <p:txBody>
-          <a:bodyPr wrap="square" lIns="0" tIns="0" rIns="0" bIns="0" rtlCol="0" anchor="ctr"/>
-          <a:lstStyle/>
-          <a:p>
-            <a:pPr indent="0" marL="0">
-              <a:buNone/>
-            </a:pPr>
-            <a:r>
-              <a:rPr lang="en-US" sz="1200" dirty="0">
-                <a:solidFill>
-                  <a:srgbClr val="1E2023"/>
-                </a:solidFill>
-                <a:latin typeface="Calibri" pitchFamily="34" charset="0"/>
-                <a:ea typeface="Calibri" pitchFamily="34" charset="-122"/>
-                <a:cs typeface="Calibri" pitchFamily="34" charset="-120"/>
-              </a:rPr>
-              <a:t>ventas del mayor cliente: cartera atomizada</a:t>
-            </a:r>
-            <a:endParaRPr lang="en-US" sz="1200" dirty="0"/>
-          </a:p>
-        </p:txBody>
-      </p:sp>
-      <p:sp>
-        <p:nvSpPr>
-          <p:cNvPr id="20" name="Text 18"/>
+              <a:t>57,8%</a:t>
+            </a:r>
+            <a:endParaRPr lang="en-US" sz="2400" dirty="0"/>
+          </a:p>
+        </p:txBody>
+      </p:sp>
+      <p:sp>
+        <p:nvSpPr>
+          <p:cNvPr id="21" name="Text 17"/>
+          <p:cNvSpPr txBox="1"/>
+          <p:nvPr/>
+        </p:nvSpPr>
+        <p:spPr>
+          <a:xfrm>
+            <a:off x="6958584" y="4160520"/>
+            <a:ext cx="1737360" cy="457200"/>
+          </a:xfrm>
+          <a:prstGeom prst="rect">
+            <a:avLst/>
+          </a:prstGeom>
+          <a:noFill/>
+          <a:ln/>
+        </p:spPr>
+        <p:txBody>
+          <a:bodyPr wrap="square" lIns="0" tIns="0" rIns="0" bIns="0" rtlCol="0" anchor="t"/>
+          <a:lstStyle/>
+          <a:p>
+            <a:pPr indent="0" marL="0">
+              <a:buNone/>
+            </a:pPr>
+            <a:r>
+              <a:rPr lang="en-US" sz="950" dirty="0">
+                <a:solidFill>
+                  <a:srgbClr val="3A3D41"/>
+                </a:solidFill>
+                <a:latin typeface="Calibri" pitchFamily="34" charset="0"/>
+                <a:ea typeface="Calibri" pitchFamily="34" charset="-122"/>
+                <a:cs typeface="Calibri" pitchFamily="34" charset="-120"/>
+              </a:rPr>
+              <a:t>del inventario en repuestos Scania</a:t>
+            </a:r>
+            <a:endParaRPr lang="en-US" sz="950" dirty="0"/>
+          </a:p>
+        </p:txBody>
+      </p:sp>
+      <p:sp>
+        <p:nvSpPr>
+          <p:cNvPr id="22" name="Text 18"/>
           <p:cNvSpPr txBox="1"/>
           <p:nvPr/>
         </p:nvSpPr>
@@ -4934,7 +5336,7 @@
       </p:sp>
       <p:sp>
         <p:nvSpPr>
-          <p:cNvPr id="21" name="Text 19"/>
+          <p:cNvPr id="23" name="Text 19"/>
           <p:cNvSpPr txBox="1"/>
           <p:nvPr/>
         </p:nvSpPr>
@@ -5667,11 +6069,11 @@
         <p:spPr>
           <a:xfrm>
             <a:off x="457200" y="1371600"/>
-            <a:ext cx="2377440" cy="914400"/>
+            <a:ext cx="2377440" cy="868680"/>
           </a:xfrm>
           <a:prstGeom prst="roundRect">
             <a:avLst>
-              <a:gd name="adj" fmla="val 8000"/>
+              <a:gd name="adj" fmla="val 8421"/>
             </a:avLst>
           </a:prstGeom>
           <a:solidFill>
@@ -5689,7 +6091,7 @@
         <p:spPr>
           <a:xfrm>
             <a:off x="640080" y="1371600"/>
-            <a:ext cx="2057400" cy="914400"/>
+            <a:ext cx="2057400" cy="868680"/>
           </a:xfrm>
           <a:prstGeom prst="rect">
             <a:avLst/>
@@ -5745,11 +6147,11 @@
         <p:spPr>
           <a:xfrm>
             <a:off x="2971800" y="1371600"/>
-            <a:ext cx="2377440" cy="914400"/>
+            <a:ext cx="2377440" cy="868680"/>
           </a:xfrm>
           <a:prstGeom prst="roundRect">
             <a:avLst>
-              <a:gd name="adj" fmla="val 8000"/>
+              <a:gd name="adj" fmla="val 8421"/>
             </a:avLst>
           </a:prstGeom>
           <a:solidFill>
@@ -5767,7 +6169,7 @@
         <p:spPr>
           <a:xfrm>
             <a:off x="3154680" y="1371600"/>
-            <a:ext cx="2057400" cy="914400"/>
+            <a:ext cx="2057400" cy="868680"/>
           </a:xfrm>
           <a:prstGeom prst="rect">
             <a:avLst/>
@@ -5822,12 +6224,12 @@
         </p:nvSpPr>
         <p:spPr>
           <a:xfrm>
-            <a:off x="457200" y="2423160"/>
-            <a:ext cx="2377440" cy="914400"/>
+            <a:off x="457200" y="2359152"/>
+            <a:ext cx="2377440" cy="868680"/>
           </a:xfrm>
           <a:prstGeom prst="roundRect">
             <a:avLst>
-              <a:gd name="adj" fmla="val 8000"/>
+              <a:gd name="adj" fmla="val 8421"/>
             </a:avLst>
           </a:prstGeom>
           <a:solidFill>
@@ -5844,8 +6246,8 @@
         </p:nvSpPr>
         <p:spPr>
           <a:xfrm>
-            <a:off x="640080" y="2423160"/>
-            <a:ext cx="2057400" cy="914400"/>
+            <a:off x="640080" y="2359152"/>
+            <a:ext cx="2057400" cy="868680"/>
           </a:xfrm>
           <a:prstGeom prst="rect">
             <a:avLst/>
@@ -5900,12 +6302,12 @@
         </p:nvSpPr>
         <p:spPr>
           <a:xfrm>
-            <a:off x="2971800" y="2423160"/>
-            <a:ext cx="2377440" cy="914400"/>
+            <a:off x="2971800" y="2359152"/>
+            <a:ext cx="2377440" cy="868680"/>
           </a:xfrm>
           <a:prstGeom prst="roundRect">
             <a:avLst>
-              <a:gd name="adj" fmla="val 8000"/>
+              <a:gd name="adj" fmla="val 8421"/>
             </a:avLst>
           </a:prstGeom>
           <a:solidFill>
@@ -5922,8 +6324,8 @@
         </p:nvSpPr>
         <p:spPr>
           <a:xfrm>
-            <a:off x="3154680" y="2423160"/>
-            <a:ext cx="2057400" cy="914400"/>
+            <a:off x="3154680" y="2359152"/>
+            <a:ext cx="2057400" cy="868680"/>
           </a:xfrm>
           <a:prstGeom prst="rect">
             <a:avLst/>
@@ -5978,12 +6380,12 @@
         </p:nvSpPr>
         <p:spPr>
           <a:xfrm>
-            <a:off x="457200" y="3474720"/>
-            <a:ext cx="2377440" cy="914400"/>
+            <a:off x="457200" y="3346704"/>
+            <a:ext cx="2377440" cy="868680"/>
           </a:xfrm>
           <a:prstGeom prst="roundRect">
             <a:avLst>
-              <a:gd name="adj" fmla="val 8000"/>
+              <a:gd name="adj" fmla="val 8421"/>
             </a:avLst>
           </a:prstGeom>
           <a:solidFill>
@@ -6000,8 +6402,8 @@
         </p:nvSpPr>
         <p:spPr>
           <a:xfrm>
-            <a:off x="640080" y="3474720"/>
-            <a:ext cx="2057400" cy="914400"/>
+            <a:off x="640080" y="3346704"/>
+            <a:ext cx="2057400" cy="868680"/>
           </a:xfrm>
           <a:prstGeom prst="rect">
             <a:avLst/>
@@ -6056,12 +6458,12 @@
         </p:nvSpPr>
         <p:spPr>
           <a:xfrm>
-            <a:off x="2971800" y="3474720"/>
-            <a:ext cx="2377440" cy="914400"/>
+            <a:off x="2971800" y="3346704"/>
+            <a:ext cx="2377440" cy="868680"/>
           </a:xfrm>
           <a:prstGeom prst="roundRect">
             <a:avLst>
-              <a:gd name="adj" fmla="val 8000"/>
+              <a:gd name="adj" fmla="val 8421"/>
             </a:avLst>
           </a:prstGeom>
           <a:solidFill>
@@ -6078,8 +6480,8 @@
         </p:nvSpPr>
         <p:spPr>
           <a:xfrm>
-            <a:off x="3154680" y="3474720"/>
-            <a:ext cx="2057400" cy="914400"/>
+            <a:off x="3154680" y="3346704"/>
+            <a:ext cx="2057400" cy="868680"/>
           </a:xfrm>
           <a:prstGeom prst="rect">
             <a:avLst/>
@@ -6273,7 +6675,7 @@
         </p:nvSpPr>
         <p:spPr>
           <a:xfrm>
-            <a:off x="457200" y="4343400"/>
+            <a:off x="457200" y="4389120"/>
             <a:ext cx="4846320" cy="365760"/>
           </a:xfrm>
           <a:prstGeom prst="rect">

</xml_diff>

<commit_message>
Presentación Tavares: solo unidad de Katueté
Co-Authored-By: Claude Sonnet 5.5 <noreply@anthropic.com>
Claude-Session: https://claude.ai/code/session_01Ca6i6mxVBQE5Hs5u6ti3nX
</commit_message>
<xml_diff>
--- a/Vista_Previa_Presentacion_Tavares.pptx
+++ b/Vista_Previa_Presentacion_Tavares.pptx
@@ -2394,7 +2394,7 @@
       </p:grpSpPr>
       <p:pic>
         <p:nvPicPr>
-          <p:cNvPr id="2" name="Image 0" descr="use/campo9.jpg">    </p:cNvPr>
+          <p:cNvPr id="2" name="Image 0" descr="use/kat_sign.jpg">    </p:cNvPr>
           <p:cNvPicPr>
             <a:picLocks noChangeAspect="1"/>
           </p:cNvPicPr>
@@ -2472,7 +2472,7 @@
                 <a:ea typeface="Calibri" pitchFamily="34" charset="-122"/>
                 <a:cs typeface="Calibri" pitchFamily="34" charset="-120"/>
               </a:rPr>
-              <a:t>Unidad Campo 9 · Ruta PY 02</a:t>
+              <a:t>Unidad Katueté · Ruta PY 03</a:t>
             </a:r>
             <a:endParaRPr lang="en-US" sz="1000" dirty="0"/>
           </a:p>
@@ -3079,7 +3079,7 @@
         <p:spPr>
           <a:xfrm>
             <a:off x="4617720" y="1234440"/>
-            <a:ext cx="0" cy="3291840"/>
+            <a:ext cx="0" cy="3017520"/>
           </a:xfrm>
           <a:prstGeom prst="line">
             <a:avLst/>
@@ -3101,7 +3101,7 @@
         </p:nvSpPr>
         <p:spPr>
           <a:xfrm>
-            <a:off x="4507992" y="1225296"/>
+            <a:off x="4507992" y="1316736"/>
             <a:ext cx="219456" cy="219456"/>
           </a:xfrm>
           <a:prstGeom prst="ellipse">
@@ -3126,7 +3126,7 @@
         </p:nvSpPr>
         <p:spPr>
           <a:xfrm>
-            <a:off x="4892040" y="1097280"/>
+            <a:off x="4892040" y="1188720"/>
             <a:ext cx="822960" cy="475488"/>
           </a:xfrm>
           <a:prstGeom prst="rect">
@@ -3165,7 +3165,7 @@
         </p:nvSpPr>
         <p:spPr>
           <a:xfrm>
-            <a:off x="5715000" y="1097280"/>
+            <a:off x="5715000" y="1188720"/>
             <a:ext cx="3017520" cy="475488"/>
           </a:xfrm>
           <a:prstGeom prst="rect">
@@ -3204,7 +3204,7 @@
         </p:nvSpPr>
         <p:spPr>
           <a:xfrm>
-            <a:off x="4507992" y="1801368"/>
+            <a:off x="4507992" y="1975104"/>
             <a:ext cx="219456" cy="219456"/>
           </a:xfrm>
           <a:prstGeom prst="ellipse">
@@ -3229,7 +3229,7 @@
         </p:nvSpPr>
         <p:spPr>
           <a:xfrm>
-            <a:off x="4892040" y="1673352"/>
+            <a:off x="4892040" y="1847088"/>
             <a:ext cx="822960" cy="475488"/>
           </a:xfrm>
           <a:prstGeom prst="rect">
@@ -3268,7 +3268,7 @@
         </p:nvSpPr>
         <p:spPr>
           <a:xfrm>
-            <a:off x="5715000" y="1673352"/>
+            <a:off x="5715000" y="1847088"/>
             <a:ext cx="3017520" cy="475488"/>
           </a:xfrm>
           <a:prstGeom prst="rect">
@@ -3307,7 +3307,7 @@
         </p:nvSpPr>
         <p:spPr>
           <a:xfrm>
-            <a:off x="4507992" y="2377440"/>
+            <a:off x="4507992" y="2633472"/>
             <a:ext cx="219456" cy="219456"/>
           </a:xfrm>
           <a:prstGeom prst="ellipse">
@@ -3332,7 +3332,7 @@
         </p:nvSpPr>
         <p:spPr>
           <a:xfrm>
-            <a:off x="4892040" y="2249424"/>
+            <a:off x="4892040" y="2505456"/>
             <a:ext cx="822960" cy="475488"/>
           </a:xfrm>
           <a:prstGeom prst="rect">
@@ -3371,7 +3371,7 @@
         </p:nvSpPr>
         <p:spPr>
           <a:xfrm>
-            <a:off x="5715000" y="2249424"/>
+            <a:off x="5715000" y="2505456"/>
             <a:ext cx="3017520" cy="475488"/>
           </a:xfrm>
           <a:prstGeom prst="rect">
@@ -3410,7 +3410,7 @@
         </p:nvSpPr>
         <p:spPr>
           <a:xfrm>
-            <a:off x="4507992" y="2953512"/>
+            <a:off x="4507992" y="3291840"/>
             <a:ext cx="219456" cy="219456"/>
           </a:xfrm>
           <a:prstGeom prst="ellipse">
@@ -3435,7 +3435,7 @@
         </p:nvSpPr>
         <p:spPr>
           <a:xfrm>
-            <a:off x="4892040" y="2825496"/>
+            <a:off x="4892040" y="3163824"/>
             <a:ext cx="822960" cy="475488"/>
           </a:xfrm>
           <a:prstGeom prst="rect">
@@ -3474,7 +3474,7 @@
         </p:nvSpPr>
         <p:spPr>
           <a:xfrm>
-            <a:off x="5715000" y="2825496"/>
+            <a:off x="5715000" y="3163824"/>
             <a:ext cx="3017520" cy="475488"/>
           </a:xfrm>
           <a:prstGeom prst="rect">
@@ -3513,110 +3513,7 @@
         </p:nvSpPr>
         <p:spPr>
           <a:xfrm>
-            <a:off x="4507992" y="3529584"/>
-            <a:ext cx="219456" cy="219456"/>
-          </a:xfrm>
-          <a:prstGeom prst="ellipse">
-            <a:avLst/>
-          </a:prstGeom>
-          <a:solidFill>
-            <a:srgbClr val="1E2023"/>
-          </a:solidFill>
-          <a:ln w="25400">
-            <a:solidFill>
-              <a:srgbClr val="F3F4F5"/>
-            </a:solidFill>
-            <a:prstDash val="solid"/>
-          </a:ln>
-        </p:spPr>
-      </p:sp>
-      <p:sp>
-        <p:nvSpPr>
-          <p:cNvPr id="21" name="Text 18"/>
-          <p:cNvSpPr txBox="1"/>
-          <p:nvPr/>
-        </p:nvSpPr>
-        <p:spPr>
-          <a:xfrm>
-            <a:off x="4892040" y="3401568"/>
-            <a:ext cx="822960" cy="475488"/>
-          </a:xfrm>
-          <a:prstGeom prst="rect">
-            <a:avLst/>
-          </a:prstGeom>
-          <a:noFill/>
-          <a:ln/>
-        </p:spPr>
-        <p:txBody>
-          <a:bodyPr wrap="square" lIns="0" tIns="0" rIns="0" bIns="0" rtlCol="0" anchor="ctr"/>
-          <a:lstStyle/>
-          <a:p>
-            <a:pPr indent="0" marL="0">
-              <a:buNone/>
-            </a:pPr>
-            <a:r>
-              <a:rPr lang="en-US" sz="1700" b="1" dirty="0">
-                <a:solidFill>
-                  <a:srgbClr val="1E2023"/>
-                </a:solidFill>
-                <a:latin typeface="Cambria" pitchFamily="34" charset="0"/>
-                <a:ea typeface="Cambria" pitchFamily="34" charset="-122"/>
-                <a:cs typeface="Cambria" pitchFamily="34" charset="-120"/>
-              </a:rPr>
-              <a:t>2023</a:t>
-            </a:r>
-            <a:endParaRPr lang="en-US" sz="1700" dirty="0"/>
-          </a:p>
-        </p:txBody>
-      </p:sp>
-      <p:sp>
-        <p:nvSpPr>
-          <p:cNvPr id="22" name="Text 19"/>
-          <p:cNvSpPr txBox="1"/>
-          <p:nvPr/>
-        </p:nvSpPr>
-        <p:spPr>
-          <a:xfrm>
-            <a:off x="5715000" y="3401568"/>
-            <a:ext cx="3017520" cy="475488"/>
-          </a:xfrm>
-          <a:prstGeom prst="rect">
-            <a:avLst/>
-          </a:prstGeom>
-          <a:noFill/>
-          <a:ln/>
-        </p:spPr>
-        <p:txBody>
-          <a:bodyPr wrap="square" lIns="0" tIns="0" rIns="0" bIns="0" rtlCol="0" anchor="ctr"/>
-          <a:lstStyle/>
-          <a:p>
-            <a:pPr indent="0" marL="0">
-              <a:buNone/>
-            </a:pPr>
-            <a:r>
-              <a:rPr lang="en-US" sz="1050" dirty="0">
-                <a:solidFill>
-                  <a:srgbClr val="3A3D41"/>
-                </a:solidFill>
-                <a:latin typeface="Calibri" pitchFamily="34" charset="0"/>
-                <a:ea typeface="Calibri" pitchFamily="34" charset="-122"/>
-                <a:cs typeface="Calibri" pitchFamily="34" charset="-120"/>
-              </a:rPr>
-              <a:t>Abre la unidad de Campo 9, sobre la Ruta PY 02</a:t>
-            </a:r>
-            <a:endParaRPr lang="en-US" sz="1050" dirty="0"/>
-          </a:p>
-        </p:txBody>
-      </p:sp>
-      <p:sp>
-        <p:nvSpPr>
-          <p:cNvPr id="23" name="Shape 20"/>
-          <p:cNvSpPr/>
-          <p:nvPr/>
-        </p:nvSpPr>
-        <p:spPr>
-          <a:xfrm>
-            <a:off x="4507992" y="4105656"/>
+            <a:off x="4507992" y="3950208"/>
             <a:ext cx="219456" cy="219456"/>
           </a:xfrm>
           <a:prstGeom prst="ellipse">
@@ -3635,13 +3532,13 @@
       </p:sp>
       <p:sp>
         <p:nvSpPr>
-          <p:cNvPr id="24" name="Text 21"/>
-          <p:cNvSpPr txBox="1"/>
-          <p:nvPr/>
-        </p:nvSpPr>
-        <p:spPr>
-          <a:xfrm>
-            <a:off x="4892040" y="3977640"/>
+          <p:cNvPr id="21" name="Text 18"/>
+          <p:cNvSpPr txBox="1"/>
+          <p:nvPr/>
+        </p:nvSpPr>
+        <p:spPr>
+          <a:xfrm>
+            <a:off x="4892040" y="3822192"/>
             <a:ext cx="822960" cy="475488"/>
           </a:xfrm>
           <a:prstGeom prst="rect">
@@ -3674,13 +3571,13 @@
       </p:sp>
       <p:sp>
         <p:nvSpPr>
-          <p:cNvPr id="25" name="Text 22"/>
-          <p:cNvSpPr txBox="1"/>
-          <p:nvPr/>
-        </p:nvSpPr>
-        <p:spPr>
-          <a:xfrm>
-            <a:off x="5715000" y="3977640"/>
+          <p:cNvPr id="22" name="Text 19"/>
+          <p:cNvSpPr txBox="1"/>
+          <p:nvPr/>
+        </p:nvSpPr>
+        <p:spPr>
+          <a:xfrm>
+            <a:off x="5715000" y="3822192"/>
             <a:ext cx="3017520" cy="475488"/>
           </a:xfrm>
           <a:prstGeom prst="rect">
@@ -3713,7 +3610,7 @@
       </p:sp>
       <p:sp>
         <p:nvSpPr>
-          <p:cNvPr id="26" name="Text 23"/>
+          <p:cNvPr id="23" name="Text 20"/>
           <p:cNvSpPr txBox="1"/>
           <p:nvPr/>
         </p:nvSpPr>
@@ -3752,7 +3649,7 @@
       </p:sp>
       <p:sp>
         <p:nvSpPr>
-          <p:cNvPr id="27" name="Text 24"/>
+          <p:cNvPr id="24" name="Text 21"/>
           <p:cNvSpPr txBox="1"/>
           <p:nvPr/>
         </p:nvSpPr>
@@ -4678,7 +4575,7 @@
                 <a:ea typeface="Cambria" pitchFamily="34" charset="-122"/>
                 <a:cs typeface="Cambria" pitchFamily="34" charset="-120"/>
               </a:rPr>
-              <a:t>Presencia y clientes</a:t>
+              <a:t>Nuestra unidad en Katueté</a:t>
             </a:r>
             <a:endParaRPr lang="en-US" sz="3000" dirty="0"/>
           </a:p>
@@ -4717,7 +4614,7 @@
                 <a:ea typeface="Calibri" pitchFamily="34" charset="-122"/>
                 <a:cs typeface="Calibri" pitchFamily="34" charset="-120"/>
               </a:rPr>
-              <a:t>Sobre los ejes logísticos de la principal zona agroproductiva</a:t>
+              <a:t>Sobre la Ruta PY 03, en el corazón de la zona agroproductiva de Canindeyú</a:t>
             </a:r>
             <a:endParaRPr lang="en-US" sz="1200" dirty="0"/>
           </a:p>
@@ -4725,7 +4622,7 @@
       </p:sp>
       <p:pic>
         <p:nvPicPr>
-          <p:cNvPr id="4" name="Image 0" descr="use/katuete.jpg">    </p:cNvPr>
+          <p:cNvPr id="4" name="Image 0" descr="use/kat_wide.jpg">    </p:cNvPr>
           <p:cNvPicPr>
             <a:picLocks noChangeAspect="1"/>
           </p:cNvPicPr>
@@ -4739,7 +4636,7 @@
         <p:spPr>
           <a:xfrm>
             <a:off x="457200" y="1325880"/>
-            <a:ext cx="4023360" cy="2103120"/>
+            <a:ext cx="4846320" cy="2103120"/>
           </a:xfrm>
           <a:prstGeom prst="rect">
             <a:avLst/>
@@ -4755,7 +4652,7 @@
         <p:spPr>
           <a:xfrm>
             <a:off x="594360" y="3063240"/>
-            <a:ext cx="2651760" cy="274320"/>
+            <a:ext cx="2377440" cy="274320"/>
           </a:xfrm>
           <a:prstGeom prst="roundRect">
             <a:avLst>
@@ -4779,7 +4676,7 @@
         <p:spPr>
           <a:xfrm>
             <a:off x="594360" y="3063240"/>
-            <a:ext cx="2651760" cy="274320"/>
+            <a:ext cx="2377440" cy="274320"/>
           </a:xfrm>
           <a:prstGeom prst="rect">
             <a:avLst/>
@@ -4803,85 +4700,99 @@
                 <a:ea typeface="Calibri" pitchFamily="34" charset="-122"/>
                 <a:cs typeface="Calibri" pitchFamily="34" charset="-120"/>
               </a:rPr>
-              <a:t>Unidad 1 · Katueté (Canindeyú)</a:t>
+              <a:t>Unidad Katueté · Canindeyú</a:t>
             </a:r>
             <a:endParaRPr lang="en-US" sz="1000" dirty="0"/>
           </a:p>
         </p:txBody>
       </p:sp>
-      <p:pic>
-        <p:nvPicPr>
-          <p:cNvPr id="7" name="Image 1" descr="use/campo9.jpg">    </p:cNvPr>
-          <p:cNvPicPr>
-            <a:picLocks noChangeAspect="1"/>
-          </p:cNvPicPr>
-          <p:nvPr/>
-        </p:nvPicPr>
-        <p:blipFill>
-          <a:blip r:embed="rId2"/>
-          <a:srcRect l="0" r="0" t="0" b="0"/>
-          <a:stretch/>
-        </p:blipFill>
-        <p:spPr>
-          <a:xfrm>
-            <a:off x="4663440" y="1325880"/>
-            <a:ext cx="4023360" cy="2103120"/>
-          </a:xfrm>
-          <a:prstGeom prst="rect">
-            <a:avLst/>
-          </a:prstGeom>
-        </p:spPr>
-      </p:pic>
-      <p:sp>
-        <p:nvSpPr>
-          <p:cNvPr id="8" name="Shape 4"/>
+      <p:sp>
+        <p:nvSpPr>
+          <p:cNvPr id="7" name="Shape 4"/>
           <p:cNvSpPr/>
           <p:nvPr/>
         </p:nvSpPr>
         <p:spPr>
           <a:xfrm>
-            <a:off x="4800600" y="3063240"/>
-            <a:ext cx="2651760" cy="274320"/>
+            <a:off x="5532120" y="1325880"/>
+            <a:ext cx="3154680" cy="2103120"/>
           </a:xfrm>
           <a:prstGeom prst="roundRect">
             <a:avLst>
-              <a:gd name="adj" fmla="val 16667"/>
+              <a:gd name="adj" fmla="val 4348"/>
             </a:avLst>
           </a:prstGeom>
           <a:solidFill>
-            <a:srgbClr val="1E2023">
-              <a:alpha val="85000"/>
-            </a:srgbClr>
+            <a:srgbClr val="1E2023"/>
           </a:solidFill>
           <a:ln/>
         </p:spPr>
       </p:sp>
       <p:sp>
         <p:nvSpPr>
-          <p:cNvPr id="9" name="Text 5"/>
-          <p:cNvSpPr txBox="1"/>
-          <p:nvPr/>
-        </p:nvSpPr>
-        <p:spPr>
-          <a:xfrm>
-            <a:off x="4800600" y="3063240"/>
-            <a:ext cx="2651760" cy="274320"/>
-          </a:xfrm>
-          <a:prstGeom prst="rect">
-            <a:avLst/>
-          </a:prstGeom>
-          <a:noFill/>
-          <a:ln/>
-        </p:spPr>
-        <p:txBody>
-          <a:bodyPr wrap="square" lIns="0" tIns="0" rIns="0" bIns="0" rtlCol="0" anchor="ctr"/>
-          <a:lstStyle/>
-          <a:p>
-            <a:pPr algn="ctr" indent="0" marL="0">
-              <a:buNone/>
-            </a:pPr>
-            <a:r>
-              <a:rPr lang="en-US" sz="1000" b="1" dirty="0">
+          <p:cNvPr id="8" name="Text 5"/>
+          <p:cNvSpPr txBox="1"/>
+          <p:nvPr/>
+        </p:nvSpPr>
+        <p:spPr>
+          <a:xfrm>
+            <a:off x="5760720" y="1463040"/>
+            <a:ext cx="2743200" cy="228600"/>
+          </a:xfrm>
+          <a:prstGeom prst="rect">
+            <a:avLst/>
+          </a:prstGeom>
+          <a:noFill/>
+          <a:ln/>
+        </p:spPr>
+        <p:txBody>
+          <a:bodyPr wrap="square" lIns="0" tIns="0" rIns="0" bIns="0" rtlCol="0" anchor="ctr"/>
+          <a:lstStyle/>
+          <a:p>
+            <a:pPr indent="0" marL="0">
+              <a:buNone/>
+            </a:pPr>
+            <a:r>
+              <a:rPr lang="en-US" sz="900" b="1" spc="300" kern="0" dirty="0">
+                <a:solidFill>
+                  <a:srgbClr val="E5323B"/>
+                </a:solidFill>
+                <a:latin typeface="Calibri" pitchFamily="34" charset="0"/>
+                <a:ea typeface="Calibri" pitchFamily="34" charset="-122"/>
+                <a:cs typeface="Calibri" pitchFamily="34" charset="-120"/>
+              </a:rPr>
+              <a:t>UBICACIÓN</a:t>
+            </a:r>
+            <a:endParaRPr lang="en-US" sz="900" dirty="0"/>
+          </a:p>
+        </p:txBody>
+      </p:sp>
+      <p:sp>
+        <p:nvSpPr>
+          <p:cNvPr id="9" name="Text 6"/>
+          <p:cNvSpPr txBox="1"/>
+          <p:nvPr/>
+        </p:nvSpPr>
+        <p:spPr>
+          <a:xfrm>
+            <a:off x="5760720" y="1737360"/>
+            <a:ext cx="2743200" cy="1600200"/>
+          </a:xfrm>
+          <a:prstGeom prst="rect">
+            <a:avLst/>
+          </a:prstGeom>
+          <a:noFill/>
+          <a:ln/>
+        </p:spPr>
+        <p:txBody>
+          <a:bodyPr wrap="square" lIns="0" tIns="0" rIns="0" bIns="0" rtlCol="0" anchor="t"/>
+          <a:lstStyle/>
+          <a:p>
+            <a:pPr indent="0" marL="0">
+              <a:buNone/>
+            </a:pPr>
+            <a:r>
+              <a:rPr lang="en-US" sz="1500" b="1" dirty="0">
                 <a:solidFill>
                   <a:srgbClr val="FFFFFF"/>
                 </a:solidFill>
@@ -4889,15 +4800,66 @@
                 <a:ea typeface="Calibri" pitchFamily="34" charset="-122"/>
                 <a:cs typeface="Calibri" pitchFamily="34" charset="-120"/>
               </a:rPr>
-              <a:t>Unidad 2 · Campo 9 (Caaguazú)</a:t>
-            </a:r>
-            <a:endParaRPr lang="en-US" sz="1000" dirty="0"/>
-          </a:p>
-        </p:txBody>
-      </p:sp>
-      <p:sp>
-        <p:nvSpPr>
-          <p:cNvPr id="10" name="Shape 6"/>
+              <a:t>Ruta PY 03, km 355</a:t>
+            </a:r>
+            <a:endParaRPr lang="en-US" sz="1500" dirty="0"/>
+          </a:p>
+          <a:p>
+            <a:pPr indent="0" marL="0">
+              <a:buNone/>
+            </a:pPr>
+            <a:r>
+              <a:rPr lang="en-US" sz="1200" dirty="0">
+                <a:solidFill>
+                  <a:srgbClr val="FFFFFF"/>
+                </a:solidFill>
+                <a:latin typeface="Calibri" pitchFamily="34" charset="0"/>
+                <a:ea typeface="Calibri" pitchFamily="34" charset="-122"/>
+                <a:cs typeface="Calibri" pitchFamily="34" charset="-120"/>
+              </a:rPr>
+              <a:t>Katueté, Canindeyú</a:t>
+            </a:r>
+            <a:endParaRPr lang="en-US" sz="1500" dirty="0"/>
+          </a:p>
+          <a:p>
+            <a:pPr indent="0" marL="0">
+              <a:buNone/>
+            </a:pPr>
+            <a:r>
+              <a:rPr lang="en-US" sz="600" dirty="0">
+                <a:solidFill>
+                  <a:srgbClr val="FFFFFF"/>
+                </a:solidFill>
+                <a:latin typeface="Calibri" pitchFamily="34" charset="0"/>
+                <a:ea typeface="Calibri" pitchFamily="34" charset="-122"/>
+                <a:cs typeface="Calibri" pitchFamily="34" charset="-120"/>
+              </a:rPr>
+              <a:t> </a:t>
+            </a:r>
+            <a:endParaRPr lang="en-US" sz="1500" dirty="0"/>
+          </a:p>
+          <a:p>
+            <a:pPr indent="0" marL="0">
+              <a:buNone/>
+            </a:pPr>
+            <a:r>
+              <a:rPr lang="en-US" sz="1050" dirty="0">
+                <a:solidFill>
+                  <a:srgbClr val="C9CCD0"/>
+                </a:solidFill>
+                <a:latin typeface="Calibri" pitchFamily="34" charset="0"/>
+                <a:ea typeface="Calibri" pitchFamily="34" charset="-122"/>
+                <a:cs typeface="Calibri" pitchFamily="34" charset="-120"/>
+              </a:rPr>
+              <a:t>Cerca del productor y del transportista: disponibilidad inmediata de repuestos y servicio de taller.</a:t>
+            </a:r>
+            <a:endParaRPr lang="en-US" sz="1500" dirty="0"/>
+          </a:p>
+        </p:txBody>
+      </p:sp>
+      <p:sp>
+        <p:nvSpPr>
+          <p:cNvPr id="10" name="Shape 7"/>
           <p:cNvSpPr/>
           <p:nvPr/>
         </p:nvSpPr>
@@ -4919,7 +4881,7 @@
       </p:sp>
       <p:sp>
         <p:nvSpPr>
-          <p:cNvPr id="11" name="Text 7"/>
+          <p:cNvPr id="11" name="Text 8"/>
           <p:cNvSpPr txBox="1"/>
           <p:nvPr/>
         </p:nvSpPr>
@@ -4958,7 +4920,7 @@
       </p:sp>
       <p:sp>
         <p:nvSpPr>
-          <p:cNvPr id="12" name="Text 8"/>
+          <p:cNvPr id="12" name="Text 9"/>
           <p:cNvSpPr txBox="1"/>
           <p:nvPr/>
         </p:nvSpPr>
@@ -4997,7 +4959,7 @@
       </p:sp>
       <p:sp>
         <p:nvSpPr>
-          <p:cNvPr id="13" name="Shape 9"/>
+          <p:cNvPr id="13" name="Shape 10"/>
           <p:cNvSpPr/>
           <p:nvPr/>
         </p:nvSpPr>
@@ -5019,7 +4981,7 @@
       </p:sp>
       <p:sp>
         <p:nvSpPr>
-          <p:cNvPr id="14" name="Text 10"/>
+          <p:cNvPr id="14" name="Text 11"/>
           <p:cNvSpPr txBox="1"/>
           <p:nvPr/>
         </p:nvSpPr>
@@ -5058,7 +5020,7 @@
       </p:sp>
       <p:sp>
         <p:nvSpPr>
-          <p:cNvPr id="15" name="Text 11"/>
+          <p:cNvPr id="15" name="Text 12"/>
           <p:cNvSpPr txBox="1"/>
           <p:nvPr/>
         </p:nvSpPr>
@@ -5097,7 +5059,7 @@
       </p:sp>
       <p:sp>
         <p:nvSpPr>
-          <p:cNvPr id="16" name="Shape 12"/>
+          <p:cNvPr id="16" name="Shape 13"/>
           <p:cNvSpPr/>
           <p:nvPr/>
         </p:nvSpPr>
@@ -5119,7 +5081,7 @@
       </p:sp>
       <p:sp>
         <p:nvSpPr>
-          <p:cNvPr id="17" name="Text 13"/>
+          <p:cNvPr id="17" name="Text 14"/>
           <p:cNvSpPr txBox="1"/>
           <p:nvPr/>
         </p:nvSpPr>
@@ -5158,7 +5120,7 @@
       </p:sp>
       <p:sp>
         <p:nvSpPr>
-          <p:cNvPr id="18" name="Text 14"/>
+          <p:cNvPr id="18" name="Text 15"/>
           <p:cNvSpPr txBox="1"/>
           <p:nvPr/>
         </p:nvSpPr>
@@ -5197,7 +5159,7 @@
       </p:sp>
       <p:sp>
         <p:nvSpPr>
-          <p:cNvPr id="19" name="Shape 15"/>
+          <p:cNvPr id="19" name="Shape 16"/>
           <p:cNvSpPr/>
           <p:nvPr/>
         </p:nvSpPr>
@@ -5219,7 +5181,7 @@
       </p:sp>
       <p:sp>
         <p:nvSpPr>
-          <p:cNvPr id="20" name="Text 16"/>
+          <p:cNvPr id="20" name="Text 17"/>
           <p:cNvSpPr txBox="1"/>
           <p:nvPr/>
         </p:nvSpPr>
@@ -5258,7 +5220,7 @@
       </p:sp>
       <p:sp>
         <p:nvSpPr>
-          <p:cNvPr id="21" name="Text 17"/>
+          <p:cNvPr id="21" name="Text 18"/>
           <p:cNvSpPr txBox="1"/>
           <p:nvPr/>
         </p:nvSpPr>
@@ -5297,7 +5259,7 @@
       </p:sp>
       <p:sp>
         <p:nvSpPr>
-          <p:cNvPr id="22" name="Text 18"/>
+          <p:cNvPr id="22" name="Text 19"/>
           <p:cNvSpPr txBox="1"/>
           <p:nvPr/>
         </p:nvSpPr>
@@ -5336,7 +5298,7 @@
       </p:sp>
       <p:sp>
         <p:nvSpPr>
-          <p:cNvPr id="23" name="Text 19"/>
+          <p:cNvPr id="23" name="Text 20"/>
           <p:cNvSpPr txBox="1"/>
           <p:nvPr/>
         </p:nvSpPr>
@@ -6929,7 +6891,7 @@
         </p:nvSpPr>
         <p:spPr>
           <a:xfrm>
-            <a:off x="3749040" y="1463040"/>
+            <a:off x="3749040" y="1554480"/>
             <a:ext cx="4937760" cy="201168"/>
           </a:xfrm>
           <a:prstGeom prst="rect">
@@ -6954,7 +6916,7 @@
                 <a:ea typeface="Calibri" pitchFamily="34" charset="-122"/>
                 <a:cs typeface="Calibri" pitchFamily="34" charset="-120"/>
               </a:rPr>
-              <a:t>UNIDAD 1 · KATUETÉ</a:t>
+              <a:t>UNIDAD KATUETÉ</a:t>
             </a:r>
             <a:endParaRPr lang="en-US" sz="900" dirty="0"/>
           </a:p>
@@ -6968,7 +6930,7 @@
         </p:nvSpPr>
         <p:spPr>
           <a:xfrm>
-            <a:off x="3749040" y="1664208"/>
+            <a:off x="3749040" y="1755648"/>
             <a:ext cx="4937760" cy="457200"/>
           </a:xfrm>
           <a:prstGeom prst="rect">
@@ -6993,7 +6955,7 @@
                 <a:ea typeface="Calibri" pitchFamily="34" charset="-122"/>
                 <a:cs typeface="Calibri" pitchFamily="34" charset="-120"/>
               </a:rPr>
-              <a:t>Py 03 km 355, Canindeyú</a:t>
+              <a:t>Py 03 km 355, Katueté – Canindeyú</a:t>
             </a:r>
             <a:endParaRPr lang="en-US" sz="1200" dirty="0"/>
           </a:p>
@@ -7024,7 +6986,7 @@
         </p:nvSpPr>
         <p:spPr>
           <a:xfrm>
-            <a:off x="3749040" y="2240280"/>
+            <a:off x="3749040" y="2468880"/>
             <a:ext cx="4937760" cy="201168"/>
           </a:xfrm>
           <a:prstGeom prst="rect">
@@ -7049,7 +7011,7 @@
                 <a:ea typeface="Calibri" pitchFamily="34" charset="-122"/>
                 <a:cs typeface="Calibri" pitchFamily="34" charset="-120"/>
               </a:rPr>
-              <a:t>UNIDAD 2 · CAMPO 9</a:t>
+              <a:t>CORREO</a:t>
             </a:r>
             <a:endParaRPr lang="en-US" sz="900" dirty="0"/>
           </a:p>
@@ -7063,7 +7025,7 @@
         </p:nvSpPr>
         <p:spPr>
           <a:xfrm>
-            <a:off x="3749040" y="2441448"/>
+            <a:off x="3749040" y="2670048"/>
             <a:ext cx="4937760" cy="457200"/>
           </a:xfrm>
           <a:prstGeom prst="rect">
@@ -7088,7 +7050,7 @@
                 <a:ea typeface="Calibri" pitchFamily="34" charset="-122"/>
                 <a:cs typeface="Calibri" pitchFamily="34" charset="-120"/>
               </a:rPr>
-              <a:t>J. Asunción Flores 661, Caaguazú</a:t>
+              <a:t>financiero@tavaresgroup.com.py</a:t>
             </a:r>
             <a:endParaRPr lang="en-US" sz="1200" dirty="0"/>
           </a:p>
@@ -7105,7 +7067,7 @@
                 <a:ea typeface="Calibri" pitchFamily="34" charset="-122"/>
                 <a:cs typeface="Calibri" pitchFamily="34" charset="-120"/>
               </a:rPr>
-              <a:t>Tel. 0983 510 885</a:t>
+              <a:t>comercial@tavaresgroup.com.py</a:t>
             </a:r>
             <a:endParaRPr lang="en-US" sz="1200" dirty="0"/>
           </a:p>
@@ -7119,7 +7081,7 @@
         </p:nvSpPr>
         <p:spPr>
           <a:xfrm>
-            <a:off x="3749040" y="3017520"/>
+            <a:off x="3749040" y="3383280"/>
             <a:ext cx="4937760" cy="201168"/>
           </a:xfrm>
           <a:prstGeom prst="rect">
@@ -7144,7 +7106,7 @@
                 <a:ea typeface="Calibri" pitchFamily="34" charset="-122"/>
                 <a:cs typeface="Calibri" pitchFamily="34" charset="-120"/>
               </a:rPr>
-              <a:t>CORREO</a:t>
+              <a:t>WEB · RUC</a:t>
             </a:r>
             <a:endParaRPr lang="en-US" sz="900" dirty="0"/>
           </a:p>
@@ -7158,7 +7120,7 @@
         </p:nvSpPr>
         <p:spPr>
           <a:xfrm>
-            <a:off x="3749040" y="3218688"/>
+            <a:off x="3749040" y="3584448"/>
             <a:ext cx="4937760" cy="457200"/>
           </a:xfrm>
           <a:prstGeom prst="rect">
@@ -7183,110 +7145,15 @@
                 <a:ea typeface="Calibri" pitchFamily="34" charset="-122"/>
                 <a:cs typeface="Calibri" pitchFamily="34" charset="-120"/>
               </a:rPr>
-              <a:t>financiero@tavaresgroup.com.py</a:t>
+              <a:t>tavaresgroup.com.py · 80052858-1</a:t>
             </a:r>
             <a:endParaRPr lang="en-US" sz="1200" dirty="0"/>
           </a:p>
-          <a:p>
-            <a:pPr indent="0" marL="0">
-              <a:buNone/>
-            </a:pPr>
-            <a:r>
-              <a:rPr lang="en-US" sz="1200" dirty="0">
-                <a:solidFill>
-                  <a:srgbClr val="FFFFFF"/>
-                </a:solidFill>
-                <a:latin typeface="Calibri" pitchFamily="34" charset="0"/>
-                <a:ea typeface="Calibri" pitchFamily="34" charset="-122"/>
-                <a:cs typeface="Calibri" pitchFamily="34" charset="-120"/>
-              </a:rPr>
-              <a:t>comercial@tavaresgroup.com.py</a:t>
-            </a:r>
-            <a:endParaRPr lang="en-US" sz="1200" dirty="0"/>
-          </a:p>
         </p:txBody>
       </p:sp>
       <p:sp>
         <p:nvSpPr>
           <p:cNvPr id="12" name="Text 9"/>
-          <p:cNvSpPr txBox="1"/>
-          <p:nvPr/>
-        </p:nvSpPr>
-        <p:spPr>
-          <a:xfrm>
-            <a:off x="3749040" y="3794760"/>
-            <a:ext cx="4937760" cy="201168"/>
-          </a:xfrm>
-          <a:prstGeom prst="rect">
-            <a:avLst/>
-          </a:prstGeom>
-          <a:noFill/>
-          <a:ln/>
-        </p:spPr>
-        <p:txBody>
-          <a:bodyPr wrap="square" lIns="0" tIns="0" rIns="0" bIns="0" rtlCol="0" anchor="ctr"/>
-          <a:lstStyle/>
-          <a:p>
-            <a:pPr indent="0" marL="0">
-              <a:buNone/>
-            </a:pPr>
-            <a:r>
-              <a:rPr lang="en-US" sz="900" b="1" spc="200" kern="0" dirty="0">
-                <a:solidFill>
-                  <a:srgbClr val="E5323B"/>
-                </a:solidFill>
-                <a:latin typeface="Calibri" pitchFamily="34" charset="0"/>
-                <a:ea typeface="Calibri" pitchFamily="34" charset="-122"/>
-                <a:cs typeface="Calibri" pitchFamily="34" charset="-120"/>
-              </a:rPr>
-              <a:t>WEB · RUC</a:t>
-            </a:r>
-            <a:endParaRPr lang="en-US" sz="900" dirty="0"/>
-          </a:p>
-        </p:txBody>
-      </p:sp>
-      <p:sp>
-        <p:nvSpPr>
-          <p:cNvPr id="13" name="Text 10"/>
-          <p:cNvSpPr txBox="1"/>
-          <p:nvPr/>
-        </p:nvSpPr>
-        <p:spPr>
-          <a:xfrm>
-            <a:off x="3749040" y="3995928"/>
-            <a:ext cx="4937760" cy="457200"/>
-          </a:xfrm>
-          <a:prstGeom prst="rect">
-            <a:avLst/>
-          </a:prstGeom>
-          <a:noFill/>
-          <a:ln/>
-        </p:spPr>
-        <p:txBody>
-          <a:bodyPr wrap="square" lIns="0" tIns="0" rIns="0" bIns="0" rtlCol="0" anchor="t"/>
-          <a:lstStyle/>
-          <a:p>
-            <a:pPr indent="0" marL="0">
-              <a:buNone/>
-            </a:pPr>
-            <a:r>
-              <a:rPr lang="en-US" sz="1200" dirty="0">
-                <a:solidFill>
-                  <a:srgbClr val="FFFFFF"/>
-                </a:solidFill>
-                <a:latin typeface="Calibri" pitchFamily="34" charset="0"/>
-                <a:ea typeface="Calibri" pitchFamily="34" charset="-122"/>
-                <a:cs typeface="Calibri" pitchFamily="34" charset="-120"/>
-              </a:rPr>
-              <a:t>tavaresgroup.com.py · 80052858-1</a:t>
-            </a:r>
-            <a:endParaRPr lang="en-US" sz="1200" dirty="0"/>
-          </a:p>
-        </p:txBody>
-      </p:sp>
-      <p:sp>
-        <p:nvSpPr>
-          <p:cNvPr id="14" name="Text 11"/>
           <p:cNvSpPr txBox="1"/>
           <p:nvPr/>
         </p:nvSpPr>

</xml_diff>

<commit_message>
Presentación Tavares: unidades Katueté y Campo 9 y red de marca en el país
Co-Authored-By: Claude Sonnet 5.5 <noreply@anthropic.com>
Claude-Session: https://claude.ai/code/session_01Ca6i6mxVBQE5Hs5u6ti3nX
</commit_message>
<xml_diff>
--- a/Vista_Previa_Presentacion_Tavares.pptx
+++ b/Vista_Previa_Presentacion_Tavares.pptx
@@ -1377,7 +1377,7 @@
           <a:p>
             <a:r>
               <a:rPr lang="en-US" dirty="0"/>
-              <a:t/>
+              <a:t>Aviso: los puntos de venta de la red de marca pertenecen a sociedades jurídicamente independientes (no consolidan con la emisora ni aportan flujos, según el prospecto). Redacción sujeta a validación de la casa de bolsa y asesoría legal.</a:t>
             </a:r>
             <a:endParaRPr lang="en-US" dirty="0"/>
           </a:p>
@@ -2550,7 +2550,7 @@
                 <a:ea typeface="Calibri" pitchFamily="34" charset="-122"/>
                 <a:cs typeface="Calibri" pitchFamily="34" charset="-120"/>
               </a:rPr>
-              <a:t>Empresa paraguaya especializada en repuestos, partes y accesorios para camiones, tractocamiones, remolques y maquinaria agrícola, con taller propio de mecánica pesada, tornería, chapería y pintura. Opera bajo la marca Tavares Group.</a:t>
+              <a:t>Empresa paraguaya especializada en repuestos, partes y accesorios para camiones, tractocamiones, remolques y maquinaria agrícola, con taller propio de mecánica pesada, tornería, chapería y pintura. Cuenta con dos unidades propias, la casa matriz de Katueté y la sucursal de Campo 9, y opera bajo la marca Tavares Group.</a:t>
             </a:r>
             <a:endParaRPr lang="en-US" sz="1250" dirty="0"/>
           </a:p>
@@ -3079,7 +3079,7 @@
         <p:spPr>
           <a:xfrm>
             <a:off x="4617720" y="1234440"/>
-            <a:ext cx="0" cy="3017520"/>
+            <a:ext cx="0" cy="3291840"/>
           </a:xfrm>
           <a:prstGeom prst="line">
             <a:avLst/>
@@ -3101,7 +3101,7 @@
         </p:nvSpPr>
         <p:spPr>
           <a:xfrm>
-            <a:off x="4507992" y="1316736"/>
+            <a:off x="4507992" y="1225296"/>
             <a:ext cx="219456" cy="219456"/>
           </a:xfrm>
           <a:prstGeom prst="ellipse">
@@ -3126,7 +3126,7 @@
         </p:nvSpPr>
         <p:spPr>
           <a:xfrm>
-            <a:off x="4892040" y="1188720"/>
+            <a:off x="4892040" y="1097280"/>
             <a:ext cx="822960" cy="475488"/>
           </a:xfrm>
           <a:prstGeom prst="rect">
@@ -3165,7 +3165,7 @@
         </p:nvSpPr>
         <p:spPr>
           <a:xfrm>
-            <a:off x="5715000" y="1188720"/>
+            <a:off x="5715000" y="1097280"/>
             <a:ext cx="3017520" cy="475488"/>
           </a:xfrm>
           <a:prstGeom prst="rect">
@@ -3204,7 +3204,7 @@
         </p:nvSpPr>
         <p:spPr>
           <a:xfrm>
-            <a:off x="4507992" y="1975104"/>
+            <a:off x="4507992" y="1801368"/>
             <a:ext cx="219456" cy="219456"/>
           </a:xfrm>
           <a:prstGeom prst="ellipse">
@@ -3229,7 +3229,7 @@
         </p:nvSpPr>
         <p:spPr>
           <a:xfrm>
-            <a:off x="4892040" y="1847088"/>
+            <a:off x="4892040" y="1673352"/>
             <a:ext cx="822960" cy="475488"/>
           </a:xfrm>
           <a:prstGeom prst="rect">
@@ -3268,7 +3268,7 @@
         </p:nvSpPr>
         <p:spPr>
           <a:xfrm>
-            <a:off x="5715000" y="1847088"/>
+            <a:off x="5715000" y="1673352"/>
             <a:ext cx="3017520" cy="475488"/>
           </a:xfrm>
           <a:prstGeom prst="rect">
@@ -3307,7 +3307,7 @@
         </p:nvSpPr>
         <p:spPr>
           <a:xfrm>
-            <a:off x="4507992" y="2633472"/>
+            <a:off x="4507992" y="2377440"/>
             <a:ext cx="219456" cy="219456"/>
           </a:xfrm>
           <a:prstGeom prst="ellipse">
@@ -3332,7 +3332,7 @@
         </p:nvSpPr>
         <p:spPr>
           <a:xfrm>
-            <a:off x="4892040" y="2505456"/>
+            <a:off x="4892040" y="2249424"/>
             <a:ext cx="822960" cy="475488"/>
           </a:xfrm>
           <a:prstGeom prst="rect">
@@ -3371,7 +3371,7 @@
         </p:nvSpPr>
         <p:spPr>
           <a:xfrm>
-            <a:off x="5715000" y="2505456"/>
+            <a:off x="5715000" y="2249424"/>
             <a:ext cx="3017520" cy="475488"/>
           </a:xfrm>
           <a:prstGeom prst="rect">
@@ -3410,7 +3410,7 @@
         </p:nvSpPr>
         <p:spPr>
           <a:xfrm>
-            <a:off x="4507992" y="3291840"/>
+            <a:off x="4507992" y="2953512"/>
             <a:ext cx="219456" cy="219456"/>
           </a:xfrm>
           <a:prstGeom prst="ellipse">
@@ -3435,7 +3435,7 @@
         </p:nvSpPr>
         <p:spPr>
           <a:xfrm>
-            <a:off x="4892040" y="3163824"/>
+            <a:off x="4892040" y="2825496"/>
             <a:ext cx="822960" cy="475488"/>
           </a:xfrm>
           <a:prstGeom prst="rect">
@@ -3474,7 +3474,7 @@
         </p:nvSpPr>
         <p:spPr>
           <a:xfrm>
-            <a:off x="5715000" y="3163824"/>
+            <a:off x="5715000" y="2825496"/>
             <a:ext cx="3017520" cy="475488"/>
           </a:xfrm>
           <a:prstGeom prst="rect">
@@ -3513,7 +3513,110 @@
         </p:nvSpPr>
         <p:spPr>
           <a:xfrm>
-            <a:off x="4507992" y="3950208"/>
+            <a:off x="4507992" y="3529584"/>
+            <a:ext cx="219456" cy="219456"/>
+          </a:xfrm>
+          <a:prstGeom prst="ellipse">
+            <a:avLst/>
+          </a:prstGeom>
+          <a:solidFill>
+            <a:srgbClr val="1E2023"/>
+          </a:solidFill>
+          <a:ln w="25400">
+            <a:solidFill>
+              <a:srgbClr val="F3F4F5"/>
+            </a:solidFill>
+            <a:prstDash val="solid"/>
+          </a:ln>
+        </p:spPr>
+      </p:sp>
+      <p:sp>
+        <p:nvSpPr>
+          <p:cNvPr id="21" name="Text 18"/>
+          <p:cNvSpPr txBox="1"/>
+          <p:nvPr/>
+        </p:nvSpPr>
+        <p:spPr>
+          <a:xfrm>
+            <a:off x="4892040" y="3401568"/>
+            <a:ext cx="822960" cy="475488"/>
+          </a:xfrm>
+          <a:prstGeom prst="rect">
+            <a:avLst/>
+          </a:prstGeom>
+          <a:noFill/>
+          <a:ln/>
+        </p:spPr>
+        <p:txBody>
+          <a:bodyPr wrap="square" lIns="0" tIns="0" rIns="0" bIns="0" rtlCol="0" anchor="ctr"/>
+          <a:lstStyle/>
+          <a:p>
+            <a:pPr indent="0" marL="0">
+              <a:buNone/>
+            </a:pPr>
+            <a:r>
+              <a:rPr lang="en-US" sz="1700" b="1" dirty="0">
+                <a:solidFill>
+                  <a:srgbClr val="1E2023"/>
+                </a:solidFill>
+                <a:latin typeface="Cambria" pitchFamily="34" charset="0"/>
+                <a:ea typeface="Cambria" pitchFamily="34" charset="-122"/>
+                <a:cs typeface="Cambria" pitchFamily="34" charset="-120"/>
+              </a:rPr>
+              <a:t>2023</a:t>
+            </a:r>
+            <a:endParaRPr lang="en-US" sz="1700" dirty="0"/>
+          </a:p>
+        </p:txBody>
+      </p:sp>
+      <p:sp>
+        <p:nvSpPr>
+          <p:cNvPr id="22" name="Text 19"/>
+          <p:cNvSpPr txBox="1"/>
+          <p:nvPr/>
+        </p:nvSpPr>
+        <p:spPr>
+          <a:xfrm>
+            <a:off x="5715000" y="3401568"/>
+            <a:ext cx="3017520" cy="475488"/>
+          </a:xfrm>
+          <a:prstGeom prst="rect">
+            <a:avLst/>
+          </a:prstGeom>
+          <a:noFill/>
+          <a:ln/>
+        </p:spPr>
+        <p:txBody>
+          <a:bodyPr wrap="square" lIns="0" tIns="0" rIns="0" bIns="0" rtlCol="0" anchor="ctr"/>
+          <a:lstStyle/>
+          <a:p>
+            <a:pPr indent="0" marL="0">
+              <a:buNone/>
+            </a:pPr>
+            <a:r>
+              <a:rPr lang="en-US" sz="1050" dirty="0">
+                <a:solidFill>
+                  <a:srgbClr val="3A3D41"/>
+                </a:solidFill>
+                <a:latin typeface="Calibri" pitchFamily="34" charset="0"/>
+                <a:ea typeface="Calibri" pitchFamily="34" charset="-122"/>
+                <a:cs typeface="Calibri" pitchFamily="34" charset="-120"/>
+              </a:rPr>
+              <a:t>Abre la unidad de Campo 9, sobre la Ruta PY 02</a:t>
+            </a:r>
+            <a:endParaRPr lang="en-US" sz="1050" dirty="0"/>
+          </a:p>
+        </p:txBody>
+      </p:sp>
+      <p:sp>
+        <p:nvSpPr>
+          <p:cNvPr id="23" name="Shape 20"/>
+          <p:cNvSpPr/>
+          <p:nvPr/>
+        </p:nvSpPr>
+        <p:spPr>
+          <a:xfrm>
+            <a:off x="4507992" y="4105656"/>
             <a:ext cx="219456" cy="219456"/>
           </a:xfrm>
           <a:prstGeom prst="ellipse">
@@ -3532,13 +3635,13 @@
       </p:sp>
       <p:sp>
         <p:nvSpPr>
-          <p:cNvPr id="21" name="Text 18"/>
-          <p:cNvSpPr txBox="1"/>
-          <p:nvPr/>
-        </p:nvSpPr>
-        <p:spPr>
-          <a:xfrm>
-            <a:off x="4892040" y="3822192"/>
+          <p:cNvPr id="24" name="Text 21"/>
+          <p:cNvSpPr txBox="1"/>
+          <p:nvPr/>
+        </p:nvSpPr>
+        <p:spPr>
+          <a:xfrm>
+            <a:off x="4892040" y="3977640"/>
             <a:ext cx="822960" cy="475488"/>
           </a:xfrm>
           <a:prstGeom prst="rect">
@@ -3571,13 +3674,13 @@
       </p:sp>
       <p:sp>
         <p:nvSpPr>
-          <p:cNvPr id="22" name="Text 19"/>
-          <p:cNvSpPr txBox="1"/>
-          <p:nvPr/>
-        </p:nvSpPr>
-        <p:spPr>
-          <a:xfrm>
-            <a:off x="5715000" y="3822192"/>
+          <p:cNvPr id="25" name="Text 22"/>
+          <p:cNvSpPr txBox="1"/>
+          <p:nvPr/>
+        </p:nvSpPr>
+        <p:spPr>
+          <a:xfrm>
+            <a:off x="5715000" y="3977640"/>
             <a:ext cx="3017520" cy="475488"/>
           </a:xfrm>
           <a:prstGeom prst="rect">
@@ -3610,7 +3713,7 @@
       </p:sp>
       <p:sp>
         <p:nvSpPr>
-          <p:cNvPr id="23" name="Text 20"/>
+          <p:cNvPr id="26" name="Text 23"/>
           <p:cNvSpPr txBox="1"/>
           <p:nvPr/>
         </p:nvSpPr>
@@ -3649,7 +3752,7 @@
       </p:sp>
       <p:sp>
         <p:nvSpPr>
-          <p:cNvPr id="24" name="Text 21"/>
+          <p:cNvPr id="27" name="Text 24"/>
           <p:cNvSpPr txBox="1"/>
           <p:nvPr/>
         </p:nvSpPr>
@@ -4575,7 +4678,7 @@
                 <a:ea typeface="Cambria" pitchFamily="34" charset="-122"/>
                 <a:cs typeface="Cambria" pitchFamily="34" charset="-120"/>
               </a:rPr>
-              <a:t>Nuestra unidad en Katueté</a:t>
+              <a:t>Presencia y clientes</a:t>
             </a:r>
             <a:endParaRPr lang="en-US" sz="3000" dirty="0"/>
           </a:p>
@@ -4614,7 +4717,7 @@
                 <a:ea typeface="Calibri" pitchFamily="34" charset="-122"/>
                 <a:cs typeface="Calibri" pitchFamily="34" charset="-120"/>
               </a:rPr>
-              <a:t>Sobre la Ruta PY 03, en el corazón de la zona agroproductiva de Canindeyú</a:t>
+              <a:t>Dos unidades propias sobre los ejes logísticos de la principal zona agroproductiva</a:t>
             </a:r>
             <a:endParaRPr lang="en-US" sz="1200" dirty="0"/>
           </a:p>
@@ -4622,7 +4725,7 @@
       </p:sp>
       <p:pic>
         <p:nvPicPr>
-          <p:cNvPr id="4" name="Image 0" descr="use/kat_wide.jpg">    </p:cNvPr>
+          <p:cNvPr id="4" name="Image 0" descr="use/katuete.jpg">    </p:cNvPr>
           <p:cNvPicPr>
             <a:picLocks noChangeAspect="1"/>
           </p:cNvPicPr>
@@ -4635,8 +4738,8 @@
         </p:blipFill>
         <p:spPr>
           <a:xfrm>
-            <a:off x="457200" y="1325880"/>
-            <a:ext cx="4846320" cy="2103120"/>
+            <a:off x="457200" y="1280160"/>
+            <a:ext cx="2514600" cy="1783080"/>
           </a:xfrm>
           <a:prstGeom prst="rect">
             <a:avLst/>
@@ -4651,8 +4754,8 @@
         </p:nvSpPr>
         <p:spPr>
           <a:xfrm>
-            <a:off x="594360" y="3063240"/>
-            <a:ext cx="2377440" cy="274320"/>
+            <a:off x="566928" y="2743200"/>
+            <a:ext cx="1828800" cy="274320"/>
           </a:xfrm>
           <a:prstGeom prst="roundRect">
             <a:avLst>
@@ -4675,8 +4778,8 @@
         </p:nvSpPr>
         <p:spPr>
           <a:xfrm>
-            <a:off x="594360" y="3063240"/>
-            <a:ext cx="2377440" cy="274320"/>
+            <a:off x="566928" y="2743200"/>
+            <a:ext cx="1828800" cy="274320"/>
           </a:xfrm>
           <a:prstGeom prst="rect">
             <a:avLst/>
@@ -4700,99 +4803,85 @@
                 <a:ea typeface="Calibri" pitchFamily="34" charset="-122"/>
                 <a:cs typeface="Calibri" pitchFamily="34" charset="-120"/>
               </a:rPr>
-              <a:t>Unidad Katueté · Canindeyú</a:t>
+              <a:t>Katueté · Casa matriz</a:t>
             </a:r>
             <a:endParaRPr lang="en-US" sz="1000" dirty="0"/>
           </a:p>
         </p:txBody>
       </p:sp>
-      <p:sp>
-        <p:nvSpPr>
-          <p:cNvPr id="7" name="Shape 4"/>
+      <p:pic>
+        <p:nvPicPr>
+          <p:cNvPr id="7" name="Image 1" descr="use/campo9.jpg">    </p:cNvPr>
+          <p:cNvPicPr>
+            <a:picLocks noChangeAspect="1"/>
+          </p:cNvPicPr>
+          <p:nvPr/>
+        </p:nvPicPr>
+        <p:blipFill>
+          <a:blip r:embed="rId2"/>
+          <a:srcRect l="0" r="0" t="0" b="0"/>
+          <a:stretch/>
+        </p:blipFill>
+        <p:spPr>
+          <a:xfrm>
+            <a:off x="3063240" y="1280160"/>
+            <a:ext cx="2514600" cy="1783080"/>
+          </a:xfrm>
+          <a:prstGeom prst="rect">
+            <a:avLst/>
+          </a:prstGeom>
+        </p:spPr>
+      </p:pic>
+      <p:sp>
+        <p:nvSpPr>
+          <p:cNvPr id="8" name="Shape 4"/>
           <p:cNvSpPr/>
           <p:nvPr/>
         </p:nvSpPr>
         <p:spPr>
           <a:xfrm>
-            <a:off x="5532120" y="1325880"/>
-            <a:ext cx="3154680" cy="2103120"/>
+            <a:off x="3172968" y="2743200"/>
+            <a:ext cx="1645920" cy="274320"/>
           </a:xfrm>
           <a:prstGeom prst="roundRect">
             <a:avLst>
-              <a:gd name="adj" fmla="val 4348"/>
+              <a:gd name="adj" fmla="val 16667"/>
             </a:avLst>
           </a:prstGeom>
           <a:solidFill>
-            <a:srgbClr val="1E2023"/>
+            <a:srgbClr val="1E2023">
+              <a:alpha val="85000"/>
+            </a:srgbClr>
           </a:solidFill>
           <a:ln/>
         </p:spPr>
       </p:sp>
       <p:sp>
         <p:nvSpPr>
-          <p:cNvPr id="8" name="Text 5"/>
-          <p:cNvSpPr txBox="1"/>
-          <p:nvPr/>
-        </p:nvSpPr>
-        <p:spPr>
-          <a:xfrm>
-            <a:off x="5760720" y="1463040"/>
-            <a:ext cx="2743200" cy="228600"/>
-          </a:xfrm>
-          <a:prstGeom prst="rect">
-            <a:avLst/>
-          </a:prstGeom>
-          <a:noFill/>
-          <a:ln/>
-        </p:spPr>
-        <p:txBody>
-          <a:bodyPr wrap="square" lIns="0" tIns="0" rIns="0" bIns="0" rtlCol="0" anchor="ctr"/>
-          <a:lstStyle/>
-          <a:p>
-            <a:pPr indent="0" marL="0">
-              <a:buNone/>
-            </a:pPr>
-            <a:r>
-              <a:rPr lang="en-US" sz="900" b="1" spc="300" kern="0" dirty="0">
-                <a:solidFill>
-                  <a:srgbClr val="E5323B"/>
-                </a:solidFill>
-                <a:latin typeface="Calibri" pitchFamily="34" charset="0"/>
-                <a:ea typeface="Calibri" pitchFamily="34" charset="-122"/>
-                <a:cs typeface="Calibri" pitchFamily="34" charset="-120"/>
-              </a:rPr>
-              <a:t>UBICACIÓN</a:t>
-            </a:r>
-            <a:endParaRPr lang="en-US" sz="900" dirty="0"/>
-          </a:p>
-        </p:txBody>
-      </p:sp>
-      <p:sp>
-        <p:nvSpPr>
-          <p:cNvPr id="9" name="Text 6"/>
-          <p:cNvSpPr txBox="1"/>
-          <p:nvPr/>
-        </p:nvSpPr>
-        <p:spPr>
-          <a:xfrm>
-            <a:off x="5760720" y="1737360"/>
-            <a:ext cx="2743200" cy="1600200"/>
-          </a:xfrm>
-          <a:prstGeom prst="rect">
-            <a:avLst/>
-          </a:prstGeom>
-          <a:noFill/>
-          <a:ln/>
-        </p:spPr>
-        <p:txBody>
-          <a:bodyPr wrap="square" lIns="0" tIns="0" rIns="0" bIns="0" rtlCol="0" anchor="t"/>
-          <a:lstStyle/>
-          <a:p>
-            <a:pPr indent="0" marL="0">
-              <a:buNone/>
-            </a:pPr>
-            <a:r>
-              <a:rPr lang="en-US" sz="1500" b="1" dirty="0">
+          <p:cNvPr id="9" name="Text 5"/>
+          <p:cNvSpPr txBox="1"/>
+          <p:nvPr/>
+        </p:nvSpPr>
+        <p:spPr>
+          <a:xfrm>
+            <a:off x="3172968" y="2743200"/>
+            <a:ext cx="1645920" cy="274320"/>
+          </a:xfrm>
+          <a:prstGeom prst="rect">
+            <a:avLst/>
+          </a:prstGeom>
+          <a:noFill/>
+          <a:ln/>
+        </p:spPr>
+        <p:txBody>
+          <a:bodyPr wrap="square" lIns="0" tIns="0" rIns="0" bIns="0" rtlCol="0" anchor="ctr"/>
+          <a:lstStyle/>
+          <a:p>
+            <a:pPr algn="ctr" indent="0" marL="0">
+              <a:buNone/>
+            </a:pPr>
+            <a:r>
+              <a:rPr lang="en-US" sz="1000" b="1" dirty="0">
                 <a:solidFill>
                   <a:srgbClr val="FFFFFF"/>
                 </a:solidFill>
@@ -4800,77 +4889,26 @@
                 <a:ea typeface="Calibri" pitchFamily="34" charset="-122"/>
                 <a:cs typeface="Calibri" pitchFamily="34" charset="-120"/>
               </a:rPr>
-              <a:t>Ruta PY 03, km 355</a:t>
-            </a:r>
-            <a:endParaRPr lang="en-US" sz="1500" dirty="0"/>
-          </a:p>
-          <a:p>
-            <a:pPr indent="0" marL="0">
-              <a:buNone/>
-            </a:pPr>
-            <a:r>
-              <a:rPr lang="en-US" sz="1200" dirty="0">
-                <a:solidFill>
-                  <a:srgbClr val="FFFFFF"/>
-                </a:solidFill>
-                <a:latin typeface="Calibri" pitchFamily="34" charset="0"/>
-                <a:ea typeface="Calibri" pitchFamily="34" charset="-122"/>
-                <a:cs typeface="Calibri" pitchFamily="34" charset="-120"/>
-              </a:rPr>
-              <a:t>Katueté, Canindeyú</a:t>
-            </a:r>
-            <a:endParaRPr lang="en-US" sz="1500" dirty="0"/>
-          </a:p>
-          <a:p>
-            <a:pPr indent="0" marL="0">
-              <a:buNone/>
-            </a:pPr>
-            <a:r>
-              <a:rPr lang="en-US" sz="600" dirty="0">
-                <a:solidFill>
-                  <a:srgbClr val="FFFFFF"/>
-                </a:solidFill>
-                <a:latin typeface="Calibri" pitchFamily="34" charset="0"/>
-                <a:ea typeface="Calibri" pitchFamily="34" charset="-122"/>
-                <a:cs typeface="Calibri" pitchFamily="34" charset="-120"/>
-              </a:rPr>
-              <a:t> </a:t>
-            </a:r>
-            <a:endParaRPr lang="en-US" sz="1500" dirty="0"/>
-          </a:p>
-          <a:p>
-            <a:pPr indent="0" marL="0">
-              <a:buNone/>
-            </a:pPr>
-            <a:r>
-              <a:rPr lang="en-US" sz="1050" dirty="0">
-                <a:solidFill>
-                  <a:srgbClr val="C9CCD0"/>
-                </a:solidFill>
-                <a:latin typeface="Calibri" pitchFamily="34" charset="0"/>
-                <a:ea typeface="Calibri" pitchFamily="34" charset="-122"/>
-                <a:cs typeface="Calibri" pitchFamily="34" charset="-120"/>
-              </a:rPr>
-              <a:t>Cerca del productor y del transportista: disponibilidad inmediata de repuestos y servicio de taller.</a:t>
-            </a:r>
-            <a:endParaRPr lang="en-US" sz="1500" dirty="0"/>
-          </a:p>
-        </p:txBody>
-      </p:sp>
-      <p:sp>
-        <p:nvSpPr>
-          <p:cNvPr id="10" name="Shape 7"/>
+              <a:t>Campo 9 · Sucursal</a:t>
+            </a:r>
+            <a:endParaRPr lang="en-US" sz="1000" dirty="0"/>
+          </a:p>
+        </p:txBody>
+      </p:sp>
+      <p:sp>
+        <p:nvSpPr>
+          <p:cNvPr id="10" name="Shape 6"/>
           <p:cNvSpPr/>
           <p:nvPr/>
         </p:nvSpPr>
         <p:spPr>
           <a:xfrm>
-            <a:off x="457200" y="3611880"/>
-            <a:ext cx="1965960" cy="1051560"/>
+            <a:off x="457200" y="3246120"/>
+            <a:ext cx="5120640" cy="1371600"/>
           </a:xfrm>
           <a:prstGeom prst="roundRect">
             <a:avLst>
-              <a:gd name="adj" fmla="val 6957"/>
+              <a:gd name="adj" fmla="val 5333"/>
             </a:avLst>
           </a:prstGeom>
           <a:solidFill>
@@ -4881,30 +4919,460 @@
       </p:sp>
       <p:sp>
         <p:nvSpPr>
-          <p:cNvPr id="11" name="Text 8"/>
-          <p:cNvSpPr txBox="1"/>
-          <p:nvPr/>
-        </p:nvSpPr>
-        <p:spPr>
-          <a:xfrm>
-            <a:off x="594360" y="3657600"/>
-            <a:ext cx="1737360" cy="502920"/>
-          </a:xfrm>
-          <a:prstGeom prst="rect">
-            <a:avLst/>
-          </a:prstGeom>
-          <a:noFill/>
-          <a:ln/>
-        </p:spPr>
-        <p:txBody>
-          <a:bodyPr wrap="square" lIns="0" tIns="0" rIns="0" bIns="0" rtlCol="0" anchor="ctr"/>
-          <a:lstStyle/>
-          <a:p>
-            <a:pPr indent="0" marL="0">
-              <a:buNone/>
-            </a:pPr>
-            <a:r>
-              <a:rPr lang="en-US" sz="2400" b="1" dirty="0">
+          <p:cNvPr id="11" name="Text 7"/>
+          <p:cNvSpPr txBox="1"/>
+          <p:nvPr/>
+        </p:nvSpPr>
+        <p:spPr>
+          <a:xfrm>
+            <a:off x="640080" y="3337560"/>
+            <a:ext cx="4754880" cy="228600"/>
+          </a:xfrm>
+          <a:prstGeom prst="rect">
+            <a:avLst/>
+          </a:prstGeom>
+          <a:noFill/>
+          <a:ln/>
+        </p:spPr>
+        <p:txBody>
+          <a:bodyPr wrap="square" lIns="0" tIns="0" rIns="0" bIns="0" rtlCol="0" anchor="ctr"/>
+          <a:lstStyle/>
+          <a:p>
+            <a:pPr indent="0" marL="0">
+              <a:buNone/>
+            </a:pPr>
+            <a:r>
+              <a:rPr lang="en-US" sz="900" b="1" spc="200" kern="0" dirty="0">
+                <a:solidFill>
+                  <a:srgbClr val="8A8D91"/>
+                </a:solidFill>
+                <a:latin typeface="Calibri" pitchFamily="34" charset="0"/>
+                <a:ea typeface="Calibri" pitchFamily="34" charset="-122"/>
+                <a:cs typeface="Calibri" pitchFamily="34" charset="-120"/>
+              </a:rPr>
+              <a:t>RED DE MARCA TAVARES GROUP EN EL PAÍS</a:t>
+            </a:r>
+            <a:endParaRPr lang="en-US" sz="900" dirty="0"/>
+          </a:p>
+        </p:txBody>
+      </p:sp>
+      <p:sp>
+        <p:nvSpPr>
+          <p:cNvPr id="12" name="Shape 8"/>
+          <p:cNvSpPr/>
+          <p:nvPr/>
+        </p:nvSpPr>
+        <p:spPr>
+          <a:xfrm>
+            <a:off x="640080" y="3611880"/>
+            <a:ext cx="1051560" cy="256032"/>
+          </a:xfrm>
+          <a:prstGeom prst="roundRect">
+            <a:avLst>
+              <a:gd name="adj" fmla="val 50000"/>
+            </a:avLst>
+          </a:prstGeom>
+          <a:solidFill>
+            <a:srgbClr val="FFFFFF"/>
+          </a:solidFill>
+          <a:ln w="9525">
+            <a:solidFill>
+              <a:srgbClr val="C4C6C9"/>
+            </a:solidFill>
+            <a:prstDash val="solid"/>
+          </a:ln>
+        </p:spPr>
+      </p:sp>
+      <p:sp>
+        <p:nvSpPr>
+          <p:cNvPr id="13" name="Text 9"/>
+          <p:cNvSpPr txBox="1"/>
+          <p:nvPr/>
+        </p:nvSpPr>
+        <p:spPr>
+          <a:xfrm>
+            <a:off x="640080" y="3611880"/>
+            <a:ext cx="1051560" cy="256032"/>
+          </a:xfrm>
+          <a:prstGeom prst="rect">
+            <a:avLst/>
+          </a:prstGeom>
+          <a:noFill/>
+          <a:ln/>
+        </p:spPr>
+        <p:txBody>
+          <a:bodyPr wrap="square" lIns="0" tIns="0" rIns="0" bIns="0" rtlCol="0" anchor="ctr"/>
+          <a:lstStyle/>
+          <a:p>
+            <a:pPr algn="ctr" indent="0" marL="0">
+              <a:buNone/>
+            </a:pPr>
+            <a:r>
+              <a:rPr lang="en-US" sz="900" dirty="0">
+                <a:solidFill>
+                  <a:srgbClr val="3A3D41"/>
+                </a:solidFill>
+                <a:latin typeface="Calibri" pitchFamily="34" charset="0"/>
+                <a:ea typeface="Calibri" pitchFamily="34" charset="-122"/>
+                <a:cs typeface="Calibri" pitchFamily="34" charset="-120"/>
+              </a:rPr>
+              <a:t>San Alberto</a:t>
+            </a:r>
+            <a:endParaRPr lang="en-US" sz="900" dirty="0"/>
+          </a:p>
+        </p:txBody>
+      </p:sp>
+      <p:sp>
+        <p:nvSpPr>
+          <p:cNvPr id="14" name="Shape 10"/>
+          <p:cNvSpPr/>
+          <p:nvPr/>
+        </p:nvSpPr>
+        <p:spPr>
+          <a:xfrm>
+            <a:off x="1783080" y="3611880"/>
+            <a:ext cx="960120" cy="256032"/>
+          </a:xfrm>
+          <a:prstGeom prst="roundRect">
+            <a:avLst>
+              <a:gd name="adj" fmla="val 50000"/>
+            </a:avLst>
+          </a:prstGeom>
+          <a:solidFill>
+            <a:srgbClr val="FFFFFF"/>
+          </a:solidFill>
+          <a:ln w="9525">
+            <a:solidFill>
+              <a:srgbClr val="C4C6C9"/>
+            </a:solidFill>
+            <a:prstDash val="solid"/>
+          </a:ln>
+        </p:spPr>
+      </p:sp>
+      <p:sp>
+        <p:nvSpPr>
+          <p:cNvPr id="15" name="Text 11"/>
+          <p:cNvSpPr txBox="1"/>
+          <p:nvPr/>
+        </p:nvSpPr>
+        <p:spPr>
+          <a:xfrm>
+            <a:off x="1783080" y="3611880"/>
+            <a:ext cx="960120" cy="256032"/>
+          </a:xfrm>
+          <a:prstGeom prst="rect">
+            <a:avLst/>
+          </a:prstGeom>
+          <a:noFill/>
+          <a:ln/>
+        </p:spPr>
+        <p:txBody>
+          <a:bodyPr wrap="square" lIns="0" tIns="0" rIns="0" bIns="0" rtlCol="0" anchor="ctr"/>
+          <a:lstStyle/>
+          <a:p>
+            <a:pPr algn="ctr" indent="0" marL="0">
+              <a:buNone/>
+            </a:pPr>
+            <a:r>
+              <a:rPr lang="en-US" sz="900" dirty="0">
+                <a:solidFill>
+                  <a:srgbClr val="3A3D41"/>
+                </a:solidFill>
+                <a:latin typeface="Calibri" pitchFamily="34" charset="0"/>
+                <a:ea typeface="Calibri" pitchFamily="34" charset="-122"/>
+                <a:cs typeface="Calibri" pitchFamily="34" charset="-120"/>
+              </a:rPr>
+              <a:t>Curuguaty</a:t>
+            </a:r>
+            <a:endParaRPr lang="en-US" sz="900" dirty="0"/>
+          </a:p>
+        </p:txBody>
+      </p:sp>
+      <p:sp>
+        <p:nvSpPr>
+          <p:cNvPr id="16" name="Shape 12"/>
+          <p:cNvSpPr/>
+          <p:nvPr/>
+        </p:nvSpPr>
+        <p:spPr>
+          <a:xfrm>
+            <a:off x="2834640" y="3611880"/>
+            <a:ext cx="914400" cy="256032"/>
+          </a:xfrm>
+          <a:prstGeom prst="roundRect">
+            <a:avLst>
+              <a:gd name="adj" fmla="val 50000"/>
+            </a:avLst>
+          </a:prstGeom>
+          <a:solidFill>
+            <a:srgbClr val="FFFFFF"/>
+          </a:solidFill>
+          <a:ln w="9525">
+            <a:solidFill>
+              <a:srgbClr val="C4C6C9"/>
+            </a:solidFill>
+            <a:prstDash val="solid"/>
+          </a:ln>
+        </p:spPr>
+      </p:sp>
+      <p:sp>
+        <p:nvSpPr>
+          <p:cNvPr id="17" name="Text 13"/>
+          <p:cNvSpPr txBox="1"/>
+          <p:nvPr/>
+        </p:nvSpPr>
+        <p:spPr>
+          <a:xfrm>
+            <a:off x="2834640" y="3611880"/>
+            <a:ext cx="914400" cy="256032"/>
+          </a:xfrm>
+          <a:prstGeom prst="rect">
+            <a:avLst/>
+          </a:prstGeom>
+          <a:noFill/>
+          <a:ln/>
+        </p:spPr>
+        <p:txBody>
+          <a:bodyPr wrap="square" lIns="0" tIns="0" rIns="0" bIns="0" rtlCol="0" anchor="ctr"/>
+          <a:lstStyle/>
+          <a:p>
+            <a:pPr algn="ctr" indent="0" marL="0">
+              <a:buNone/>
+            </a:pPr>
+            <a:r>
+              <a:rPr lang="en-US" sz="900" dirty="0">
+                <a:solidFill>
+                  <a:srgbClr val="3A3D41"/>
+                </a:solidFill>
+                <a:latin typeface="Calibri" pitchFamily="34" charset="0"/>
+                <a:ea typeface="Calibri" pitchFamily="34" charset="-122"/>
+                <a:cs typeface="Calibri" pitchFamily="34" charset="-120"/>
+              </a:rPr>
+              <a:t>Santa Rita</a:t>
+            </a:r>
+            <a:endParaRPr lang="en-US" sz="900" dirty="0"/>
+          </a:p>
+        </p:txBody>
+      </p:sp>
+      <p:sp>
+        <p:nvSpPr>
+          <p:cNvPr id="18" name="Shape 14"/>
+          <p:cNvSpPr/>
+          <p:nvPr/>
+        </p:nvSpPr>
+        <p:spPr>
+          <a:xfrm>
+            <a:off x="3840480" y="3611880"/>
+            <a:ext cx="1554480" cy="256032"/>
+          </a:xfrm>
+          <a:prstGeom prst="roundRect">
+            <a:avLst>
+              <a:gd name="adj" fmla="val 50000"/>
+            </a:avLst>
+          </a:prstGeom>
+          <a:solidFill>
+            <a:srgbClr val="FFFFFF"/>
+          </a:solidFill>
+          <a:ln w="9525">
+            <a:solidFill>
+              <a:srgbClr val="C4C6C9"/>
+            </a:solidFill>
+            <a:prstDash val="solid"/>
+          </a:ln>
+        </p:spPr>
+      </p:sp>
+      <p:sp>
+        <p:nvSpPr>
+          <p:cNvPr id="19" name="Text 15"/>
+          <p:cNvSpPr txBox="1"/>
+          <p:nvPr/>
+        </p:nvSpPr>
+        <p:spPr>
+          <a:xfrm>
+            <a:off x="3840480" y="3611880"/>
+            <a:ext cx="1554480" cy="256032"/>
+          </a:xfrm>
+          <a:prstGeom prst="rect">
+            <a:avLst/>
+          </a:prstGeom>
+          <a:noFill/>
+          <a:ln/>
+        </p:spPr>
+        <p:txBody>
+          <a:bodyPr wrap="square" lIns="0" tIns="0" rIns="0" bIns="0" rtlCol="0" anchor="ctr"/>
+          <a:lstStyle/>
+          <a:p>
+            <a:pPr algn="ctr" indent="0" marL="0">
+              <a:buNone/>
+            </a:pPr>
+            <a:r>
+              <a:rPr lang="en-US" sz="900" dirty="0">
+                <a:solidFill>
+                  <a:srgbClr val="3A3D41"/>
+                </a:solidFill>
+                <a:latin typeface="Calibri" pitchFamily="34" charset="0"/>
+                <a:ea typeface="Calibri" pitchFamily="34" charset="-122"/>
+                <a:cs typeface="Calibri" pitchFamily="34" charset="-120"/>
+              </a:rPr>
+              <a:t>Mariano Roque Alonso</a:t>
+            </a:r>
+            <a:endParaRPr lang="en-US" sz="900" dirty="0"/>
+          </a:p>
+        </p:txBody>
+      </p:sp>
+      <p:sp>
+        <p:nvSpPr>
+          <p:cNvPr id="20" name="Shape 16"/>
+          <p:cNvSpPr/>
+          <p:nvPr/>
+        </p:nvSpPr>
+        <p:spPr>
+          <a:xfrm>
+            <a:off x="640080" y="3931920"/>
+            <a:ext cx="1005840" cy="256032"/>
+          </a:xfrm>
+          <a:prstGeom prst="roundRect">
+            <a:avLst>
+              <a:gd name="adj" fmla="val 50000"/>
+            </a:avLst>
+          </a:prstGeom>
+          <a:solidFill>
+            <a:srgbClr val="FFFFFF"/>
+          </a:solidFill>
+          <a:ln w="9525">
+            <a:solidFill>
+              <a:srgbClr val="C4C6C9"/>
+            </a:solidFill>
+            <a:prstDash val="solid"/>
+          </a:ln>
+        </p:spPr>
+      </p:sp>
+      <p:sp>
+        <p:nvSpPr>
+          <p:cNvPr id="21" name="Text 17"/>
+          <p:cNvSpPr txBox="1"/>
+          <p:nvPr/>
+        </p:nvSpPr>
+        <p:spPr>
+          <a:xfrm>
+            <a:off x="640080" y="3931920"/>
+            <a:ext cx="1005840" cy="256032"/>
+          </a:xfrm>
+          <a:prstGeom prst="rect">
+            <a:avLst/>
+          </a:prstGeom>
+          <a:noFill/>
+          <a:ln/>
+        </p:spPr>
+        <p:txBody>
+          <a:bodyPr wrap="square" lIns="0" tIns="0" rIns="0" bIns="0" rtlCol="0" anchor="ctr"/>
+          <a:lstStyle/>
+          <a:p>
+            <a:pPr algn="ctr" indent="0" marL="0">
+              <a:buNone/>
+            </a:pPr>
+            <a:r>
+              <a:rPr lang="en-US" sz="900" dirty="0">
+                <a:solidFill>
+                  <a:srgbClr val="3A3D41"/>
+                </a:solidFill>
+                <a:latin typeface="Calibri" pitchFamily="34" charset="0"/>
+                <a:ea typeface="Calibri" pitchFamily="34" charset="-122"/>
+                <a:cs typeface="Calibri" pitchFamily="34" charset="-120"/>
+              </a:rPr>
+              <a:t>Loma Plata</a:t>
+            </a:r>
+            <a:endParaRPr lang="en-US" sz="900" dirty="0"/>
+          </a:p>
+        </p:txBody>
+      </p:sp>
+      <p:sp>
+        <p:nvSpPr>
+          <p:cNvPr id="22" name="Text 18"/>
+          <p:cNvSpPr txBox="1"/>
+          <p:nvPr/>
+        </p:nvSpPr>
+        <p:spPr>
+          <a:xfrm>
+            <a:off x="1828800" y="3913632"/>
+            <a:ext cx="3611880" cy="594360"/>
+          </a:xfrm>
+          <a:prstGeom prst="rect">
+            <a:avLst/>
+          </a:prstGeom>
+          <a:noFill/>
+          <a:ln/>
+        </p:spPr>
+        <p:txBody>
+          <a:bodyPr wrap="square" lIns="0" tIns="0" rIns="0" bIns="0" rtlCol="0" anchor="t"/>
+          <a:lstStyle/>
+          <a:p>
+            <a:pPr indent="0" marL="0">
+              <a:buNone/>
+            </a:pPr>
+            <a:r>
+              <a:rPr lang="en-US" sz="850" i="1" dirty="0">
+                <a:solidFill>
+                  <a:srgbClr val="8A8D91"/>
+                </a:solidFill>
+                <a:latin typeface="Calibri" pitchFamily="34" charset="0"/>
+                <a:ea typeface="Calibri" pitchFamily="34" charset="-122"/>
+                <a:cs typeface="Calibri" pitchFamily="34" charset="-120"/>
+              </a:rPr>
+              <a:t>Puntos de venta que comparten la marca, operados por sociedades independientes. No son sucursales ni filiales de la emisora ni forman parte de esta emisión.</a:t>
+            </a:r>
+            <a:endParaRPr lang="en-US" sz="850" dirty="0"/>
+          </a:p>
+        </p:txBody>
+      </p:sp>
+      <p:sp>
+        <p:nvSpPr>
+          <p:cNvPr id="23" name="Shape 19"/>
+          <p:cNvSpPr/>
+          <p:nvPr/>
+        </p:nvSpPr>
+        <p:spPr>
+          <a:xfrm>
+            <a:off x="5852160" y="1280160"/>
+            <a:ext cx="2834640" cy="749808"/>
+          </a:xfrm>
+          <a:prstGeom prst="roundRect">
+            <a:avLst>
+              <a:gd name="adj" fmla="val 9756"/>
+            </a:avLst>
+          </a:prstGeom>
+          <a:solidFill>
+            <a:srgbClr val="F3F4F5"/>
+          </a:solidFill>
+          <a:ln/>
+        </p:spPr>
+      </p:sp>
+      <p:sp>
+        <p:nvSpPr>
+          <p:cNvPr id="24" name="Text 20"/>
+          <p:cNvSpPr txBox="1"/>
+          <p:nvPr/>
+        </p:nvSpPr>
+        <p:spPr>
+          <a:xfrm>
+            <a:off x="5989320" y="1280160"/>
+            <a:ext cx="1143000" cy="749808"/>
+          </a:xfrm>
+          <a:prstGeom prst="rect">
+            <a:avLst/>
+          </a:prstGeom>
+          <a:noFill/>
+          <a:ln/>
+        </p:spPr>
+        <p:txBody>
+          <a:bodyPr wrap="square" lIns="0" tIns="0" rIns="0" bIns="0" rtlCol="0" anchor="ctr"/>
+          <a:lstStyle/>
+          <a:p>
+            <a:pPr indent="0" marL="0">
+              <a:buNone/>
+            </a:pPr>
+            <a:r>
+              <a:rPr lang="en-US" sz="2000" b="1" dirty="0">
                 <a:solidFill>
                   <a:srgbClr val="E5323B"/>
                 </a:solidFill>
@@ -4914,29 +5382,29 @@
               </a:rPr>
               <a:t>3.259</a:t>
             </a:r>
-            <a:endParaRPr lang="en-US" sz="2400" dirty="0"/>
-          </a:p>
-        </p:txBody>
-      </p:sp>
-      <p:sp>
-        <p:nvSpPr>
-          <p:cNvPr id="12" name="Text 9"/>
-          <p:cNvSpPr txBox="1"/>
-          <p:nvPr/>
-        </p:nvSpPr>
-        <p:spPr>
-          <a:xfrm>
-            <a:off x="594360" y="4160520"/>
-            <a:ext cx="1737360" cy="457200"/>
-          </a:xfrm>
-          <a:prstGeom prst="rect">
-            <a:avLst/>
-          </a:prstGeom>
-          <a:noFill/>
-          <a:ln/>
-        </p:spPr>
-        <p:txBody>
-          <a:bodyPr wrap="square" lIns="0" tIns="0" rIns="0" bIns="0" rtlCol="0" anchor="t"/>
+            <a:endParaRPr lang="en-US" sz="2000" dirty="0"/>
+          </a:p>
+        </p:txBody>
+      </p:sp>
+      <p:sp>
+        <p:nvSpPr>
+          <p:cNvPr id="25" name="Text 21"/>
+          <p:cNvSpPr txBox="1"/>
+          <p:nvPr/>
+        </p:nvSpPr>
+        <p:spPr>
+          <a:xfrm>
+            <a:off x="7132320" y="1280160"/>
+            <a:ext cx="1463040" cy="749808"/>
+          </a:xfrm>
+          <a:prstGeom prst="rect">
+            <a:avLst/>
+          </a:prstGeom>
+          <a:noFill/>
+          <a:ln/>
+        </p:spPr>
+        <p:txBody>
+          <a:bodyPr wrap="square" lIns="0" tIns="0" rIns="0" bIns="0" rtlCol="0" anchor="ctr"/>
           <a:lstStyle/>
           <a:p>
             <a:pPr indent="0" marL="0">
@@ -4959,18 +5427,18 @@
       </p:sp>
       <p:sp>
         <p:nvSpPr>
-          <p:cNvPr id="13" name="Shape 10"/>
+          <p:cNvPr id="26" name="Shape 22"/>
           <p:cNvSpPr/>
           <p:nvPr/>
         </p:nvSpPr>
         <p:spPr>
           <a:xfrm>
-            <a:off x="2578608" y="3611880"/>
-            <a:ext cx="1965960" cy="1051560"/>
+            <a:off x="5852160" y="2130552"/>
+            <a:ext cx="2834640" cy="749808"/>
           </a:xfrm>
           <a:prstGeom prst="roundRect">
             <a:avLst>
-              <a:gd name="adj" fmla="val 6957"/>
+              <a:gd name="adj" fmla="val 9756"/>
             </a:avLst>
           </a:prstGeom>
           <a:solidFill>
@@ -4981,30 +5449,30 @@
       </p:sp>
       <p:sp>
         <p:nvSpPr>
-          <p:cNvPr id="14" name="Text 11"/>
-          <p:cNvSpPr txBox="1"/>
-          <p:nvPr/>
-        </p:nvSpPr>
-        <p:spPr>
-          <a:xfrm>
-            <a:off x="2715768" y="3657600"/>
-            <a:ext cx="1737360" cy="502920"/>
-          </a:xfrm>
-          <a:prstGeom prst="rect">
-            <a:avLst/>
-          </a:prstGeom>
-          <a:noFill/>
-          <a:ln/>
-        </p:spPr>
-        <p:txBody>
-          <a:bodyPr wrap="square" lIns="0" tIns="0" rIns="0" bIns="0" rtlCol="0" anchor="ctr"/>
-          <a:lstStyle/>
-          <a:p>
-            <a:pPr indent="0" marL="0">
-              <a:buNone/>
-            </a:pPr>
-            <a:r>
-              <a:rPr lang="en-US" sz="2400" b="1" dirty="0">
+          <p:cNvPr id="27" name="Text 23"/>
+          <p:cNvSpPr txBox="1"/>
+          <p:nvPr/>
+        </p:nvSpPr>
+        <p:spPr>
+          <a:xfrm>
+            <a:off x="5989320" y="2130552"/>
+            <a:ext cx="1143000" cy="749808"/>
+          </a:xfrm>
+          <a:prstGeom prst="rect">
+            <a:avLst/>
+          </a:prstGeom>
+          <a:noFill/>
+          <a:ln/>
+        </p:spPr>
+        <p:txBody>
+          <a:bodyPr wrap="square" lIns="0" tIns="0" rIns="0" bIns="0" rtlCol="0" anchor="ctr"/>
+          <a:lstStyle/>
+          <a:p>
+            <a:pPr indent="0" marL="0">
+              <a:buNone/>
+            </a:pPr>
+            <a:r>
+              <a:rPr lang="en-US" sz="2000" b="1" dirty="0">
                 <a:solidFill>
                   <a:srgbClr val="E5323B"/>
                 </a:solidFill>
@@ -5014,29 +5482,29 @@
               </a:rPr>
               <a:t>3,3%</a:t>
             </a:r>
-            <a:endParaRPr lang="en-US" sz="2400" dirty="0"/>
-          </a:p>
-        </p:txBody>
-      </p:sp>
-      <p:sp>
-        <p:nvSpPr>
-          <p:cNvPr id="15" name="Text 12"/>
-          <p:cNvSpPr txBox="1"/>
-          <p:nvPr/>
-        </p:nvSpPr>
-        <p:spPr>
-          <a:xfrm>
-            <a:off x="2715768" y="4160520"/>
-            <a:ext cx="1737360" cy="457200"/>
-          </a:xfrm>
-          <a:prstGeom prst="rect">
-            <a:avLst/>
-          </a:prstGeom>
-          <a:noFill/>
-          <a:ln/>
-        </p:spPr>
-        <p:txBody>
-          <a:bodyPr wrap="square" lIns="0" tIns="0" rIns="0" bIns="0" rtlCol="0" anchor="t"/>
+            <a:endParaRPr lang="en-US" sz="2000" dirty="0"/>
+          </a:p>
+        </p:txBody>
+      </p:sp>
+      <p:sp>
+        <p:nvSpPr>
+          <p:cNvPr id="28" name="Text 24"/>
+          <p:cNvSpPr txBox="1"/>
+          <p:nvPr/>
+        </p:nvSpPr>
+        <p:spPr>
+          <a:xfrm>
+            <a:off x="7132320" y="2130552"/>
+            <a:ext cx="1463040" cy="749808"/>
+          </a:xfrm>
+          <a:prstGeom prst="rect">
+            <a:avLst/>
+          </a:prstGeom>
+          <a:noFill/>
+          <a:ln/>
+        </p:spPr>
+        <p:txBody>
+          <a:bodyPr wrap="square" lIns="0" tIns="0" rIns="0" bIns="0" rtlCol="0" anchor="ctr"/>
           <a:lstStyle/>
           <a:p>
             <a:pPr indent="0" marL="0">
@@ -5059,18 +5527,18 @@
       </p:sp>
       <p:sp>
         <p:nvSpPr>
-          <p:cNvPr id="16" name="Shape 13"/>
+          <p:cNvPr id="29" name="Shape 25"/>
           <p:cNvSpPr/>
           <p:nvPr/>
         </p:nvSpPr>
         <p:spPr>
           <a:xfrm>
-            <a:off x="4700016" y="3611880"/>
-            <a:ext cx="1965960" cy="1051560"/>
+            <a:off x="5852160" y="2980944"/>
+            <a:ext cx="2834640" cy="749808"/>
           </a:xfrm>
           <a:prstGeom prst="roundRect">
             <a:avLst>
-              <a:gd name="adj" fmla="val 6957"/>
+              <a:gd name="adj" fmla="val 9756"/>
             </a:avLst>
           </a:prstGeom>
           <a:solidFill>
@@ -5081,30 +5549,30 @@
       </p:sp>
       <p:sp>
         <p:nvSpPr>
-          <p:cNvPr id="17" name="Text 14"/>
-          <p:cNvSpPr txBox="1"/>
-          <p:nvPr/>
-        </p:nvSpPr>
-        <p:spPr>
-          <a:xfrm>
-            <a:off x="4837176" y="3657600"/>
-            <a:ext cx="1737360" cy="502920"/>
-          </a:xfrm>
-          <a:prstGeom prst="rect">
-            <a:avLst/>
-          </a:prstGeom>
-          <a:noFill/>
-          <a:ln/>
-        </p:spPr>
-        <p:txBody>
-          <a:bodyPr wrap="square" lIns="0" tIns="0" rIns="0" bIns="0" rtlCol="0" anchor="ctr"/>
-          <a:lstStyle/>
-          <a:p>
-            <a:pPr indent="0" marL="0">
-              <a:buNone/>
-            </a:pPr>
-            <a:r>
-              <a:rPr lang="en-US" sz="2400" b="1" dirty="0">
+          <p:cNvPr id="30" name="Text 26"/>
+          <p:cNvSpPr txBox="1"/>
+          <p:nvPr/>
+        </p:nvSpPr>
+        <p:spPr>
+          <a:xfrm>
+            <a:off x="5989320" y="2980944"/>
+            <a:ext cx="1143000" cy="749808"/>
+          </a:xfrm>
+          <a:prstGeom prst="rect">
+            <a:avLst/>
+          </a:prstGeom>
+          <a:noFill/>
+          <a:ln/>
+        </p:spPr>
+        <p:txBody>
+          <a:bodyPr wrap="square" lIns="0" tIns="0" rIns="0" bIns="0" rtlCol="0" anchor="ctr"/>
+          <a:lstStyle/>
+          <a:p>
+            <a:pPr indent="0" marL="0">
+              <a:buNone/>
+            </a:pPr>
+            <a:r>
+              <a:rPr lang="en-US" sz="2000" b="1" dirty="0">
                 <a:solidFill>
                   <a:srgbClr val="E5323B"/>
                 </a:solidFill>
@@ -5114,29 +5582,29 @@
               </a:rPr>
               <a:t>583</a:t>
             </a:r>
-            <a:endParaRPr lang="en-US" sz="2400" dirty="0"/>
-          </a:p>
-        </p:txBody>
-      </p:sp>
-      <p:sp>
-        <p:nvSpPr>
-          <p:cNvPr id="18" name="Text 15"/>
-          <p:cNvSpPr txBox="1"/>
-          <p:nvPr/>
-        </p:nvSpPr>
-        <p:spPr>
-          <a:xfrm>
-            <a:off x="4837176" y="4160520"/>
-            <a:ext cx="1737360" cy="457200"/>
-          </a:xfrm>
-          <a:prstGeom prst="rect">
-            <a:avLst/>
-          </a:prstGeom>
-          <a:noFill/>
-          <a:ln/>
-        </p:spPr>
-        <p:txBody>
-          <a:bodyPr wrap="square" lIns="0" tIns="0" rIns="0" bIns="0" rtlCol="0" anchor="t"/>
+            <a:endParaRPr lang="en-US" sz="2000" dirty="0"/>
+          </a:p>
+        </p:txBody>
+      </p:sp>
+      <p:sp>
+        <p:nvSpPr>
+          <p:cNvPr id="31" name="Text 27"/>
+          <p:cNvSpPr txBox="1"/>
+          <p:nvPr/>
+        </p:nvSpPr>
+        <p:spPr>
+          <a:xfrm>
+            <a:off x="7132320" y="2980944"/>
+            <a:ext cx="1463040" cy="749808"/>
+          </a:xfrm>
+          <a:prstGeom prst="rect">
+            <a:avLst/>
+          </a:prstGeom>
+          <a:noFill/>
+          <a:ln/>
+        </p:spPr>
+        <p:txBody>
+          <a:bodyPr wrap="square" lIns="0" tIns="0" rIns="0" bIns="0" rtlCol="0" anchor="ctr"/>
           <a:lstStyle/>
           <a:p>
             <a:pPr indent="0" marL="0">
@@ -5159,18 +5627,18 @@
       </p:sp>
       <p:sp>
         <p:nvSpPr>
-          <p:cNvPr id="19" name="Shape 16"/>
+          <p:cNvPr id="32" name="Shape 28"/>
           <p:cNvSpPr/>
           <p:nvPr/>
         </p:nvSpPr>
         <p:spPr>
           <a:xfrm>
-            <a:off x="6821424" y="3611880"/>
-            <a:ext cx="1965960" cy="1051560"/>
+            <a:off x="5852160" y="3831336"/>
+            <a:ext cx="2834640" cy="749808"/>
           </a:xfrm>
           <a:prstGeom prst="roundRect">
             <a:avLst>
-              <a:gd name="adj" fmla="val 6957"/>
+              <a:gd name="adj" fmla="val 9756"/>
             </a:avLst>
           </a:prstGeom>
           <a:solidFill>
@@ -5181,30 +5649,30 @@
       </p:sp>
       <p:sp>
         <p:nvSpPr>
-          <p:cNvPr id="20" name="Text 17"/>
-          <p:cNvSpPr txBox="1"/>
-          <p:nvPr/>
-        </p:nvSpPr>
-        <p:spPr>
-          <a:xfrm>
-            <a:off x="6958584" y="3657600"/>
-            <a:ext cx="1737360" cy="502920"/>
-          </a:xfrm>
-          <a:prstGeom prst="rect">
-            <a:avLst/>
-          </a:prstGeom>
-          <a:noFill/>
-          <a:ln/>
-        </p:spPr>
-        <p:txBody>
-          <a:bodyPr wrap="square" lIns="0" tIns="0" rIns="0" bIns="0" rtlCol="0" anchor="ctr"/>
-          <a:lstStyle/>
-          <a:p>
-            <a:pPr indent="0" marL="0">
-              <a:buNone/>
-            </a:pPr>
-            <a:r>
-              <a:rPr lang="en-US" sz="2400" b="1" dirty="0">
+          <p:cNvPr id="33" name="Text 29"/>
+          <p:cNvSpPr txBox="1"/>
+          <p:nvPr/>
+        </p:nvSpPr>
+        <p:spPr>
+          <a:xfrm>
+            <a:off x="5989320" y="3831336"/>
+            <a:ext cx="1143000" cy="749808"/>
+          </a:xfrm>
+          <a:prstGeom prst="rect">
+            <a:avLst/>
+          </a:prstGeom>
+          <a:noFill/>
+          <a:ln/>
+        </p:spPr>
+        <p:txBody>
+          <a:bodyPr wrap="square" lIns="0" tIns="0" rIns="0" bIns="0" rtlCol="0" anchor="ctr"/>
+          <a:lstStyle/>
+          <a:p>
+            <a:pPr indent="0" marL="0">
+              <a:buNone/>
+            </a:pPr>
+            <a:r>
+              <a:rPr lang="en-US" sz="2000" b="1" dirty="0">
                 <a:solidFill>
                   <a:srgbClr val="E5323B"/>
                 </a:solidFill>
@@ -5214,29 +5682,29 @@
               </a:rPr>
               <a:t>57,8%</a:t>
             </a:r>
-            <a:endParaRPr lang="en-US" sz="2400" dirty="0"/>
-          </a:p>
-        </p:txBody>
-      </p:sp>
-      <p:sp>
-        <p:nvSpPr>
-          <p:cNvPr id="21" name="Text 18"/>
-          <p:cNvSpPr txBox="1"/>
-          <p:nvPr/>
-        </p:nvSpPr>
-        <p:spPr>
-          <a:xfrm>
-            <a:off x="6958584" y="4160520"/>
-            <a:ext cx="1737360" cy="457200"/>
-          </a:xfrm>
-          <a:prstGeom prst="rect">
-            <a:avLst/>
-          </a:prstGeom>
-          <a:noFill/>
-          <a:ln/>
-        </p:spPr>
-        <p:txBody>
-          <a:bodyPr wrap="square" lIns="0" tIns="0" rIns="0" bIns="0" rtlCol="0" anchor="t"/>
+            <a:endParaRPr lang="en-US" sz="2000" dirty="0"/>
+          </a:p>
+        </p:txBody>
+      </p:sp>
+      <p:sp>
+        <p:nvSpPr>
+          <p:cNvPr id="34" name="Text 30"/>
+          <p:cNvSpPr txBox="1"/>
+          <p:nvPr/>
+        </p:nvSpPr>
+        <p:spPr>
+          <a:xfrm>
+            <a:off x="7132320" y="3831336"/>
+            <a:ext cx="1463040" cy="749808"/>
+          </a:xfrm>
+          <a:prstGeom prst="rect">
+            <a:avLst/>
+          </a:prstGeom>
+          <a:noFill/>
+          <a:ln/>
+        </p:spPr>
+        <p:txBody>
+          <a:bodyPr wrap="square" lIns="0" tIns="0" rIns="0" bIns="0" rtlCol="0" anchor="ctr"/>
           <a:lstStyle/>
           <a:p>
             <a:pPr indent="0" marL="0">
@@ -5259,7 +5727,7 @@
       </p:sp>
       <p:sp>
         <p:nvSpPr>
-          <p:cNvPr id="22" name="Text 19"/>
+          <p:cNvPr id="36" name="Text 31"/>
           <p:cNvSpPr txBox="1"/>
           <p:nvPr/>
         </p:nvSpPr>
@@ -5298,7 +5766,7 @@
       </p:sp>
       <p:sp>
         <p:nvSpPr>
-          <p:cNvPr id="23" name="Text 20"/>
+          <p:cNvPr id="37" name="Text 32"/>
           <p:cNvSpPr txBox="1"/>
           <p:nvPr/>
         </p:nvSpPr>
@@ -6891,7 +7359,7 @@
         </p:nvSpPr>
         <p:spPr>
           <a:xfrm>
-            <a:off x="3749040" y="1554480"/>
+            <a:off x="3749040" y="1371600"/>
             <a:ext cx="4937760" cy="201168"/>
           </a:xfrm>
           <a:prstGeom prst="rect">
@@ -6916,7 +7384,7 @@
                 <a:ea typeface="Calibri" pitchFamily="34" charset="-122"/>
                 <a:cs typeface="Calibri" pitchFamily="34" charset="-120"/>
               </a:rPr>
-              <a:t>UNIDAD KATUETÉ</a:t>
+              <a:t>UNIDAD 1 · KATUETÉ (CASA MATRIZ)</a:t>
             </a:r>
             <a:endParaRPr lang="en-US" sz="900" dirty="0"/>
           </a:p>
@@ -6930,7 +7398,7 @@
         </p:nvSpPr>
         <p:spPr>
           <a:xfrm>
-            <a:off x="3749040" y="1755648"/>
+            <a:off x="3749040" y="1572768"/>
             <a:ext cx="4937760" cy="457200"/>
           </a:xfrm>
           <a:prstGeom prst="rect">
@@ -6986,7 +7454,7 @@
         </p:nvSpPr>
         <p:spPr>
           <a:xfrm>
-            <a:off x="3749040" y="2468880"/>
+            <a:off x="3749040" y="2148840"/>
             <a:ext cx="4937760" cy="201168"/>
           </a:xfrm>
           <a:prstGeom prst="rect">
@@ -7011,6 +7479,101 @@
                 <a:ea typeface="Calibri" pitchFamily="34" charset="-122"/>
                 <a:cs typeface="Calibri" pitchFamily="34" charset="-120"/>
               </a:rPr>
+              <a:t>UNIDAD 2 · CAMPO 9</a:t>
+            </a:r>
+            <a:endParaRPr lang="en-US" sz="900" dirty="0"/>
+          </a:p>
+        </p:txBody>
+      </p:sp>
+      <p:sp>
+        <p:nvSpPr>
+          <p:cNvPr id="9" name="Text 6"/>
+          <p:cNvSpPr txBox="1"/>
+          <p:nvPr/>
+        </p:nvSpPr>
+        <p:spPr>
+          <a:xfrm>
+            <a:off x="3749040" y="2350008"/>
+            <a:ext cx="4937760" cy="457200"/>
+          </a:xfrm>
+          <a:prstGeom prst="rect">
+            <a:avLst/>
+          </a:prstGeom>
+          <a:noFill/>
+          <a:ln/>
+        </p:spPr>
+        <p:txBody>
+          <a:bodyPr wrap="square" lIns="0" tIns="0" rIns="0" bIns="0" rtlCol="0" anchor="t"/>
+          <a:lstStyle/>
+          <a:p>
+            <a:pPr indent="0" marL="0">
+              <a:buNone/>
+            </a:pPr>
+            <a:r>
+              <a:rPr lang="en-US" sz="1200" dirty="0">
+                <a:solidFill>
+                  <a:srgbClr val="FFFFFF"/>
+                </a:solidFill>
+                <a:latin typeface="Calibri" pitchFamily="34" charset="0"/>
+                <a:ea typeface="Calibri" pitchFamily="34" charset="-122"/>
+                <a:cs typeface="Calibri" pitchFamily="34" charset="-120"/>
+              </a:rPr>
+              <a:t>J. Asunción Flores 661, Caaguazú</a:t>
+            </a:r>
+            <a:endParaRPr lang="en-US" sz="1200" dirty="0"/>
+          </a:p>
+          <a:p>
+            <a:pPr indent="0" marL="0">
+              <a:buNone/>
+            </a:pPr>
+            <a:r>
+              <a:rPr lang="en-US" sz="1200" dirty="0">
+                <a:solidFill>
+                  <a:srgbClr val="FFFFFF"/>
+                </a:solidFill>
+                <a:latin typeface="Calibri" pitchFamily="34" charset="0"/>
+                <a:ea typeface="Calibri" pitchFamily="34" charset="-122"/>
+                <a:cs typeface="Calibri" pitchFamily="34" charset="-120"/>
+              </a:rPr>
+              <a:t>Tel. 0983 510 885</a:t>
+            </a:r>
+            <a:endParaRPr lang="en-US" sz="1200" dirty="0"/>
+          </a:p>
+        </p:txBody>
+      </p:sp>
+      <p:sp>
+        <p:nvSpPr>
+          <p:cNvPr id="10" name="Text 7"/>
+          <p:cNvSpPr txBox="1"/>
+          <p:nvPr/>
+        </p:nvSpPr>
+        <p:spPr>
+          <a:xfrm>
+            <a:off x="3749040" y="2926080"/>
+            <a:ext cx="4937760" cy="201168"/>
+          </a:xfrm>
+          <a:prstGeom prst="rect">
+            <a:avLst/>
+          </a:prstGeom>
+          <a:noFill/>
+          <a:ln/>
+        </p:spPr>
+        <p:txBody>
+          <a:bodyPr wrap="square" lIns="0" tIns="0" rIns="0" bIns="0" rtlCol="0" anchor="ctr"/>
+          <a:lstStyle/>
+          <a:p>
+            <a:pPr indent="0" marL="0">
+              <a:buNone/>
+            </a:pPr>
+            <a:r>
+              <a:rPr lang="en-US" sz="900" b="1" spc="200" kern="0" dirty="0">
+                <a:solidFill>
+                  <a:srgbClr val="E5323B"/>
+                </a:solidFill>
+                <a:latin typeface="Calibri" pitchFamily="34" charset="0"/>
+                <a:ea typeface="Calibri" pitchFamily="34" charset="-122"/>
+                <a:cs typeface="Calibri" pitchFamily="34" charset="-120"/>
+              </a:rPr>
               <a:t>CORREO</a:t>
             </a:r>
             <a:endParaRPr lang="en-US" sz="900" dirty="0"/>
@@ -7019,13 +7582,13 @@
       </p:sp>
       <p:sp>
         <p:nvSpPr>
-          <p:cNvPr id="9" name="Text 6"/>
-          <p:cNvSpPr txBox="1"/>
-          <p:nvPr/>
-        </p:nvSpPr>
-        <p:spPr>
-          <a:xfrm>
-            <a:off x="3749040" y="2670048"/>
+          <p:cNvPr id="11" name="Text 8"/>
+          <p:cNvSpPr txBox="1"/>
+          <p:nvPr/>
+        </p:nvSpPr>
+        <p:spPr>
+          <a:xfrm>
+            <a:off x="3749040" y="3127248"/>
             <a:ext cx="4937760" cy="457200"/>
           </a:xfrm>
           <a:prstGeom prst="rect">
@@ -7075,13 +7638,13 @@
       </p:sp>
       <p:sp>
         <p:nvSpPr>
-          <p:cNvPr id="10" name="Text 7"/>
-          <p:cNvSpPr txBox="1"/>
-          <p:nvPr/>
-        </p:nvSpPr>
-        <p:spPr>
-          <a:xfrm>
-            <a:off x="3749040" y="3383280"/>
+          <p:cNvPr id="12" name="Text 9"/>
+          <p:cNvSpPr txBox="1"/>
+          <p:nvPr/>
+        </p:nvSpPr>
+        <p:spPr>
+          <a:xfrm>
+            <a:off x="3749040" y="3703320"/>
             <a:ext cx="4937760" cy="201168"/>
           </a:xfrm>
           <a:prstGeom prst="rect">
@@ -7114,13 +7677,13 @@
       </p:sp>
       <p:sp>
         <p:nvSpPr>
-          <p:cNvPr id="11" name="Text 8"/>
-          <p:cNvSpPr txBox="1"/>
-          <p:nvPr/>
-        </p:nvSpPr>
-        <p:spPr>
-          <a:xfrm>
-            <a:off x="3749040" y="3584448"/>
+          <p:cNvPr id="13" name="Text 10"/>
+          <p:cNvSpPr txBox="1"/>
+          <p:nvPr/>
+        </p:nvSpPr>
+        <p:spPr>
+          <a:xfrm>
+            <a:off x="3749040" y="3904488"/>
             <a:ext cx="4937760" cy="457200"/>
           </a:xfrm>
           <a:prstGeom prst="rect">
@@ -7153,7 +7716,7 @@
       </p:sp>
       <p:sp>
         <p:nvSpPr>
-          <p:cNvPr id="12" name="Text 9"/>
+          <p:cNvPr id="14" name="Text 11"/>
           <p:cNvSpPr txBox="1"/>
           <p:nvPr/>
         </p:nvSpPr>

</xml_diff>